<commit_message>
Add voice-guided picking adapter to the device capability adapter layer
</commit_message>
<xml_diff>
--- a/wcs-architecture/WCS架构产品方案.pptx
+++ b/wcs-architecture/WCS架构产品方案.pptx
@@ -5704,7 +5704,7 @@
         <p:spPr>
           <a:xfrm>
             <a:off x="420623" y="4591770"/>
-            <a:ext cx="1792724" cy="409997"/>
+            <a:ext cx="1488602" cy="409997"/>
           </a:xfrm>
           <a:prstGeom prst="roundRect">
             <a:avLst>
@@ -5772,8 +5772,8 @@
         </p:nvSpPr>
         <p:spPr>
           <a:xfrm>
-            <a:off x="2245352" y="4591770"/>
-            <a:ext cx="1792724" cy="409997"/>
+            <a:off x="1941230" y="4591770"/>
+            <a:ext cx="1488602" cy="409997"/>
           </a:xfrm>
           <a:prstGeom prst="roundRect">
             <a:avLst>
@@ -5841,8 +5841,8 @@
         </p:nvSpPr>
         <p:spPr>
           <a:xfrm>
-            <a:off x="4070080" y="4591770"/>
-            <a:ext cx="1792724" cy="409997"/>
+            <a:off x="3461837" y="4591770"/>
+            <a:ext cx="1488602" cy="409997"/>
           </a:xfrm>
           <a:prstGeom prst="roundRect">
             <a:avLst>
@@ -5910,8 +5910,8 @@
         </p:nvSpPr>
         <p:spPr>
           <a:xfrm>
-            <a:off x="5894808" y="4591770"/>
-            <a:ext cx="1792724" cy="409997"/>
+            <a:off x="4982444" y="4591770"/>
+            <a:ext cx="1488602" cy="409997"/>
           </a:xfrm>
           <a:prstGeom prst="roundRect">
             <a:avLst>
@@ -5979,8 +5979,8 @@
         </p:nvSpPr>
         <p:spPr>
           <a:xfrm>
-            <a:off x="7719536" y="4591770"/>
-            <a:ext cx="1792724" cy="409997"/>
+            <a:off x="6503051" y="4591770"/>
+            <a:ext cx="1488602" cy="409997"/>
           </a:xfrm>
           <a:prstGeom prst="roundRect">
             <a:avLst>
@@ -6023,6 +6023,75 @@
                 </a:solidFill>
                 <a:latin typeface="Microsoft YaHei"/>
               </a:rPr>
+              <a:t>语音适配拣选</a:t>
+            </a:r>
+          </a:p>
+          <a:p>
+            <a:pPr algn="ctr"/>
+            <a:r>
+              <a:rPr sz="800">
+                <a:solidFill>
+                  <a:srgbClr val="7A7A7A"/>
+                </a:solidFill>
+                <a:latin typeface="Microsoft YaHei"/>
+              </a:rPr>
+              <a:t>语音引导·免视觉</a:t>
+            </a:r>
+          </a:p>
+        </p:txBody>
+      </p:sp>
+      <p:sp>
+        <p:nvSpPr>
+          <p:cNvPr id="59" name="Rounded Rectangle 58"/>
+          <p:cNvSpPr/>
+          <p:nvPr/>
+        </p:nvSpPr>
+        <p:spPr>
+          <a:xfrm>
+            <a:off x="8023658" y="4591770"/>
+            <a:ext cx="1488602" cy="409997"/>
+          </a:xfrm>
+          <a:prstGeom prst="roundRect">
+            <a:avLst>
+              <a:gd name="adj" fmla="val 6000"/>
+            </a:avLst>
+          </a:prstGeom>
+          <a:solidFill>
+            <a:srgbClr val="FBFCFE"/>
+          </a:solidFill>
+          <a:ln w="9525">
+            <a:solidFill>
+              <a:srgbClr val="C9C9C9"/>
+            </a:solidFill>
+          </a:ln>
+          <a:effectLst/>
+        </p:spPr>
+        <p:style>
+          <a:lnRef idx="1">
+            <a:schemeClr val="accent1"/>
+          </a:lnRef>
+          <a:fillRef idx="3">
+            <a:schemeClr val="accent1"/>
+          </a:fillRef>
+          <a:effectRef idx="2">
+            <a:schemeClr val="accent1"/>
+          </a:effectRef>
+          <a:fontRef idx="minor">
+            <a:schemeClr val="lt1"/>
+          </a:fontRef>
+        </p:style>
+        <p:txBody>
+          <a:bodyPr rtlCol="0" anchor="ctr" wrap="square" tIns="12700" bIns="12700" lIns="25400" rIns="25400"/>
+          <a:lstStyle/>
+          <a:p>
+            <a:pPr algn="ctr"/>
+            <a:r>
+              <a:rPr sz="950" b="1">
+                <a:solidFill>
+                  <a:srgbClr val="262626"/>
+                </a:solidFill>
+                <a:latin typeface="Microsoft YaHei"/>
+              </a:rPr>
               <a:t>通用设备适配</a:t>
             </a:r>
           </a:p>
@@ -6042,7 +6111,7 @@
       </p:sp>
       <p:sp>
         <p:nvSpPr>
-          <p:cNvPr id="59" name="TextBox 58"/>
+          <p:cNvPr id="60" name="TextBox 59"/>
           <p:cNvSpPr txBox="1"/>
           <p:nvPr/>
         </p:nvSpPr>
@@ -6077,7 +6146,7 @@
       </p:sp>
       <p:sp>
         <p:nvSpPr>
-          <p:cNvPr id="60" name="Rounded Rectangle 59"/>
+          <p:cNvPr id="61" name="Rounded Rectangle 60"/>
           <p:cNvSpPr/>
           <p:nvPr/>
         </p:nvSpPr>
@@ -6126,7 +6195,7 @@
       </p:sp>
       <p:sp>
         <p:nvSpPr>
-          <p:cNvPr id="61" name="TextBox 60"/>
+          <p:cNvPr id="62" name="TextBox 61"/>
           <p:cNvSpPr txBox="1"/>
           <p:nvPr/>
         </p:nvSpPr>
@@ -6161,7 +6230,7 @@
       </p:sp>
       <p:sp>
         <p:nvSpPr>
-          <p:cNvPr id="62" name="TextBox 61"/>
+          <p:cNvPr id="63" name="TextBox 62"/>
           <p:cNvSpPr txBox="1"/>
           <p:nvPr/>
         </p:nvSpPr>
@@ -6196,7 +6265,7 @@
       </p:sp>
       <p:sp>
         <p:nvSpPr>
-          <p:cNvPr id="63" name="TextBox 62"/>
+          <p:cNvPr id="64" name="TextBox 63"/>
           <p:cNvSpPr txBox="1"/>
           <p:nvPr/>
         </p:nvSpPr>
@@ -6231,7 +6300,7 @@
       </p:sp>
       <p:sp>
         <p:nvSpPr>
-          <p:cNvPr id="64" name="Rectangle 63"/>
+          <p:cNvPr id="65" name="Rectangle 64"/>
           <p:cNvSpPr/>
           <p:nvPr/>
         </p:nvSpPr>
@@ -6275,7 +6344,7 @@
       </p:sp>
       <p:sp>
         <p:nvSpPr>
-          <p:cNvPr id="65" name="TextBox 64"/>
+          <p:cNvPr id="66" name="TextBox 65"/>
           <p:cNvSpPr txBox="1"/>
           <p:nvPr/>
         </p:nvSpPr>
@@ -6310,7 +6379,7 @@
       </p:sp>
       <p:sp>
         <p:nvSpPr>
-          <p:cNvPr id="66" name="TextBox 65"/>
+          <p:cNvPr id="67" name="TextBox 66"/>
           <p:cNvSpPr txBox="1"/>
           <p:nvPr/>
         </p:nvSpPr>
@@ -6345,7 +6414,7 @@
       </p:sp>
       <p:sp>
         <p:nvSpPr>
-          <p:cNvPr id="67" name="Rectangle 66"/>
+          <p:cNvPr id="68" name="Rectangle 67"/>
           <p:cNvSpPr/>
           <p:nvPr/>
         </p:nvSpPr>
@@ -6389,7 +6458,7 @@
       </p:sp>
       <p:sp>
         <p:nvSpPr>
-          <p:cNvPr id="68" name="TextBox 67"/>
+          <p:cNvPr id="69" name="TextBox 68"/>
           <p:cNvSpPr txBox="1"/>
           <p:nvPr/>
         </p:nvSpPr>
@@ -6424,7 +6493,7 @@
       </p:sp>
       <p:sp>
         <p:nvSpPr>
-          <p:cNvPr id="69" name="TextBox 68"/>
+          <p:cNvPr id="70" name="TextBox 69"/>
           <p:cNvSpPr txBox="1"/>
           <p:nvPr/>
         </p:nvSpPr>
@@ -6459,7 +6528,7 @@
       </p:sp>
       <p:sp>
         <p:nvSpPr>
-          <p:cNvPr id="70" name="Rectangle 69"/>
+          <p:cNvPr id="71" name="Rectangle 70"/>
           <p:cNvSpPr/>
           <p:nvPr/>
         </p:nvSpPr>
@@ -6503,7 +6572,7 @@
       </p:sp>
       <p:sp>
         <p:nvSpPr>
-          <p:cNvPr id="71" name="TextBox 70"/>
+          <p:cNvPr id="72" name="TextBox 71"/>
           <p:cNvSpPr txBox="1"/>
           <p:nvPr/>
         </p:nvSpPr>
@@ -6538,7 +6607,7 @@
       </p:sp>
       <p:sp>
         <p:nvSpPr>
-          <p:cNvPr id="72" name="TextBox 71"/>
+          <p:cNvPr id="73" name="TextBox 72"/>
           <p:cNvSpPr txBox="1"/>
           <p:nvPr/>
         </p:nvSpPr>
@@ -6573,7 +6642,7 @@
       </p:sp>
       <p:sp>
         <p:nvSpPr>
-          <p:cNvPr id="73" name="Rectangle 72"/>
+          <p:cNvPr id="74" name="Rectangle 73"/>
           <p:cNvSpPr/>
           <p:nvPr/>
         </p:nvSpPr>
@@ -6617,7 +6686,7 @@
       </p:sp>
       <p:sp>
         <p:nvSpPr>
-          <p:cNvPr id="74" name="TextBox 73"/>
+          <p:cNvPr id="75" name="TextBox 74"/>
           <p:cNvSpPr txBox="1"/>
           <p:nvPr/>
         </p:nvSpPr>
@@ -6652,7 +6721,7 @@
       </p:sp>
       <p:sp>
         <p:nvSpPr>
-          <p:cNvPr id="75" name="TextBox 74"/>
+          <p:cNvPr id="76" name="TextBox 75"/>
           <p:cNvSpPr txBox="1"/>
           <p:nvPr/>
         </p:nvSpPr>
@@ -6685,43 +6754,6 @@
           </a:p>
         </p:txBody>
       </p:sp>
-      <p:cxnSp>
-        <p:nvCxnSpPr>
-          <p:cNvPr id="76" name="Connector 75"/>
-          <p:cNvCxnSpPr/>
-          <p:nvPr/>
-        </p:nvCxnSpPr>
-        <p:spPr>
-          <a:xfrm>
-            <a:off x="1380103" y="5148072"/>
-            <a:ext cx="0" cy="256032"/>
-          </a:xfrm>
-          <a:prstGeom prst="line">
-            <a:avLst/>
-          </a:prstGeom>
-          <a:ln w="12700">
-            <a:solidFill>
-              <a:srgbClr val="8C9BB3"/>
-            </a:solidFill>
-            <a:headEnd type="triangle" w="sm" len="sm"/>
-            <a:tailEnd type="triangle" w="sm" len="sm"/>
-          </a:ln>
-        </p:spPr>
-        <p:style>
-          <a:lnRef idx="2">
-            <a:schemeClr val="accent1"/>
-          </a:lnRef>
-          <a:fillRef idx="0">
-            <a:schemeClr val="accent1"/>
-          </a:fillRef>
-          <a:effectRef idx="1">
-            <a:schemeClr val="accent1"/>
-          </a:effectRef>
-          <a:fontRef idx="minor">
-            <a:schemeClr val="tx1"/>
-          </a:fontRef>
-        </p:style>
-      </p:cxnSp>
       <p:cxnSp>
         <p:nvCxnSpPr>
           <p:cNvPr id="77" name="Connector 76"/>
@@ -6730,7 +6762,7 @@
         </p:nvCxnSpPr>
         <p:spPr>
           <a:xfrm>
-            <a:off x="3737975" y="5148072"/>
+            <a:off x="1380103" y="5148072"/>
             <a:ext cx="0" cy="256032"/>
           </a:xfrm>
           <a:prstGeom prst="line">
@@ -6767,7 +6799,7 @@
         </p:nvCxnSpPr>
         <p:spPr>
           <a:xfrm>
-            <a:off x="6095847" y="5148072"/>
+            <a:off x="3737975" y="5148072"/>
             <a:ext cx="0" cy="256032"/>
           </a:xfrm>
           <a:prstGeom prst="line">
@@ -6804,7 +6836,7 @@
         </p:nvCxnSpPr>
         <p:spPr>
           <a:xfrm>
-            <a:off x="8453719" y="5148072"/>
+            <a:off x="6095847" y="5148072"/>
             <a:ext cx="0" cy="256032"/>
           </a:xfrm>
           <a:prstGeom prst="line">
@@ -6841,7 +6873,7 @@
         </p:nvCxnSpPr>
         <p:spPr>
           <a:xfrm>
-            <a:off x="10811591" y="5148072"/>
+            <a:off x="8453719" y="5148072"/>
             <a:ext cx="0" cy="256032"/>
           </a:xfrm>
           <a:prstGeom prst="line">
@@ -6870,9 +6902,46 @@
           </a:fontRef>
         </p:style>
       </p:cxnSp>
-      <p:sp>
-        <p:nvSpPr>
-          <p:cNvPr id="81" name="TextBox 80"/>
+      <p:cxnSp>
+        <p:nvCxnSpPr>
+          <p:cNvPr id="81" name="Connector 80"/>
+          <p:cNvCxnSpPr/>
+          <p:nvPr/>
+        </p:nvCxnSpPr>
+        <p:spPr>
+          <a:xfrm>
+            <a:off x="10811591" y="5148072"/>
+            <a:ext cx="0" cy="256032"/>
+          </a:xfrm>
+          <a:prstGeom prst="line">
+            <a:avLst/>
+          </a:prstGeom>
+          <a:ln w="12700">
+            <a:solidFill>
+              <a:srgbClr val="8C9BB3"/>
+            </a:solidFill>
+            <a:headEnd type="triangle" w="sm" len="sm"/>
+            <a:tailEnd type="triangle" w="sm" len="sm"/>
+          </a:ln>
+        </p:spPr>
+        <p:style>
+          <a:lnRef idx="2">
+            <a:schemeClr val="accent1"/>
+          </a:lnRef>
+          <a:fillRef idx="0">
+            <a:schemeClr val="accent1"/>
+          </a:fillRef>
+          <a:effectRef idx="1">
+            <a:schemeClr val="accent1"/>
+          </a:effectRef>
+          <a:fontRef idx="minor">
+            <a:schemeClr val="tx1"/>
+          </a:fontRef>
+        </p:style>
+      </p:cxnSp>
+      <p:sp>
+        <p:nvSpPr>
+          <p:cNvPr id="82" name="TextBox 81"/>
           <p:cNvSpPr txBox="1"/>
           <p:nvPr/>
         </p:nvSpPr>
@@ -6907,7 +6976,7 @@
       </p:sp>
       <p:sp>
         <p:nvSpPr>
-          <p:cNvPr id="82" name="TextBox 81"/>
+          <p:cNvPr id="83" name="TextBox 82"/>
           <p:cNvSpPr txBox="1"/>
           <p:nvPr/>
         </p:nvSpPr>
@@ -6942,7 +7011,7 @@
       </p:sp>
       <p:sp>
         <p:nvSpPr>
-          <p:cNvPr id="83" name="Rounded Rectangle 82"/>
+          <p:cNvPr id="84" name="Rounded Rectangle 83"/>
           <p:cNvSpPr/>
           <p:nvPr/>
         </p:nvSpPr>
@@ -6990,7 +7059,7 @@
       </p:sp>
       <p:sp>
         <p:nvSpPr>
-          <p:cNvPr id="84" name="TextBox 83"/>
+          <p:cNvPr id="85" name="TextBox 84"/>
           <p:cNvSpPr txBox="1"/>
           <p:nvPr/>
         </p:nvSpPr>
@@ -7025,7 +7094,7 @@
       </p:sp>
       <p:sp>
         <p:nvSpPr>
-          <p:cNvPr id="85" name="Rectangle 84"/>
+          <p:cNvPr id="86" name="Rectangle 85"/>
           <p:cNvSpPr/>
           <p:nvPr/>
         </p:nvSpPr>
@@ -7069,7 +7138,7 @@
       </p:sp>
       <p:sp>
         <p:nvSpPr>
-          <p:cNvPr id="86" name="TextBox 85"/>
+          <p:cNvPr id="87" name="TextBox 86"/>
           <p:cNvSpPr txBox="1"/>
           <p:nvPr/>
         </p:nvSpPr>
@@ -7104,7 +7173,7 @@
       </p:sp>
       <p:sp>
         <p:nvSpPr>
-          <p:cNvPr id="87" name="Rounded Rectangle 86"/>
+          <p:cNvPr id="88" name="Rounded Rectangle 87"/>
           <p:cNvSpPr/>
           <p:nvPr/>
         </p:nvSpPr>
@@ -7152,7 +7221,7 @@
       </p:sp>
       <p:sp>
         <p:nvSpPr>
-          <p:cNvPr id="88" name="TextBox 87"/>
+          <p:cNvPr id="89" name="TextBox 88"/>
           <p:cNvSpPr txBox="1"/>
           <p:nvPr/>
         </p:nvSpPr>
@@ -7187,7 +7256,7 @@
       </p:sp>
       <p:sp>
         <p:nvSpPr>
-          <p:cNvPr id="89" name="Rectangle 88"/>
+          <p:cNvPr id="90" name="Rectangle 89"/>
           <p:cNvSpPr/>
           <p:nvPr/>
         </p:nvSpPr>
@@ -7231,7 +7300,7 @@
       </p:sp>
       <p:sp>
         <p:nvSpPr>
-          <p:cNvPr id="90" name="TextBox 89"/>
+          <p:cNvPr id="91" name="TextBox 90"/>
           <p:cNvSpPr txBox="1"/>
           <p:nvPr/>
         </p:nvSpPr>
@@ -7266,7 +7335,7 @@
       </p:sp>
       <p:sp>
         <p:nvSpPr>
-          <p:cNvPr id="91" name="Rounded Rectangle 90"/>
+          <p:cNvPr id="92" name="Rounded Rectangle 91"/>
           <p:cNvSpPr/>
           <p:nvPr/>
         </p:nvSpPr>
@@ -7314,7 +7383,7 @@
       </p:sp>
       <p:sp>
         <p:nvSpPr>
-          <p:cNvPr id="92" name="TextBox 91"/>
+          <p:cNvPr id="93" name="TextBox 92"/>
           <p:cNvSpPr txBox="1"/>
           <p:nvPr/>
         </p:nvSpPr>
@@ -7349,7 +7418,7 @@
       </p:sp>
       <p:sp>
         <p:nvSpPr>
-          <p:cNvPr id="93" name="Rectangle 92"/>
+          <p:cNvPr id="94" name="Rectangle 93"/>
           <p:cNvSpPr/>
           <p:nvPr/>
         </p:nvSpPr>
@@ -7393,7 +7462,7 @@
       </p:sp>
       <p:sp>
         <p:nvSpPr>
-          <p:cNvPr id="94" name="TextBox 93"/>
+          <p:cNvPr id="95" name="TextBox 94"/>
           <p:cNvSpPr txBox="1"/>
           <p:nvPr/>
         </p:nvSpPr>
@@ -7428,7 +7497,7 @@
       </p:sp>
       <p:sp>
         <p:nvSpPr>
-          <p:cNvPr id="95" name="Rounded Rectangle 94"/>
+          <p:cNvPr id="96" name="Rounded Rectangle 95"/>
           <p:cNvSpPr/>
           <p:nvPr/>
         </p:nvSpPr>
@@ -7476,7 +7545,7 @@
       </p:sp>
       <p:sp>
         <p:nvSpPr>
-          <p:cNvPr id="96" name="TextBox 95"/>
+          <p:cNvPr id="97" name="TextBox 96"/>
           <p:cNvSpPr txBox="1"/>
           <p:nvPr/>
         </p:nvSpPr>
@@ -7511,7 +7580,7 @@
       </p:sp>
       <p:sp>
         <p:nvSpPr>
-          <p:cNvPr id="97" name="Rectangle 96"/>
+          <p:cNvPr id="98" name="Rectangle 97"/>
           <p:cNvSpPr/>
           <p:nvPr/>
         </p:nvSpPr>
@@ -7555,7 +7624,7 @@
       </p:sp>
       <p:sp>
         <p:nvSpPr>
-          <p:cNvPr id="98" name="TextBox 97"/>
+          <p:cNvPr id="99" name="TextBox 98"/>
           <p:cNvSpPr txBox="1"/>
           <p:nvPr/>
         </p:nvSpPr>
@@ -7590,7 +7659,7 @@
       </p:sp>
       <p:sp>
         <p:nvSpPr>
-          <p:cNvPr id="99" name="Rounded Rectangle 98"/>
+          <p:cNvPr id="100" name="Rounded Rectangle 99"/>
           <p:cNvSpPr/>
           <p:nvPr/>
         </p:nvSpPr>
@@ -7638,7 +7707,7 @@
       </p:sp>
       <p:sp>
         <p:nvSpPr>
-          <p:cNvPr id="100" name="TextBox 99"/>
+          <p:cNvPr id="101" name="TextBox 100"/>
           <p:cNvSpPr txBox="1"/>
           <p:nvPr/>
         </p:nvSpPr>
@@ -7673,7 +7742,7 @@
       </p:sp>
       <p:sp>
         <p:nvSpPr>
-          <p:cNvPr id="101" name="Rectangle 100"/>
+          <p:cNvPr id="102" name="Rectangle 101"/>
           <p:cNvSpPr/>
           <p:nvPr/>
         </p:nvSpPr>
@@ -7717,7 +7786,7 @@
       </p:sp>
       <p:sp>
         <p:nvSpPr>
-          <p:cNvPr id="102" name="TextBox 101"/>
+          <p:cNvPr id="103" name="TextBox 102"/>
           <p:cNvSpPr txBox="1"/>
           <p:nvPr/>
         </p:nvSpPr>
@@ -7752,7 +7821,7 @@
       </p:sp>
       <p:sp>
         <p:nvSpPr>
-          <p:cNvPr id="103" name="Rounded Rectangle 102"/>
+          <p:cNvPr id="104" name="Rounded Rectangle 103"/>
           <p:cNvSpPr/>
           <p:nvPr/>
         </p:nvSpPr>
@@ -7800,7 +7869,7 @@
       </p:sp>
       <p:sp>
         <p:nvSpPr>
-          <p:cNvPr id="104" name="TextBox 103"/>
+          <p:cNvPr id="105" name="TextBox 104"/>
           <p:cNvSpPr txBox="1"/>
           <p:nvPr/>
         </p:nvSpPr>
@@ -7835,7 +7904,7 @@
       </p:sp>
       <p:sp>
         <p:nvSpPr>
-          <p:cNvPr id="105" name="Rounded Rectangle 104"/>
+          <p:cNvPr id="106" name="Rounded Rectangle 105"/>
           <p:cNvSpPr/>
           <p:nvPr/>
         </p:nvSpPr>
@@ -7883,7 +7952,7 @@
       </p:sp>
       <p:sp>
         <p:nvSpPr>
-          <p:cNvPr id="106" name="TextBox 105"/>
+          <p:cNvPr id="107" name="TextBox 106"/>
           <p:cNvSpPr txBox="1"/>
           <p:nvPr/>
         </p:nvSpPr>
@@ -7918,7 +7987,7 @@
       </p:sp>
       <p:sp>
         <p:nvSpPr>
-          <p:cNvPr id="107" name="Rounded Rectangle 106"/>
+          <p:cNvPr id="108" name="Rounded Rectangle 107"/>
           <p:cNvSpPr/>
           <p:nvPr/>
         </p:nvSpPr>
@@ -7966,7 +8035,7 @@
       </p:sp>
       <p:sp>
         <p:nvSpPr>
-          <p:cNvPr id="108" name="TextBox 107"/>
+          <p:cNvPr id="109" name="TextBox 108"/>
           <p:cNvSpPr txBox="1"/>
           <p:nvPr/>
         </p:nvSpPr>
@@ -8001,7 +8070,7 @@
       </p:sp>
       <p:sp>
         <p:nvSpPr>
-          <p:cNvPr id="109" name="Rounded Rectangle 108"/>
+          <p:cNvPr id="110" name="Rounded Rectangle 109"/>
           <p:cNvSpPr/>
           <p:nvPr/>
         </p:nvSpPr>
@@ -8049,7 +8118,7 @@
       </p:sp>
       <p:sp>
         <p:nvSpPr>
-          <p:cNvPr id="110" name="TextBox 109"/>
+          <p:cNvPr id="111" name="TextBox 110"/>
           <p:cNvSpPr txBox="1"/>
           <p:nvPr/>
         </p:nvSpPr>
@@ -8084,7 +8153,7 @@
       </p:sp>
       <p:sp>
         <p:nvSpPr>
-          <p:cNvPr id="111" name="Rounded Rectangle 110"/>
+          <p:cNvPr id="112" name="Rounded Rectangle 111"/>
           <p:cNvSpPr/>
           <p:nvPr/>
         </p:nvSpPr>
@@ -8132,7 +8201,7 @@
       </p:sp>
       <p:sp>
         <p:nvSpPr>
-          <p:cNvPr id="112" name="TextBox 111"/>
+          <p:cNvPr id="113" name="TextBox 112"/>
           <p:cNvSpPr txBox="1"/>
           <p:nvPr/>
         </p:nvSpPr>
@@ -8167,7 +8236,7 @@
       </p:sp>
       <p:sp>
         <p:nvSpPr>
-          <p:cNvPr id="113" name="Rounded Rectangle 112"/>
+          <p:cNvPr id="114" name="Rounded Rectangle 113"/>
           <p:cNvSpPr/>
           <p:nvPr/>
         </p:nvSpPr>
@@ -8215,7 +8284,7 @@
       </p:sp>
       <p:sp>
         <p:nvSpPr>
-          <p:cNvPr id="114" name="TextBox 113"/>
+          <p:cNvPr id="115" name="TextBox 114"/>
           <p:cNvSpPr txBox="1"/>
           <p:nvPr/>
         </p:nvSpPr>
@@ -8250,7 +8319,7 @@
       </p:sp>
       <p:sp>
         <p:nvSpPr>
-          <p:cNvPr id="115" name="Rounded Rectangle 114"/>
+          <p:cNvPr id="116" name="Rounded Rectangle 115"/>
           <p:cNvSpPr/>
           <p:nvPr/>
         </p:nvSpPr>
@@ -8298,7 +8367,7 @@
       </p:sp>
       <p:sp>
         <p:nvSpPr>
-          <p:cNvPr id="116" name="TextBox 115"/>
+          <p:cNvPr id="117" name="TextBox 116"/>
           <p:cNvSpPr txBox="1"/>
           <p:nvPr/>
         </p:nvSpPr>
@@ -8333,7 +8402,7 @@
       </p:sp>
       <p:sp>
         <p:nvSpPr>
-          <p:cNvPr id="117" name="Rounded Rectangle 116"/>
+          <p:cNvPr id="118" name="Rounded Rectangle 117"/>
           <p:cNvSpPr/>
           <p:nvPr/>
         </p:nvSpPr>
@@ -8381,7 +8450,7 @@
       </p:sp>
       <p:sp>
         <p:nvSpPr>
-          <p:cNvPr id="118" name="TextBox 117"/>
+          <p:cNvPr id="119" name="TextBox 118"/>
           <p:cNvSpPr txBox="1"/>
           <p:nvPr/>
         </p:nvSpPr>
@@ -8416,7 +8485,7 @@
       </p:sp>
       <p:sp>
         <p:nvSpPr>
-          <p:cNvPr id="119" name="Rounded Rectangle 118"/>
+          <p:cNvPr id="120" name="Rounded Rectangle 119"/>
           <p:cNvSpPr/>
           <p:nvPr/>
         </p:nvSpPr>
@@ -8464,7 +8533,7 @@
       </p:sp>
       <p:sp>
         <p:nvSpPr>
-          <p:cNvPr id="120" name="TextBox 119"/>
+          <p:cNvPr id="121" name="TextBox 120"/>
           <p:cNvSpPr txBox="1"/>
           <p:nvPr/>
         </p:nvSpPr>
@@ -8499,7 +8568,7 @@
       </p:sp>
       <p:sp>
         <p:nvSpPr>
-          <p:cNvPr id="121" name="Rounded Rectangle 120"/>
+          <p:cNvPr id="122" name="Rounded Rectangle 121"/>
           <p:cNvSpPr/>
           <p:nvPr/>
         </p:nvSpPr>
@@ -8547,7 +8616,7 @@
       </p:sp>
       <p:sp>
         <p:nvSpPr>
-          <p:cNvPr id="122" name="TextBox 121"/>
+          <p:cNvPr id="123" name="TextBox 122"/>
           <p:cNvSpPr txBox="1"/>
           <p:nvPr/>
         </p:nvSpPr>
@@ -8582,7 +8651,7 @@
       </p:sp>
       <p:sp>
         <p:nvSpPr>
-          <p:cNvPr id="123" name="Rounded Rectangle 122"/>
+          <p:cNvPr id="124" name="Rounded Rectangle 123"/>
           <p:cNvSpPr/>
           <p:nvPr/>
         </p:nvSpPr>
@@ -8630,7 +8699,7 @@
       </p:sp>
       <p:sp>
         <p:nvSpPr>
-          <p:cNvPr id="124" name="TextBox 123"/>
+          <p:cNvPr id="125" name="TextBox 124"/>
           <p:cNvSpPr txBox="1"/>
           <p:nvPr/>
         </p:nvSpPr>
@@ -8665,7 +8734,7 @@
       </p:sp>
       <p:sp>
         <p:nvSpPr>
-          <p:cNvPr id="125" name="TextBox 124"/>
+          <p:cNvPr id="126" name="TextBox 125"/>
           <p:cNvSpPr txBox="1"/>
           <p:nvPr/>
         </p:nvSpPr>

</xml_diff>

<commit_message>
Add WCS5 voice-picking vendor system before WCS N
Vendor row now has its own 6-column grid (independent from the 5-column
WMS row) so the new WCS5 card and its dedicated bidirectional WCS arrow
fit without disturbing the upstream WMS layout.
</commit_message>
<xml_diff>
--- a/wcs-architecture/WCS架构产品方案.pptx
+++ b/wcs-architecture/WCS架构产品方案.pptx
@@ -6762,7 +6762,7 @@
         </p:nvCxnSpPr>
         <p:spPr>
           <a:xfrm>
-            <a:off x="1380103" y="5148072"/>
+            <a:off x="1183614" y="5148072"/>
             <a:ext cx="0" cy="256032"/>
           </a:xfrm>
           <a:prstGeom prst="line">
@@ -6799,7 +6799,7 @@
         </p:nvCxnSpPr>
         <p:spPr>
           <a:xfrm>
-            <a:off x="3737975" y="5148072"/>
+            <a:off x="3148507" y="5148072"/>
             <a:ext cx="0" cy="256032"/>
           </a:xfrm>
           <a:prstGeom prst="line">
@@ -6836,7 +6836,7 @@
         </p:nvCxnSpPr>
         <p:spPr>
           <a:xfrm>
-            <a:off x="6095847" y="5148072"/>
+            <a:off x="5113401" y="5148072"/>
             <a:ext cx="0" cy="256032"/>
           </a:xfrm>
           <a:prstGeom prst="line">
@@ -6873,7 +6873,7 @@
         </p:nvCxnSpPr>
         <p:spPr>
           <a:xfrm>
-            <a:off x="8453719" y="5148072"/>
+            <a:off x="7078294" y="5148072"/>
             <a:ext cx="0" cy="256032"/>
           </a:xfrm>
           <a:prstGeom prst="line">
@@ -6910,7 +6910,7 @@
         </p:nvCxnSpPr>
         <p:spPr>
           <a:xfrm>
-            <a:off x="10811591" y="5148072"/>
+            <a:off x="9043187" y="5148072"/>
             <a:ext cx="0" cy="256032"/>
           </a:xfrm>
           <a:prstGeom prst="line">
@@ -6939,16 +6939,53 @@
           </a:fontRef>
         </p:style>
       </p:cxnSp>
-      <p:sp>
-        <p:nvSpPr>
-          <p:cNvPr id="82" name="TextBox 81"/>
+      <p:cxnSp>
+        <p:nvCxnSpPr>
+          <p:cNvPr id="82" name="Connector 81"/>
+          <p:cNvCxnSpPr/>
+          <p:nvPr/>
+        </p:nvCxnSpPr>
+        <p:spPr>
+          <a:xfrm>
+            <a:off x="11008080" y="5148072"/>
+            <a:ext cx="0" cy="256032"/>
+          </a:xfrm>
+          <a:prstGeom prst="line">
+            <a:avLst/>
+          </a:prstGeom>
+          <a:ln w="12700">
+            <a:solidFill>
+              <a:srgbClr val="8C9BB3"/>
+            </a:solidFill>
+            <a:headEnd type="triangle" w="sm" len="sm"/>
+            <a:tailEnd type="triangle" w="sm" len="sm"/>
+          </a:ln>
+        </p:spPr>
+        <p:style>
+          <a:lnRef idx="2">
+            <a:schemeClr val="accent1"/>
+          </a:lnRef>
+          <a:fillRef idx="0">
+            <a:schemeClr val="accent1"/>
+          </a:fillRef>
+          <a:effectRef idx="1">
+            <a:schemeClr val="accent1"/>
+          </a:effectRef>
+          <a:fontRef idx="minor">
+            <a:schemeClr val="tx1"/>
+          </a:fontRef>
+        </p:style>
+      </p:cxnSp>
+      <p:sp>
+        <p:nvSpPr>
+          <p:cNvPr id="83" name="TextBox 82"/>
           <p:cNvSpPr txBox="1"/>
           <p:nvPr/>
         </p:nvSpPr>
         <p:spPr>
           <a:xfrm>
-            <a:off x="2853348" y="5138928"/>
-            <a:ext cx="6192389" cy="237744"/>
+            <a:off x="2421072" y="5138928"/>
+            <a:ext cx="5819485" cy="237744"/>
           </a:xfrm>
           <a:prstGeom prst="rect">
             <a:avLst/>
@@ -6976,7 +7013,7 @@
       </p:sp>
       <p:sp>
         <p:nvSpPr>
-          <p:cNvPr id="83" name="TextBox 82"/>
+          <p:cNvPr id="84" name="TextBox 83"/>
           <p:cNvSpPr txBox="1"/>
           <p:nvPr/>
         </p:nvSpPr>
@@ -7011,14 +7048,14 @@
       </p:sp>
       <p:sp>
         <p:nvSpPr>
-          <p:cNvPr id="84" name="Rounded Rectangle 83"/>
+          <p:cNvPr id="85" name="Rounded Rectangle 84"/>
           <p:cNvSpPr/>
           <p:nvPr/>
         </p:nvSpPr>
         <p:spPr>
           <a:xfrm>
             <a:off x="274320" y="5404104"/>
-            <a:ext cx="2211567" cy="676656"/>
+            <a:ext cx="1818589" cy="676656"/>
           </a:xfrm>
           <a:prstGeom prst="roundRect">
             <a:avLst>
@@ -7059,14 +7096,14 @@
       </p:sp>
       <p:sp>
         <p:nvSpPr>
-          <p:cNvPr id="85" name="TextBox 84"/>
+          <p:cNvPr id="86" name="TextBox 85"/>
           <p:cNvSpPr txBox="1"/>
           <p:nvPr/>
         </p:nvSpPr>
         <p:spPr>
           <a:xfrm>
-            <a:off x="347472" y="5468112"/>
-            <a:ext cx="2065263" cy="201168"/>
+            <a:off x="329184" y="5468112"/>
+            <a:ext cx="1708861" cy="201168"/>
           </a:xfrm>
           <a:prstGeom prst="rect">
             <a:avLst/>
@@ -7081,7 +7118,7 @@
           <a:p>
             <a:pPr algn="ctr"/>
             <a:r>
-              <a:rPr sz="1050" b="1" i="0">
+              <a:rPr sz="1000" b="1" i="0">
                 <a:solidFill>
                   <a:srgbClr val="1F4E79"/>
                 </a:solidFill>
@@ -7094,14 +7131,14 @@
       </p:sp>
       <p:sp>
         <p:nvSpPr>
-          <p:cNvPr id="86" name="Rectangle 85"/>
+          <p:cNvPr id="87" name="Rectangle 86"/>
           <p:cNvSpPr/>
           <p:nvPr/>
         </p:nvSpPr>
         <p:spPr>
           <a:xfrm>
-            <a:off x="672402" y="5678424"/>
-            <a:ext cx="1415403" cy="13716"/>
+            <a:off x="601666" y="5678424"/>
+            <a:ext cx="1163897" cy="13716"/>
           </a:xfrm>
           <a:prstGeom prst="rect">
             <a:avLst/>
@@ -7138,14 +7175,14 @@
       </p:sp>
       <p:sp>
         <p:nvSpPr>
-          <p:cNvPr id="87" name="TextBox 86"/>
+          <p:cNvPr id="88" name="TextBox 87"/>
           <p:cNvSpPr txBox="1"/>
           <p:nvPr/>
         </p:nvSpPr>
         <p:spPr>
           <a:xfrm>
-            <a:off x="347472" y="5733288"/>
-            <a:ext cx="2065263" cy="292608"/>
+            <a:off x="329184" y="5733288"/>
+            <a:ext cx="1708861" cy="292608"/>
           </a:xfrm>
           <a:prstGeom prst="rect">
             <a:avLst/>
@@ -7160,7 +7197,7 @@
           <a:p>
             <a:pPr algn="ctr"/>
             <a:r>
-              <a:rPr sz="850" b="0" i="0">
+              <a:rPr sz="800" b="0" i="0">
                 <a:solidFill>
                   <a:srgbClr val="7A7A7A"/>
                 </a:solidFill>
@@ -7173,14 +7210,14 @@
       </p:sp>
       <p:sp>
         <p:nvSpPr>
-          <p:cNvPr id="88" name="Rounded Rectangle 87"/>
+          <p:cNvPr id="89" name="Rounded Rectangle 88"/>
           <p:cNvSpPr/>
           <p:nvPr/>
         </p:nvSpPr>
         <p:spPr>
           <a:xfrm>
-            <a:off x="2632191" y="5404104"/>
-            <a:ext cx="2211567" cy="676656"/>
+            <a:off x="2239213" y="5404104"/>
+            <a:ext cx="1818589" cy="676656"/>
           </a:xfrm>
           <a:prstGeom prst="roundRect">
             <a:avLst>
@@ -7221,14 +7258,14 @@
       </p:sp>
       <p:sp>
         <p:nvSpPr>
-          <p:cNvPr id="89" name="TextBox 88"/>
+          <p:cNvPr id="90" name="TextBox 89"/>
           <p:cNvSpPr txBox="1"/>
           <p:nvPr/>
         </p:nvSpPr>
         <p:spPr>
           <a:xfrm>
-            <a:off x="2705343" y="5468112"/>
-            <a:ext cx="2065263" cy="201168"/>
+            <a:off x="2294077" y="5468112"/>
+            <a:ext cx="1708861" cy="201168"/>
           </a:xfrm>
           <a:prstGeom prst="rect">
             <a:avLst/>
@@ -7243,7 +7280,7 @@
           <a:p>
             <a:pPr algn="ctr"/>
             <a:r>
-              <a:rPr sz="1050" b="1" i="0">
+              <a:rPr sz="1000" b="1" i="0">
                 <a:solidFill>
                   <a:srgbClr val="1F4E79"/>
                 </a:solidFill>
@@ -7256,14 +7293,14 @@
       </p:sp>
       <p:sp>
         <p:nvSpPr>
-          <p:cNvPr id="90" name="Rectangle 89"/>
+          <p:cNvPr id="91" name="Rectangle 90"/>
           <p:cNvSpPr/>
           <p:nvPr/>
         </p:nvSpPr>
         <p:spPr>
           <a:xfrm>
-            <a:off x="3030274" y="5678424"/>
-            <a:ext cx="1415403" cy="13716"/>
+            <a:off x="2566559" y="5678424"/>
+            <a:ext cx="1163897" cy="13716"/>
           </a:xfrm>
           <a:prstGeom prst="rect">
             <a:avLst/>
@@ -7300,14 +7337,14 @@
       </p:sp>
       <p:sp>
         <p:nvSpPr>
-          <p:cNvPr id="91" name="TextBox 90"/>
+          <p:cNvPr id="92" name="TextBox 91"/>
           <p:cNvSpPr txBox="1"/>
           <p:nvPr/>
         </p:nvSpPr>
         <p:spPr>
           <a:xfrm>
-            <a:off x="2705343" y="5733288"/>
-            <a:ext cx="2065263" cy="292608"/>
+            <a:off x="2294077" y="5733288"/>
+            <a:ext cx="1708861" cy="292608"/>
           </a:xfrm>
           <a:prstGeom prst="rect">
             <a:avLst/>
@@ -7322,7 +7359,7 @@
           <a:p>
             <a:pPr algn="ctr"/>
             <a:r>
-              <a:rPr sz="850" b="0" i="0">
+              <a:rPr sz="800" b="0" i="0">
                 <a:solidFill>
                   <a:srgbClr val="7A7A7A"/>
                 </a:solidFill>
@@ -7335,14 +7372,14 @@
       </p:sp>
       <p:sp>
         <p:nvSpPr>
-          <p:cNvPr id="92" name="Rounded Rectangle 91"/>
+          <p:cNvPr id="93" name="Rounded Rectangle 92"/>
           <p:cNvSpPr/>
           <p:nvPr/>
         </p:nvSpPr>
         <p:spPr>
           <a:xfrm>
-            <a:off x="4990063" y="5404104"/>
-            <a:ext cx="2211567" cy="676656"/>
+            <a:off x="4204106" y="5404104"/>
+            <a:ext cx="1818589" cy="676656"/>
           </a:xfrm>
           <a:prstGeom prst="roundRect">
             <a:avLst>
@@ -7383,14 +7420,14 @@
       </p:sp>
       <p:sp>
         <p:nvSpPr>
-          <p:cNvPr id="93" name="TextBox 92"/>
+          <p:cNvPr id="94" name="TextBox 93"/>
           <p:cNvSpPr txBox="1"/>
           <p:nvPr/>
         </p:nvSpPr>
         <p:spPr>
           <a:xfrm>
-            <a:off x="5063215" y="5468112"/>
-            <a:ext cx="2065263" cy="201168"/>
+            <a:off x="4258970" y="5468112"/>
+            <a:ext cx="1708861" cy="201168"/>
           </a:xfrm>
           <a:prstGeom prst="rect">
             <a:avLst/>
@@ -7405,7 +7442,7 @@
           <a:p>
             <a:pPr algn="ctr"/>
             <a:r>
-              <a:rPr sz="1050" b="1" i="0">
+              <a:rPr sz="1000" b="1" i="0">
                 <a:solidFill>
                   <a:srgbClr val="1F4E79"/>
                 </a:solidFill>
@@ -7418,14 +7455,14 @@
       </p:sp>
       <p:sp>
         <p:nvSpPr>
-          <p:cNvPr id="94" name="Rectangle 93"/>
+          <p:cNvPr id="95" name="Rectangle 94"/>
           <p:cNvSpPr/>
           <p:nvPr/>
         </p:nvSpPr>
         <p:spPr>
           <a:xfrm>
-            <a:off x="5388145" y="5678424"/>
-            <a:ext cx="1415403" cy="13716"/>
+            <a:off x="4531452" y="5678424"/>
+            <a:ext cx="1163897" cy="13716"/>
           </a:xfrm>
           <a:prstGeom prst="rect">
             <a:avLst/>
@@ -7462,14 +7499,14 @@
       </p:sp>
       <p:sp>
         <p:nvSpPr>
-          <p:cNvPr id="95" name="TextBox 94"/>
+          <p:cNvPr id="96" name="TextBox 95"/>
           <p:cNvSpPr txBox="1"/>
           <p:nvPr/>
         </p:nvSpPr>
         <p:spPr>
           <a:xfrm>
-            <a:off x="5063215" y="5733288"/>
-            <a:ext cx="2065263" cy="292608"/>
+            <a:off x="4258970" y="5733288"/>
+            <a:ext cx="1708861" cy="292608"/>
           </a:xfrm>
           <a:prstGeom prst="rect">
             <a:avLst/>
@@ -7484,7 +7521,7 @@
           <a:p>
             <a:pPr algn="ctr"/>
             <a:r>
-              <a:rPr sz="850" b="0" i="0">
+              <a:rPr sz="800" b="0" i="0">
                 <a:solidFill>
                   <a:srgbClr val="7A7A7A"/>
                 </a:solidFill>
@@ -7497,14 +7534,14 @@
       </p:sp>
       <p:sp>
         <p:nvSpPr>
-          <p:cNvPr id="96" name="Rounded Rectangle 95"/>
+          <p:cNvPr id="97" name="Rounded Rectangle 96"/>
           <p:cNvSpPr/>
           <p:nvPr/>
         </p:nvSpPr>
         <p:spPr>
           <a:xfrm>
-            <a:off x="7347935" y="5404104"/>
-            <a:ext cx="2211567" cy="676656"/>
+            <a:off x="6168999" y="5404104"/>
+            <a:ext cx="1818589" cy="676656"/>
           </a:xfrm>
           <a:prstGeom prst="roundRect">
             <a:avLst>
@@ -7545,14 +7582,14 @@
       </p:sp>
       <p:sp>
         <p:nvSpPr>
-          <p:cNvPr id="97" name="TextBox 96"/>
+          <p:cNvPr id="98" name="TextBox 97"/>
           <p:cNvSpPr txBox="1"/>
           <p:nvPr/>
         </p:nvSpPr>
         <p:spPr>
           <a:xfrm>
-            <a:off x="7421087" y="5468112"/>
-            <a:ext cx="2065263" cy="201168"/>
+            <a:off x="6223863" y="5468112"/>
+            <a:ext cx="1708861" cy="201168"/>
           </a:xfrm>
           <a:prstGeom prst="rect">
             <a:avLst/>
@@ -7567,7 +7604,7 @@
           <a:p>
             <a:pPr algn="ctr"/>
             <a:r>
-              <a:rPr sz="1050" b="1" i="0">
+              <a:rPr sz="1000" b="1" i="0">
                 <a:solidFill>
                   <a:srgbClr val="1F4E79"/>
                 </a:solidFill>
@@ -7580,14 +7617,14 @@
       </p:sp>
       <p:sp>
         <p:nvSpPr>
-          <p:cNvPr id="98" name="Rectangle 97"/>
+          <p:cNvPr id="99" name="Rectangle 98"/>
           <p:cNvSpPr/>
           <p:nvPr/>
         </p:nvSpPr>
         <p:spPr>
           <a:xfrm>
-            <a:off x="7746017" y="5678424"/>
-            <a:ext cx="1415403" cy="13716"/>
+            <a:off x="6496345" y="5678424"/>
+            <a:ext cx="1163897" cy="13716"/>
           </a:xfrm>
           <a:prstGeom prst="rect">
             <a:avLst/>
@@ -7624,14 +7661,14 @@
       </p:sp>
       <p:sp>
         <p:nvSpPr>
-          <p:cNvPr id="99" name="TextBox 98"/>
+          <p:cNvPr id="100" name="TextBox 99"/>
           <p:cNvSpPr txBox="1"/>
           <p:nvPr/>
         </p:nvSpPr>
         <p:spPr>
           <a:xfrm>
-            <a:off x="7421087" y="5733288"/>
-            <a:ext cx="2065263" cy="292608"/>
+            <a:off x="6223863" y="5733288"/>
+            <a:ext cx="1708861" cy="292608"/>
           </a:xfrm>
           <a:prstGeom prst="rect">
             <a:avLst/>
@@ -7646,7 +7683,7 @@
           <a:p>
             <a:pPr algn="ctr"/>
             <a:r>
-              <a:rPr sz="850" b="0" i="0">
+              <a:rPr sz="800" b="0" i="0">
                 <a:solidFill>
                   <a:srgbClr val="7A7A7A"/>
                 </a:solidFill>
@@ -7659,14 +7696,14 @@
       </p:sp>
       <p:sp>
         <p:nvSpPr>
-          <p:cNvPr id="100" name="Rounded Rectangle 99"/>
+          <p:cNvPr id="101" name="Rounded Rectangle 100"/>
           <p:cNvSpPr/>
           <p:nvPr/>
         </p:nvSpPr>
         <p:spPr>
           <a:xfrm>
-            <a:off x="9705807" y="5404104"/>
-            <a:ext cx="2211567" cy="676656"/>
+            <a:off x="8133892" y="5404104"/>
+            <a:ext cx="1818589" cy="676656"/>
           </a:xfrm>
           <a:prstGeom prst="roundRect">
             <a:avLst>
@@ -7707,14 +7744,14 @@
       </p:sp>
       <p:sp>
         <p:nvSpPr>
-          <p:cNvPr id="101" name="TextBox 100"/>
+          <p:cNvPr id="102" name="TextBox 101"/>
           <p:cNvSpPr txBox="1"/>
           <p:nvPr/>
         </p:nvSpPr>
         <p:spPr>
           <a:xfrm>
-            <a:off x="9778959" y="5468112"/>
-            <a:ext cx="2065263" cy="201168"/>
+            <a:off x="8188756" y="5468112"/>
+            <a:ext cx="1708861" cy="201168"/>
           </a:xfrm>
           <a:prstGeom prst="rect">
             <a:avLst/>
@@ -7729,27 +7766,27 @@
           <a:p>
             <a:pPr algn="ctr"/>
             <a:r>
-              <a:rPr sz="1050" b="1" i="0">
+              <a:rPr sz="1000" b="1" i="0">
                 <a:solidFill>
                   <a:srgbClr val="1F4E79"/>
                 </a:solidFill>
                 <a:latin typeface="Microsoft YaHei"/>
               </a:rPr>
-              <a:t>WCS N · 分拣机器人</a:t>
-            </a:r>
-          </a:p>
-        </p:txBody>
-      </p:sp>
-      <p:sp>
-        <p:nvSpPr>
-          <p:cNvPr id="102" name="Rectangle 101"/>
+              <a:t>WCS5 · 语音拣选</a:t>
+            </a:r>
+          </a:p>
+        </p:txBody>
+      </p:sp>
+      <p:sp>
+        <p:nvSpPr>
+          <p:cNvPr id="103" name="Rectangle 102"/>
           <p:cNvSpPr/>
           <p:nvPr/>
         </p:nvSpPr>
         <p:spPr>
           <a:xfrm>
-            <a:off x="10103889" y="5678424"/>
-            <a:ext cx="1415403" cy="13716"/>
+            <a:off x="8461238" y="5678424"/>
+            <a:ext cx="1163897" cy="13716"/>
           </a:xfrm>
           <a:prstGeom prst="rect">
             <a:avLst/>
@@ -7786,14 +7823,14 @@
       </p:sp>
       <p:sp>
         <p:nvSpPr>
-          <p:cNvPr id="103" name="TextBox 102"/>
+          <p:cNvPr id="104" name="TextBox 103"/>
           <p:cNvSpPr txBox="1"/>
           <p:nvPr/>
         </p:nvSpPr>
         <p:spPr>
           <a:xfrm>
-            <a:off x="9778959" y="5733288"/>
-            <a:ext cx="2065263" cy="292608"/>
+            <a:off x="8188756" y="5733288"/>
+            <a:ext cx="1708861" cy="292608"/>
           </a:xfrm>
           <a:prstGeom prst="rect">
             <a:avLst/>
@@ -7808,12 +7845,174 @@
           <a:p>
             <a:pPr algn="ctr"/>
             <a:r>
-              <a:rPr sz="850" b="0" i="0">
+              <a:rPr sz="800" b="0" i="0">
                 <a:solidFill>
                   <a:srgbClr val="7A7A7A"/>
                 </a:solidFill>
                 <a:latin typeface="Microsoft YaHei"/>
               </a:rPr>
+              <a:t>语音终端 · 免视觉拣选</a:t>
+            </a:r>
+          </a:p>
+        </p:txBody>
+      </p:sp>
+      <p:sp>
+        <p:nvSpPr>
+          <p:cNvPr id="105" name="Rounded Rectangle 104"/>
+          <p:cNvSpPr/>
+          <p:nvPr/>
+        </p:nvSpPr>
+        <p:spPr>
+          <a:xfrm>
+            <a:off x="10098785" y="5404104"/>
+            <a:ext cx="1818589" cy="676656"/>
+          </a:xfrm>
+          <a:prstGeom prst="roundRect">
+            <a:avLst>
+              <a:gd name="adj" fmla="val 5000"/>
+            </a:avLst>
+          </a:prstGeom>
+          <a:solidFill>
+            <a:srgbClr val="FFFFFF"/>
+          </a:solidFill>
+          <a:ln w="12700">
+            <a:solidFill>
+              <a:srgbClr val="C9C9C9"/>
+            </a:solidFill>
+          </a:ln>
+          <a:effectLst/>
+        </p:spPr>
+        <p:style>
+          <a:lnRef idx="1">
+            <a:schemeClr val="accent1"/>
+          </a:lnRef>
+          <a:fillRef idx="3">
+            <a:schemeClr val="accent1"/>
+          </a:fillRef>
+          <a:effectRef idx="2">
+            <a:schemeClr val="accent1"/>
+          </a:effectRef>
+          <a:fontRef idx="minor">
+            <a:schemeClr val="lt1"/>
+          </a:fontRef>
+        </p:style>
+        <p:txBody>
+          <a:bodyPr rtlCol="0" anchor="ctr"/>
+          <a:lstStyle/>
+          <a:p>
+            <a:pPr algn="ctr"/>
+          </a:p>
+        </p:txBody>
+      </p:sp>
+      <p:sp>
+        <p:nvSpPr>
+          <p:cNvPr id="106" name="TextBox 105"/>
+          <p:cNvSpPr txBox="1"/>
+          <p:nvPr/>
+        </p:nvSpPr>
+        <p:spPr>
+          <a:xfrm>
+            <a:off x="10153650" y="5468112"/>
+            <a:ext cx="1708861" cy="201168"/>
+          </a:xfrm>
+          <a:prstGeom prst="rect">
+            <a:avLst/>
+          </a:prstGeom>
+          <a:noFill/>
+        </p:spPr>
+        <p:txBody>
+          <a:bodyPr wrap="square" anchor="t" lIns="0" rIns="0" tIns="0" bIns="0">
+            <a:spAutoFit/>
+          </a:bodyPr>
+          <a:lstStyle/>
+          <a:p>
+            <a:pPr algn="ctr"/>
+            <a:r>
+              <a:rPr sz="1000" b="1" i="0">
+                <a:solidFill>
+                  <a:srgbClr val="1F4E79"/>
+                </a:solidFill>
+                <a:latin typeface="Microsoft YaHei"/>
+              </a:rPr>
+              <a:t>WCS N · 分拣机器人</a:t>
+            </a:r>
+          </a:p>
+        </p:txBody>
+      </p:sp>
+      <p:sp>
+        <p:nvSpPr>
+          <p:cNvPr id="107" name="Rectangle 106"/>
+          <p:cNvSpPr/>
+          <p:nvPr/>
+        </p:nvSpPr>
+        <p:spPr>
+          <a:xfrm>
+            <a:off x="10426132" y="5678424"/>
+            <a:ext cx="1163897" cy="13716"/>
+          </a:xfrm>
+          <a:prstGeom prst="rect">
+            <a:avLst/>
+          </a:prstGeom>
+          <a:solidFill>
+            <a:srgbClr val="C9C9C9"/>
+          </a:solidFill>
+          <a:ln>
+            <a:noFill/>
+          </a:ln>
+          <a:effectLst/>
+        </p:spPr>
+        <p:style>
+          <a:lnRef idx="1">
+            <a:schemeClr val="accent1"/>
+          </a:lnRef>
+          <a:fillRef idx="3">
+            <a:schemeClr val="accent1"/>
+          </a:fillRef>
+          <a:effectRef idx="2">
+            <a:schemeClr val="accent1"/>
+          </a:effectRef>
+          <a:fontRef idx="minor">
+            <a:schemeClr val="lt1"/>
+          </a:fontRef>
+        </p:style>
+        <p:txBody>
+          <a:bodyPr rtlCol="0" anchor="ctr"/>
+          <a:lstStyle/>
+          <a:p>
+            <a:pPr algn="ctr"/>
+          </a:p>
+        </p:txBody>
+      </p:sp>
+      <p:sp>
+        <p:nvSpPr>
+          <p:cNvPr id="108" name="TextBox 107"/>
+          <p:cNvSpPr txBox="1"/>
+          <p:nvPr/>
+        </p:nvSpPr>
+        <p:spPr>
+          <a:xfrm>
+            <a:off x="10153650" y="5733288"/>
+            <a:ext cx="1708861" cy="292608"/>
+          </a:xfrm>
+          <a:prstGeom prst="rect">
+            <a:avLst/>
+          </a:prstGeom>
+          <a:noFill/>
+        </p:spPr>
+        <p:txBody>
+          <a:bodyPr wrap="square" anchor="t" lIns="0" rIns="0" tIns="0" bIns="0">
+            <a:spAutoFit/>
+          </a:bodyPr>
+          <a:lstStyle/>
+          <a:p>
+            <a:pPr algn="ctr"/>
+            <a:r>
+              <a:rPr sz="800" b="0" i="0">
+                <a:solidFill>
+                  <a:srgbClr val="7A7A7A"/>
+                </a:solidFill>
+                <a:latin typeface="Microsoft YaHei"/>
+              </a:rPr>
               <a:t>柔性分拣 · 可横向扩展</a:t>
             </a:r>
           </a:p>
@@ -7821,7 +8020,7 @@
       </p:sp>
       <p:sp>
         <p:nvSpPr>
-          <p:cNvPr id="104" name="Rounded Rectangle 103"/>
+          <p:cNvPr id="109" name="Rounded Rectangle 108"/>
           <p:cNvSpPr/>
           <p:nvPr/>
         </p:nvSpPr>
@@ -7869,7 +8068,7 @@
       </p:sp>
       <p:sp>
         <p:nvSpPr>
-          <p:cNvPr id="105" name="TextBox 104"/>
+          <p:cNvPr id="110" name="TextBox 109"/>
           <p:cNvSpPr txBox="1"/>
           <p:nvPr/>
         </p:nvSpPr>
@@ -7904,7 +8103,7 @@
       </p:sp>
       <p:sp>
         <p:nvSpPr>
-          <p:cNvPr id="106" name="Rounded Rectangle 105"/>
+          <p:cNvPr id="111" name="Rounded Rectangle 110"/>
           <p:cNvSpPr/>
           <p:nvPr/>
         </p:nvSpPr>
@@ -7952,7 +8151,7 @@
       </p:sp>
       <p:sp>
         <p:nvSpPr>
-          <p:cNvPr id="107" name="TextBox 106"/>
+          <p:cNvPr id="112" name="TextBox 111"/>
           <p:cNvSpPr txBox="1"/>
           <p:nvPr/>
         </p:nvSpPr>
@@ -7987,7 +8186,7 @@
       </p:sp>
       <p:sp>
         <p:nvSpPr>
-          <p:cNvPr id="108" name="Rounded Rectangle 107"/>
+          <p:cNvPr id="113" name="Rounded Rectangle 112"/>
           <p:cNvSpPr/>
           <p:nvPr/>
         </p:nvSpPr>
@@ -8035,7 +8234,7 @@
       </p:sp>
       <p:sp>
         <p:nvSpPr>
-          <p:cNvPr id="109" name="TextBox 108"/>
+          <p:cNvPr id="114" name="TextBox 113"/>
           <p:cNvSpPr txBox="1"/>
           <p:nvPr/>
         </p:nvSpPr>
@@ -8070,7 +8269,7 @@
       </p:sp>
       <p:sp>
         <p:nvSpPr>
-          <p:cNvPr id="110" name="Rounded Rectangle 109"/>
+          <p:cNvPr id="115" name="Rounded Rectangle 114"/>
           <p:cNvSpPr/>
           <p:nvPr/>
         </p:nvSpPr>
@@ -8118,7 +8317,7 @@
       </p:sp>
       <p:sp>
         <p:nvSpPr>
-          <p:cNvPr id="111" name="TextBox 110"/>
+          <p:cNvPr id="116" name="TextBox 115"/>
           <p:cNvSpPr txBox="1"/>
           <p:nvPr/>
         </p:nvSpPr>
@@ -8153,7 +8352,7 @@
       </p:sp>
       <p:sp>
         <p:nvSpPr>
-          <p:cNvPr id="112" name="Rounded Rectangle 111"/>
+          <p:cNvPr id="117" name="Rounded Rectangle 116"/>
           <p:cNvSpPr/>
           <p:nvPr/>
         </p:nvSpPr>
@@ -8201,7 +8400,7 @@
       </p:sp>
       <p:sp>
         <p:nvSpPr>
-          <p:cNvPr id="113" name="TextBox 112"/>
+          <p:cNvPr id="118" name="TextBox 117"/>
           <p:cNvSpPr txBox="1"/>
           <p:nvPr/>
         </p:nvSpPr>
@@ -8236,7 +8435,7 @@
       </p:sp>
       <p:sp>
         <p:nvSpPr>
-          <p:cNvPr id="114" name="Rounded Rectangle 113"/>
+          <p:cNvPr id="119" name="Rounded Rectangle 118"/>
           <p:cNvSpPr/>
           <p:nvPr/>
         </p:nvSpPr>
@@ -8284,7 +8483,7 @@
       </p:sp>
       <p:sp>
         <p:nvSpPr>
-          <p:cNvPr id="115" name="TextBox 114"/>
+          <p:cNvPr id="120" name="TextBox 119"/>
           <p:cNvSpPr txBox="1"/>
           <p:nvPr/>
         </p:nvSpPr>
@@ -8319,7 +8518,7 @@
       </p:sp>
       <p:sp>
         <p:nvSpPr>
-          <p:cNvPr id="116" name="Rounded Rectangle 115"/>
+          <p:cNvPr id="121" name="Rounded Rectangle 120"/>
           <p:cNvSpPr/>
           <p:nvPr/>
         </p:nvSpPr>
@@ -8367,7 +8566,7 @@
       </p:sp>
       <p:sp>
         <p:nvSpPr>
-          <p:cNvPr id="117" name="TextBox 116"/>
+          <p:cNvPr id="122" name="TextBox 121"/>
           <p:cNvSpPr txBox="1"/>
           <p:nvPr/>
         </p:nvSpPr>
@@ -8402,7 +8601,7 @@
       </p:sp>
       <p:sp>
         <p:nvSpPr>
-          <p:cNvPr id="118" name="Rounded Rectangle 117"/>
+          <p:cNvPr id="123" name="Rounded Rectangle 122"/>
           <p:cNvSpPr/>
           <p:nvPr/>
         </p:nvSpPr>
@@ -8450,7 +8649,7 @@
       </p:sp>
       <p:sp>
         <p:nvSpPr>
-          <p:cNvPr id="119" name="TextBox 118"/>
+          <p:cNvPr id="124" name="TextBox 123"/>
           <p:cNvSpPr txBox="1"/>
           <p:nvPr/>
         </p:nvSpPr>
@@ -8485,7 +8684,7 @@
       </p:sp>
       <p:sp>
         <p:nvSpPr>
-          <p:cNvPr id="120" name="Rounded Rectangle 119"/>
+          <p:cNvPr id="125" name="Rounded Rectangle 124"/>
           <p:cNvSpPr/>
           <p:nvPr/>
         </p:nvSpPr>
@@ -8533,7 +8732,7 @@
       </p:sp>
       <p:sp>
         <p:nvSpPr>
-          <p:cNvPr id="121" name="TextBox 120"/>
+          <p:cNvPr id="126" name="TextBox 125"/>
           <p:cNvSpPr txBox="1"/>
           <p:nvPr/>
         </p:nvSpPr>
@@ -8568,7 +8767,7 @@
       </p:sp>
       <p:sp>
         <p:nvSpPr>
-          <p:cNvPr id="122" name="Rounded Rectangle 121"/>
+          <p:cNvPr id="127" name="Rounded Rectangle 126"/>
           <p:cNvSpPr/>
           <p:nvPr/>
         </p:nvSpPr>
@@ -8616,7 +8815,7 @@
       </p:sp>
       <p:sp>
         <p:nvSpPr>
-          <p:cNvPr id="123" name="TextBox 122"/>
+          <p:cNvPr id="128" name="TextBox 127"/>
           <p:cNvSpPr txBox="1"/>
           <p:nvPr/>
         </p:nvSpPr>
@@ -8651,7 +8850,7 @@
       </p:sp>
       <p:sp>
         <p:nvSpPr>
-          <p:cNvPr id="124" name="Rounded Rectangle 123"/>
+          <p:cNvPr id="129" name="Rounded Rectangle 128"/>
           <p:cNvSpPr/>
           <p:nvPr/>
         </p:nvSpPr>
@@ -8699,7 +8898,7 @@
       </p:sp>
       <p:sp>
         <p:nvSpPr>
-          <p:cNvPr id="125" name="TextBox 124"/>
+          <p:cNvPr id="130" name="TextBox 129"/>
           <p:cNvSpPr txBox="1"/>
           <p:nvPr/>
         </p:nvSpPr>
@@ -8734,7 +8933,7 @@
       </p:sp>
       <p:sp>
         <p:nvSpPr>
-          <p:cNvPr id="126" name="TextBox 125"/>
+          <p:cNvPr id="131" name="TextBox 130"/>
           <p:cNvSpPr txBox="1"/>
           <p:nvPr/>
         </p:nvSpPr>

</xml_diff>

<commit_message>
Regroup WMS row into supply-chain/store domains; add device-monitoring layer to kanban panel
Per annotated reference image: WMS row now groups DC/FC/City DC Flux WMS
under 供应链 WMS and 门店/云仓 WMS under 门店域 WMS, each card showing its
sub-systems (DC, CDC, FWDC/FC/CBEC, 门店, 云仓/社区店/Darkstore). Added
设备监控层 as a fourth description item in the WCS 可视化平台 side panel.
</commit_message>
<xml_diff>
--- a/wcs-architecture/WCS架构产品方案.pptx
+++ b/wcs-architecture/WCS架构产品方案.pptx
@@ -3211,7 +3211,7 @@
         <p:spPr>
           <a:xfrm>
             <a:off x="274320" y="877824"/>
-            <a:ext cx="3657600" cy="201168"/>
+            <a:ext cx="6400800" cy="201168"/>
           </a:xfrm>
           <a:prstGeom prst="rect">
             <a:avLst/>
@@ -3232,915 +3232,60 @@
                 </a:solidFill>
                 <a:latin typeface="Microsoft YaHei"/>
               </a:rPr>
-              <a:t>上游 · 多 WMS / WHC 系统</a:t>
-            </a:r>
-          </a:p>
-        </p:txBody>
-      </p:sp>
-      <p:sp>
-        <p:nvSpPr>
-          <p:cNvPr id="6" name="Rounded Rectangle 5"/>
+              <a:t>业务决策层 · WMS（上游多源系统接入）</a:t>
+            </a:r>
+          </a:p>
+        </p:txBody>
+      </p:sp>
+      <p:sp>
+        <p:nvSpPr>
+          <p:cNvPr id="6" name="TextBox 5"/>
+          <p:cNvSpPr txBox="1"/>
+          <p:nvPr/>
+        </p:nvSpPr>
+        <p:spPr>
+          <a:xfrm>
+            <a:off x="292608" y="877824"/>
+            <a:ext cx="2743200" cy="164592"/>
+          </a:xfrm>
+          <a:prstGeom prst="rect">
+            <a:avLst/>
+          </a:prstGeom>
+          <a:noFill/>
+        </p:spPr>
+        <p:txBody>
+          <a:bodyPr wrap="square" anchor="t" lIns="0" rIns="0" tIns="0" bIns="0">
+            <a:spAutoFit/>
+          </a:bodyPr>
+          <a:lstStyle/>
+          <a:p>
+            <a:pPr algn="l"/>
+            <a:r>
+              <a:rPr sz="900" b="1" i="0">
+                <a:solidFill>
+                  <a:srgbClr val="595959"/>
+                </a:solidFill>
+                <a:latin typeface="Microsoft YaHei"/>
+              </a:rPr>
+              <a:t>供应链 WMS</a:t>
+            </a:r>
+          </a:p>
+        </p:txBody>
+      </p:sp>
+      <p:sp>
+        <p:nvSpPr>
+          <p:cNvPr id="7" name="Rounded Rectangle 6"/>
           <p:cNvSpPr/>
           <p:nvPr/>
         </p:nvSpPr>
         <p:spPr>
           <a:xfrm>
             <a:off x="274320" y="1078992"/>
-            <a:ext cx="2211567" cy="530352"/>
+            <a:ext cx="6549996" cy="530352"/>
           </a:xfrm>
           <a:prstGeom prst="roundRect">
             <a:avLst>
               <a:gd name="adj" fmla="val 5000"/>
-            </a:avLst>
-          </a:prstGeom>
-          <a:solidFill>
-            <a:srgbClr val="FFFFFF"/>
-          </a:solidFill>
-          <a:ln w="12700">
-            <a:solidFill>
-              <a:srgbClr val="9FB7D4"/>
-            </a:solidFill>
-          </a:ln>
-          <a:effectLst/>
-        </p:spPr>
-        <p:style>
-          <a:lnRef idx="1">
-            <a:schemeClr val="accent1"/>
-          </a:lnRef>
-          <a:fillRef idx="3">
-            <a:schemeClr val="accent1"/>
-          </a:fillRef>
-          <a:effectRef idx="2">
-            <a:schemeClr val="accent1"/>
-          </a:effectRef>
-          <a:fontRef idx="minor">
-            <a:schemeClr val="lt1"/>
-          </a:fontRef>
-        </p:style>
-        <p:txBody>
-          <a:bodyPr rtlCol="0" anchor="ctr"/>
-          <a:lstStyle/>
-          <a:p>
-            <a:pPr algn="ctr"/>
-          </a:p>
-        </p:txBody>
-      </p:sp>
-      <p:sp>
-        <p:nvSpPr>
-          <p:cNvPr id="7" name="TextBox 6"/>
-          <p:cNvSpPr txBox="1"/>
-          <p:nvPr/>
-        </p:nvSpPr>
-        <p:spPr>
-          <a:xfrm>
-            <a:off x="274320" y="1152144"/>
-            <a:ext cx="2211567" cy="219456"/>
-          </a:xfrm>
-          <a:prstGeom prst="rect">
-            <a:avLst/>
-          </a:prstGeom>
-          <a:noFill/>
-        </p:spPr>
-        <p:txBody>
-          <a:bodyPr wrap="square" anchor="t" lIns="0" rIns="0" tIns="0" bIns="0">
-            <a:spAutoFit/>
-          </a:bodyPr>
-          <a:lstStyle/>
-          <a:p>
-            <a:pPr algn="ctr"/>
-            <a:r>
-              <a:rPr sz="1250" b="1" i="0">
-                <a:solidFill>
-                  <a:srgbClr val="1F4E79"/>
-                </a:solidFill>
-                <a:latin typeface="Microsoft YaHei"/>
-              </a:rPr>
-              <a:t>DC Flux WMS</a:t>
-            </a:r>
-          </a:p>
-        </p:txBody>
-      </p:sp>
-      <p:sp>
-        <p:nvSpPr>
-          <p:cNvPr id="8" name="Rectangle 7"/>
-          <p:cNvSpPr/>
-          <p:nvPr/>
-        </p:nvSpPr>
-        <p:spPr>
-          <a:xfrm>
-            <a:off x="672402" y="1389888"/>
-            <a:ext cx="1415403" cy="16459"/>
-          </a:xfrm>
-          <a:prstGeom prst="rect">
-            <a:avLst/>
-          </a:prstGeom>
-          <a:solidFill>
-            <a:srgbClr val="2E75B6"/>
-          </a:solidFill>
-          <a:ln>
-            <a:noFill/>
-          </a:ln>
-          <a:effectLst/>
-        </p:spPr>
-        <p:style>
-          <a:lnRef idx="1">
-            <a:schemeClr val="accent1"/>
-          </a:lnRef>
-          <a:fillRef idx="3">
-            <a:schemeClr val="accent1"/>
-          </a:fillRef>
-          <a:effectRef idx="2">
-            <a:schemeClr val="accent1"/>
-          </a:effectRef>
-          <a:fontRef idx="minor">
-            <a:schemeClr val="lt1"/>
-          </a:fontRef>
-        </p:style>
-        <p:txBody>
-          <a:bodyPr rtlCol="0" anchor="ctr"/>
-          <a:lstStyle/>
-          <a:p>
-            <a:pPr algn="ctr"/>
-          </a:p>
-        </p:txBody>
-      </p:sp>
-      <p:sp>
-        <p:nvSpPr>
-          <p:cNvPr id="9" name="Rounded Rectangle 8"/>
-          <p:cNvSpPr/>
-          <p:nvPr/>
-        </p:nvSpPr>
-        <p:spPr>
-          <a:xfrm>
-            <a:off x="2632191" y="1078992"/>
-            <a:ext cx="2211567" cy="530352"/>
-          </a:xfrm>
-          <a:prstGeom prst="roundRect">
-            <a:avLst>
-              <a:gd name="adj" fmla="val 5000"/>
-            </a:avLst>
-          </a:prstGeom>
-          <a:solidFill>
-            <a:srgbClr val="FFFFFF"/>
-          </a:solidFill>
-          <a:ln w="12700">
-            <a:solidFill>
-              <a:srgbClr val="9FB7D4"/>
-            </a:solidFill>
-          </a:ln>
-          <a:effectLst/>
-        </p:spPr>
-        <p:style>
-          <a:lnRef idx="1">
-            <a:schemeClr val="accent1"/>
-          </a:lnRef>
-          <a:fillRef idx="3">
-            <a:schemeClr val="accent1"/>
-          </a:fillRef>
-          <a:effectRef idx="2">
-            <a:schemeClr val="accent1"/>
-          </a:effectRef>
-          <a:fontRef idx="minor">
-            <a:schemeClr val="lt1"/>
-          </a:fontRef>
-        </p:style>
-        <p:txBody>
-          <a:bodyPr rtlCol="0" anchor="ctr"/>
-          <a:lstStyle/>
-          <a:p>
-            <a:pPr algn="ctr"/>
-          </a:p>
-        </p:txBody>
-      </p:sp>
-      <p:sp>
-        <p:nvSpPr>
-          <p:cNvPr id="10" name="TextBox 9"/>
-          <p:cNvSpPr txBox="1"/>
-          <p:nvPr/>
-        </p:nvSpPr>
-        <p:spPr>
-          <a:xfrm>
-            <a:off x="2632191" y="1152144"/>
-            <a:ext cx="2211567" cy="219456"/>
-          </a:xfrm>
-          <a:prstGeom prst="rect">
-            <a:avLst/>
-          </a:prstGeom>
-          <a:noFill/>
-        </p:spPr>
-        <p:txBody>
-          <a:bodyPr wrap="square" anchor="t" lIns="0" rIns="0" tIns="0" bIns="0">
-            <a:spAutoFit/>
-          </a:bodyPr>
-          <a:lstStyle/>
-          <a:p>
-            <a:pPr algn="ctr"/>
-            <a:r>
-              <a:rPr sz="1250" b="1" i="0">
-                <a:solidFill>
-                  <a:srgbClr val="1F4E79"/>
-                </a:solidFill>
-                <a:latin typeface="Microsoft YaHei"/>
-              </a:rPr>
-              <a:t>FC Flux WMS</a:t>
-            </a:r>
-          </a:p>
-        </p:txBody>
-      </p:sp>
-      <p:sp>
-        <p:nvSpPr>
-          <p:cNvPr id="11" name="Rectangle 10"/>
-          <p:cNvSpPr/>
-          <p:nvPr/>
-        </p:nvSpPr>
-        <p:spPr>
-          <a:xfrm>
-            <a:off x="3030274" y="1389888"/>
-            <a:ext cx="1415403" cy="16459"/>
-          </a:xfrm>
-          <a:prstGeom prst="rect">
-            <a:avLst/>
-          </a:prstGeom>
-          <a:solidFill>
-            <a:srgbClr val="2E75B6"/>
-          </a:solidFill>
-          <a:ln>
-            <a:noFill/>
-          </a:ln>
-          <a:effectLst/>
-        </p:spPr>
-        <p:style>
-          <a:lnRef idx="1">
-            <a:schemeClr val="accent1"/>
-          </a:lnRef>
-          <a:fillRef idx="3">
-            <a:schemeClr val="accent1"/>
-          </a:fillRef>
-          <a:effectRef idx="2">
-            <a:schemeClr val="accent1"/>
-          </a:effectRef>
-          <a:fontRef idx="minor">
-            <a:schemeClr val="lt1"/>
-          </a:fontRef>
-        </p:style>
-        <p:txBody>
-          <a:bodyPr rtlCol="0" anchor="ctr"/>
-          <a:lstStyle/>
-          <a:p>
-            <a:pPr algn="ctr"/>
-          </a:p>
-        </p:txBody>
-      </p:sp>
-      <p:sp>
-        <p:nvSpPr>
-          <p:cNvPr id="12" name="Rounded Rectangle 11"/>
-          <p:cNvSpPr/>
-          <p:nvPr/>
-        </p:nvSpPr>
-        <p:spPr>
-          <a:xfrm>
-            <a:off x="4990063" y="1078992"/>
-            <a:ext cx="2211567" cy="530352"/>
-          </a:xfrm>
-          <a:prstGeom prst="roundRect">
-            <a:avLst>
-              <a:gd name="adj" fmla="val 5000"/>
-            </a:avLst>
-          </a:prstGeom>
-          <a:solidFill>
-            <a:srgbClr val="FFFFFF"/>
-          </a:solidFill>
-          <a:ln w="12700">
-            <a:solidFill>
-              <a:srgbClr val="9FB7D4"/>
-            </a:solidFill>
-          </a:ln>
-          <a:effectLst/>
-        </p:spPr>
-        <p:style>
-          <a:lnRef idx="1">
-            <a:schemeClr val="accent1"/>
-          </a:lnRef>
-          <a:fillRef idx="3">
-            <a:schemeClr val="accent1"/>
-          </a:fillRef>
-          <a:effectRef idx="2">
-            <a:schemeClr val="accent1"/>
-          </a:effectRef>
-          <a:fontRef idx="minor">
-            <a:schemeClr val="lt1"/>
-          </a:fontRef>
-        </p:style>
-        <p:txBody>
-          <a:bodyPr rtlCol="0" anchor="ctr"/>
-          <a:lstStyle/>
-          <a:p>
-            <a:pPr algn="ctr"/>
-          </a:p>
-        </p:txBody>
-      </p:sp>
-      <p:sp>
-        <p:nvSpPr>
-          <p:cNvPr id="13" name="TextBox 12"/>
-          <p:cNvSpPr txBox="1"/>
-          <p:nvPr/>
-        </p:nvSpPr>
-        <p:spPr>
-          <a:xfrm>
-            <a:off x="4990063" y="1152144"/>
-            <a:ext cx="2211567" cy="219456"/>
-          </a:xfrm>
-          <a:prstGeom prst="rect">
-            <a:avLst/>
-          </a:prstGeom>
-          <a:noFill/>
-        </p:spPr>
-        <p:txBody>
-          <a:bodyPr wrap="square" anchor="t" lIns="0" rIns="0" tIns="0" bIns="0">
-            <a:spAutoFit/>
-          </a:bodyPr>
-          <a:lstStyle/>
-          <a:p>
-            <a:pPr algn="ctr"/>
-            <a:r>
-              <a:rPr sz="1250" b="1" i="0">
-                <a:solidFill>
-                  <a:srgbClr val="1F4E79"/>
-                </a:solidFill>
-                <a:latin typeface="Microsoft YaHei"/>
-              </a:rPr>
-              <a:t>City DC WMS</a:t>
-            </a:r>
-          </a:p>
-        </p:txBody>
-      </p:sp>
-      <p:sp>
-        <p:nvSpPr>
-          <p:cNvPr id="14" name="Rectangle 13"/>
-          <p:cNvSpPr/>
-          <p:nvPr/>
-        </p:nvSpPr>
-        <p:spPr>
-          <a:xfrm>
-            <a:off x="5388145" y="1389888"/>
-            <a:ext cx="1415403" cy="16459"/>
-          </a:xfrm>
-          <a:prstGeom prst="rect">
-            <a:avLst/>
-          </a:prstGeom>
-          <a:solidFill>
-            <a:srgbClr val="2E75B6"/>
-          </a:solidFill>
-          <a:ln>
-            <a:noFill/>
-          </a:ln>
-          <a:effectLst/>
-        </p:spPr>
-        <p:style>
-          <a:lnRef idx="1">
-            <a:schemeClr val="accent1"/>
-          </a:lnRef>
-          <a:fillRef idx="3">
-            <a:schemeClr val="accent1"/>
-          </a:fillRef>
-          <a:effectRef idx="2">
-            <a:schemeClr val="accent1"/>
-          </a:effectRef>
-          <a:fontRef idx="minor">
-            <a:schemeClr val="lt1"/>
-          </a:fontRef>
-        </p:style>
-        <p:txBody>
-          <a:bodyPr rtlCol="0" anchor="ctr"/>
-          <a:lstStyle/>
-          <a:p>
-            <a:pPr algn="ctr"/>
-          </a:p>
-        </p:txBody>
-      </p:sp>
-      <p:sp>
-        <p:nvSpPr>
-          <p:cNvPr id="15" name="Rounded Rectangle 14"/>
-          <p:cNvSpPr/>
-          <p:nvPr/>
-        </p:nvSpPr>
-        <p:spPr>
-          <a:xfrm>
-            <a:off x="7347935" y="1078992"/>
-            <a:ext cx="2211567" cy="530352"/>
-          </a:xfrm>
-          <a:prstGeom prst="roundRect">
-            <a:avLst>
-              <a:gd name="adj" fmla="val 5000"/>
-            </a:avLst>
-          </a:prstGeom>
-          <a:solidFill>
-            <a:srgbClr val="FFFFFF"/>
-          </a:solidFill>
-          <a:ln w="12700">
-            <a:solidFill>
-              <a:srgbClr val="9FB7D4"/>
-            </a:solidFill>
-          </a:ln>
-          <a:effectLst/>
-        </p:spPr>
-        <p:style>
-          <a:lnRef idx="1">
-            <a:schemeClr val="accent1"/>
-          </a:lnRef>
-          <a:fillRef idx="3">
-            <a:schemeClr val="accent1"/>
-          </a:fillRef>
-          <a:effectRef idx="2">
-            <a:schemeClr val="accent1"/>
-          </a:effectRef>
-          <a:fontRef idx="minor">
-            <a:schemeClr val="lt1"/>
-          </a:fontRef>
-        </p:style>
-        <p:txBody>
-          <a:bodyPr rtlCol="0" anchor="ctr"/>
-          <a:lstStyle/>
-          <a:p>
-            <a:pPr algn="ctr"/>
-          </a:p>
-        </p:txBody>
-      </p:sp>
-      <p:sp>
-        <p:nvSpPr>
-          <p:cNvPr id="16" name="TextBox 15"/>
-          <p:cNvSpPr txBox="1"/>
-          <p:nvPr/>
-        </p:nvSpPr>
-        <p:spPr>
-          <a:xfrm>
-            <a:off x="7347935" y="1152144"/>
-            <a:ext cx="2211567" cy="219456"/>
-          </a:xfrm>
-          <a:prstGeom prst="rect">
-            <a:avLst/>
-          </a:prstGeom>
-          <a:noFill/>
-        </p:spPr>
-        <p:txBody>
-          <a:bodyPr wrap="square" anchor="t" lIns="0" rIns="0" tIns="0" bIns="0">
-            <a:spAutoFit/>
-          </a:bodyPr>
-          <a:lstStyle/>
-          <a:p>
-            <a:pPr algn="ctr"/>
-            <a:r>
-              <a:rPr sz="1250" b="1" i="0">
-                <a:solidFill>
-                  <a:srgbClr val="1F4E79"/>
-                </a:solidFill>
-                <a:latin typeface="Microsoft YaHei"/>
-              </a:rPr>
-              <a:t>门店 WMS</a:t>
-            </a:r>
-          </a:p>
-        </p:txBody>
-      </p:sp>
-      <p:sp>
-        <p:nvSpPr>
-          <p:cNvPr id="17" name="Rectangle 16"/>
-          <p:cNvSpPr/>
-          <p:nvPr/>
-        </p:nvSpPr>
-        <p:spPr>
-          <a:xfrm>
-            <a:off x="7746017" y="1389888"/>
-            <a:ext cx="1415403" cy="16459"/>
-          </a:xfrm>
-          <a:prstGeom prst="rect">
-            <a:avLst/>
-          </a:prstGeom>
-          <a:solidFill>
-            <a:srgbClr val="2E75B6"/>
-          </a:solidFill>
-          <a:ln>
-            <a:noFill/>
-          </a:ln>
-          <a:effectLst/>
-        </p:spPr>
-        <p:style>
-          <a:lnRef idx="1">
-            <a:schemeClr val="accent1"/>
-          </a:lnRef>
-          <a:fillRef idx="3">
-            <a:schemeClr val="accent1"/>
-          </a:fillRef>
-          <a:effectRef idx="2">
-            <a:schemeClr val="accent1"/>
-          </a:effectRef>
-          <a:fontRef idx="minor">
-            <a:schemeClr val="lt1"/>
-          </a:fontRef>
-        </p:style>
-        <p:txBody>
-          <a:bodyPr rtlCol="0" anchor="ctr"/>
-          <a:lstStyle/>
-          <a:p>
-            <a:pPr algn="ctr"/>
-          </a:p>
-        </p:txBody>
-      </p:sp>
-      <p:sp>
-        <p:nvSpPr>
-          <p:cNvPr id="18" name="Rounded Rectangle 17"/>
-          <p:cNvSpPr/>
-          <p:nvPr/>
-        </p:nvSpPr>
-        <p:spPr>
-          <a:xfrm>
-            <a:off x="9705807" y="1078992"/>
-            <a:ext cx="2211567" cy="530352"/>
-          </a:xfrm>
-          <a:prstGeom prst="roundRect">
-            <a:avLst>
-              <a:gd name="adj" fmla="val 5000"/>
-            </a:avLst>
-          </a:prstGeom>
-          <a:solidFill>
-            <a:srgbClr val="FFFFFF"/>
-          </a:solidFill>
-          <a:ln w="12700">
-            <a:solidFill>
-              <a:srgbClr val="9FB7D4"/>
-            </a:solidFill>
-          </a:ln>
-          <a:effectLst/>
-        </p:spPr>
-        <p:style>
-          <a:lnRef idx="1">
-            <a:schemeClr val="accent1"/>
-          </a:lnRef>
-          <a:fillRef idx="3">
-            <a:schemeClr val="accent1"/>
-          </a:fillRef>
-          <a:effectRef idx="2">
-            <a:schemeClr val="accent1"/>
-          </a:effectRef>
-          <a:fontRef idx="minor">
-            <a:schemeClr val="lt1"/>
-          </a:fontRef>
-        </p:style>
-        <p:txBody>
-          <a:bodyPr rtlCol="0" anchor="ctr"/>
-          <a:lstStyle/>
-          <a:p>
-            <a:pPr algn="ctr"/>
-          </a:p>
-        </p:txBody>
-      </p:sp>
-      <p:sp>
-        <p:nvSpPr>
-          <p:cNvPr id="19" name="TextBox 18"/>
-          <p:cNvSpPr txBox="1"/>
-          <p:nvPr/>
-        </p:nvSpPr>
-        <p:spPr>
-          <a:xfrm>
-            <a:off x="9705807" y="1152144"/>
-            <a:ext cx="2211567" cy="219456"/>
-          </a:xfrm>
-          <a:prstGeom prst="rect">
-            <a:avLst/>
-          </a:prstGeom>
-          <a:noFill/>
-        </p:spPr>
-        <p:txBody>
-          <a:bodyPr wrap="square" anchor="t" lIns="0" rIns="0" tIns="0" bIns="0">
-            <a:spAutoFit/>
-          </a:bodyPr>
-          <a:lstStyle/>
-          <a:p>
-            <a:pPr algn="ctr"/>
-            <a:r>
-              <a:rPr sz="1250" b="1" i="0">
-                <a:solidFill>
-                  <a:srgbClr val="1F4E79"/>
-                </a:solidFill>
-                <a:latin typeface="Microsoft YaHei"/>
-              </a:rPr>
-              <a:t>云仓 WMS</a:t>
-            </a:r>
-          </a:p>
-        </p:txBody>
-      </p:sp>
-      <p:sp>
-        <p:nvSpPr>
-          <p:cNvPr id="20" name="Rectangle 19"/>
-          <p:cNvSpPr/>
-          <p:nvPr/>
-        </p:nvSpPr>
-        <p:spPr>
-          <a:xfrm>
-            <a:off x="10103889" y="1389888"/>
-            <a:ext cx="1415403" cy="16459"/>
-          </a:xfrm>
-          <a:prstGeom prst="rect">
-            <a:avLst/>
-          </a:prstGeom>
-          <a:solidFill>
-            <a:srgbClr val="2E75B6"/>
-          </a:solidFill>
-          <a:ln>
-            <a:noFill/>
-          </a:ln>
-          <a:effectLst/>
-        </p:spPr>
-        <p:style>
-          <a:lnRef idx="1">
-            <a:schemeClr val="accent1"/>
-          </a:lnRef>
-          <a:fillRef idx="3">
-            <a:schemeClr val="accent1"/>
-          </a:fillRef>
-          <a:effectRef idx="2">
-            <a:schemeClr val="accent1"/>
-          </a:effectRef>
-          <a:fontRef idx="minor">
-            <a:schemeClr val="lt1"/>
-          </a:fontRef>
-        </p:style>
-        <p:txBody>
-          <a:bodyPr rtlCol="0" anchor="ctr"/>
-          <a:lstStyle/>
-          <a:p>
-            <a:pPr algn="ctr"/>
-          </a:p>
-        </p:txBody>
-      </p:sp>
-      <p:cxnSp>
-        <p:nvCxnSpPr>
-          <p:cNvPr id="21" name="Connector 20"/>
-          <p:cNvCxnSpPr/>
-          <p:nvPr/>
-        </p:nvCxnSpPr>
-        <p:spPr>
-          <a:xfrm>
-            <a:off x="1380103" y="1636775"/>
-            <a:ext cx="0" cy="237744"/>
-          </a:xfrm>
-          <a:prstGeom prst="line">
-            <a:avLst/>
-          </a:prstGeom>
-          <a:ln w="12700">
-            <a:solidFill>
-              <a:srgbClr val="8C9BB3"/>
-            </a:solidFill>
-            <a:headEnd type="triangle" w="sm" len="sm"/>
-            <a:tailEnd type="triangle" w="sm" len="sm"/>
-          </a:ln>
-        </p:spPr>
-        <p:style>
-          <a:lnRef idx="2">
-            <a:schemeClr val="accent1"/>
-          </a:lnRef>
-          <a:fillRef idx="0">
-            <a:schemeClr val="accent1"/>
-          </a:fillRef>
-          <a:effectRef idx="1">
-            <a:schemeClr val="accent1"/>
-          </a:effectRef>
-          <a:fontRef idx="minor">
-            <a:schemeClr val="tx1"/>
-          </a:fontRef>
-        </p:style>
-      </p:cxnSp>
-      <p:cxnSp>
-        <p:nvCxnSpPr>
-          <p:cNvPr id="22" name="Connector 21"/>
-          <p:cNvCxnSpPr/>
-          <p:nvPr/>
-        </p:nvCxnSpPr>
-        <p:spPr>
-          <a:xfrm>
-            <a:off x="3737975" y="1636775"/>
-            <a:ext cx="0" cy="237744"/>
-          </a:xfrm>
-          <a:prstGeom prst="line">
-            <a:avLst/>
-          </a:prstGeom>
-          <a:ln w="12700">
-            <a:solidFill>
-              <a:srgbClr val="8C9BB3"/>
-            </a:solidFill>
-            <a:headEnd type="triangle" w="sm" len="sm"/>
-            <a:tailEnd type="triangle" w="sm" len="sm"/>
-          </a:ln>
-        </p:spPr>
-        <p:style>
-          <a:lnRef idx="2">
-            <a:schemeClr val="accent1"/>
-          </a:lnRef>
-          <a:fillRef idx="0">
-            <a:schemeClr val="accent1"/>
-          </a:fillRef>
-          <a:effectRef idx="1">
-            <a:schemeClr val="accent1"/>
-          </a:effectRef>
-          <a:fontRef idx="minor">
-            <a:schemeClr val="tx1"/>
-          </a:fontRef>
-        </p:style>
-      </p:cxnSp>
-      <p:cxnSp>
-        <p:nvCxnSpPr>
-          <p:cNvPr id="23" name="Connector 22"/>
-          <p:cNvCxnSpPr/>
-          <p:nvPr/>
-        </p:nvCxnSpPr>
-        <p:spPr>
-          <a:xfrm>
-            <a:off x="6095847" y="1636775"/>
-            <a:ext cx="0" cy="237744"/>
-          </a:xfrm>
-          <a:prstGeom prst="line">
-            <a:avLst/>
-          </a:prstGeom>
-          <a:ln w="12700">
-            <a:solidFill>
-              <a:srgbClr val="8C9BB3"/>
-            </a:solidFill>
-            <a:headEnd type="triangle" w="sm" len="sm"/>
-            <a:tailEnd type="triangle" w="sm" len="sm"/>
-          </a:ln>
-        </p:spPr>
-        <p:style>
-          <a:lnRef idx="2">
-            <a:schemeClr val="accent1"/>
-          </a:lnRef>
-          <a:fillRef idx="0">
-            <a:schemeClr val="accent1"/>
-          </a:fillRef>
-          <a:effectRef idx="1">
-            <a:schemeClr val="accent1"/>
-          </a:effectRef>
-          <a:fontRef idx="minor">
-            <a:schemeClr val="tx1"/>
-          </a:fontRef>
-        </p:style>
-      </p:cxnSp>
-      <p:cxnSp>
-        <p:nvCxnSpPr>
-          <p:cNvPr id="24" name="Connector 23"/>
-          <p:cNvCxnSpPr/>
-          <p:nvPr/>
-        </p:nvCxnSpPr>
-        <p:spPr>
-          <a:xfrm>
-            <a:off x="8453719" y="1636775"/>
-            <a:ext cx="0" cy="237744"/>
-          </a:xfrm>
-          <a:prstGeom prst="line">
-            <a:avLst/>
-          </a:prstGeom>
-          <a:ln w="12700">
-            <a:solidFill>
-              <a:srgbClr val="8C9BB3"/>
-            </a:solidFill>
-            <a:headEnd type="triangle" w="sm" len="sm"/>
-            <a:tailEnd type="triangle" w="sm" len="sm"/>
-          </a:ln>
-        </p:spPr>
-        <p:style>
-          <a:lnRef idx="2">
-            <a:schemeClr val="accent1"/>
-          </a:lnRef>
-          <a:fillRef idx="0">
-            <a:schemeClr val="accent1"/>
-          </a:fillRef>
-          <a:effectRef idx="1">
-            <a:schemeClr val="accent1"/>
-          </a:effectRef>
-          <a:fontRef idx="minor">
-            <a:schemeClr val="tx1"/>
-          </a:fontRef>
-        </p:style>
-      </p:cxnSp>
-      <p:cxnSp>
-        <p:nvCxnSpPr>
-          <p:cNvPr id="25" name="Connector 24"/>
-          <p:cNvCxnSpPr/>
-          <p:nvPr/>
-        </p:nvCxnSpPr>
-        <p:spPr>
-          <a:xfrm>
-            <a:off x="10811591" y="1636775"/>
-            <a:ext cx="0" cy="237744"/>
-          </a:xfrm>
-          <a:prstGeom prst="line">
-            <a:avLst/>
-          </a:prstGeom>
-          <a:ln w="12700">
-            <a:solidFill>
-              <a:srgbClr val="8C9BB3"/>
-            </a:solidFill>
-            <a:headEnd type="triangle" w="sm" len="sm"/>
-            <a:tailEnd type="triangle" w="sm" len="sm"/>
-          </a:ln>
-        </p:spPr>
-        <p:style>
-          <a:lnRef idx="2">
-            <a:schemeClr val="accent1"/>
-          </a:lnRef>
-          <a:fillRef idx="0">
-            <a:schemeClr val="accent1"/>
-          </a:fillRef>
-          <a:effectRef idx="1">
-            <a:schemeClr val="accent1"/>
-          </a:effectRef>
-          <a:fontRef idx="minor">
-            <a:schemeClr val="tx1"/>
-          </a:fontRef>
-        </p:style>
-      </p:cxnSp>
-      <p:sp>
-        <p:nvSpPr>
-          <p:cNvPr id="26" name="TextBox 25"/>
-          <p:cNvSpPr txBox="1"/>
-          <p:nvPr/>
-        </p:nvSpPr>
-        <p:spPr>
-          <a:xfrm>
-            <a:off x="3185083" y="1627631"/>
-            <a:ext cx="5528919" cy="237744"/>
-          </a:xfrm>
-          <a:prstGeom prst="rect">
-            <a:avLst/>
-          </a:prstGeom>
-          <a:noFill/>
-        </p:spPr>
-        <p:txBody>
-          <a:bodyPr wrap="square" anchor="ctr" lIns="0" rIns="0" tIns="0" bIns="0">
-            <a:spAutoFit/>
-          </a:bodyPr>
-          <a:lstStyle/>
-          <a:p>
-            <a:pPr algn="ctr"/>
-            <a:r>
-              <a:rPr sz="900" b="0" i="0">
-                <a:solidFill>
-                  <a:srgbClr val="7A7A7A"/>
-                </a:solidFill>
-                <a:latin typeface="Microsoft YaHei"/>
-              </a:rPr>
-              <a:t>标准指令双向交互：下行指令 / 上行状态，统一经 WCS</a:t>
-            </a:r>
-          </a:p>
-        </p:txBody>
-      </p:sp>
-      <p:sp>
-        <p:nvSpPr>
-          <p:cNvPr id="27" name="TextBox 26"/>
-          <p:cNvSpPr txBox="1"/>
-          <p:nvPr/>
-        </p:nvSpPr>
-        <p:spPr>
-          <a:xfrm>
-            <a:off x="274320" y="1655063"/>
-            <a:ext cx="2377440" cy="201168"/>
-          </a:xfrm>
-          <a:prstGeom prst="rect">
-            <a:avLst/>
-          </a:prstGeom>
-          <a:noFill/>
-        </p:spPr>
-        <p:txBody>
-          <a:bodyPr wrap="square" anchor="t" lIns="0" rIns="0" tIns="0" bIns="0">
-            <a:spAutoFit/>
-          </a:bodyPr>
-          <a:lstStyle/>
-          <a:p>
-            <a:pPr algn="l"/>
-            <a:r>
-              <a:rPr sz="1000" b="0" i="0">
-                <a:solidFill>
-                  <a:srgbClr val="595959"/>
-                </a:solidFill>
-                <a:latin typeface="Microsoft YaHei"/>
-              </a:rPr>
-              <a:t>WCS 平台</a:t>
-            </a:r>
-          </a:p>
-        </p:txBody>
-      </p:sp>
-      <p:sp>
-        <p:nvSpPr>
-          <p:cNvPr id="28" name="Rounded Rectangle 27"/>
-          <p:cNvSpPr/>
-          <p:nvPr/>
-        </p:nvSpPr>
-        <p:spPr>
-          <a:xfrm>
-            <a:off x="274320" y="1874519"/>
-            <a:ext cx="11643055" cy="3246120"/>
-          </a:xfrm>
-          <a:prstGeom prst="roundRect">
-            <a:avLst>
-              <a:gd name="adj" fmla="val 2000"/>
             </a:avLst>
           </a:prstGeom>
           <a:solidFill>
@@ -4178,7 +3323,1205 @@
       </p:sp>
       <p:sp>
         <p:nvSpPr>
-          <p:cNvPr id="29" name="Rounded Rectangle 28"/>
+          <p:cNvPr id="8" name="Rounded Rectangle 7"/>
+          <p:cNvSpPr/>
+          <p:nvPr/>
+        </p:nvSpPr>
+        <p:spPr>
+          <a:xfrm>
+            <a:off x="373939" y="1143000"/>
+            <a:ext cx="1618820" cy="402335"/>
+          </a:xfrm>
+          <a:prstGeom prst="roundRect">
+            <a:avLst>
+              <a:gd name="adj" fmla="val 7000"/>
+            </a:avLst>
+          </a:prstGeom>
+          <a:solidFill>
+            <a:srgbClr val="FFFFFF"/>
+          </a:solidFill>
+          <a:ln w="12700">
+            <a:solidFill>
+              <a:srgbClr val="9FB7D4"/>
+            </a:solidFill>
+          </a:ln>
+          <a:effectLst/>
+        </p:spPr>
+        <p:style>
+          <a:lnRef idx="1">
+            <a:schemeClr val="accent1"/>
+          </a:lnRef>
+          <a:fillRef idx="3">
+            <a:schemeClr val="accent1"/>
+          </a:fillRef>
+          <a:effectRef idx="2">
+            <a:schemeClr val="accent1"/>
+          </a:effectRef>
+          <a:fontRef idx="minor">
+            <a:schemeClr val="lt1"/>
+          </a:fontRef>
+        </p:style>
+        <p:txBody>
+          <a:bodyPr rtlCol="0" anchor="ctr"/>
+          <a:lstStyle/>
+          <a:p>
+            <a:pPr algn="ctr"/>
+          </a:p>
+        </p:txBody>
+      </p:sp>
+      <p:sp>
+        <p:nvSpPr>
+          <p:cNvPr id="9" name="TextBox 8"/>
+          <p:cNvSpPr txBox="1"/>
+          <p:nvPr/>
+        </p:nvSpPr>
+        <p:spPr>
+          <a:xfrm>
+            <a:off x="373939" y="1179576"/>
+            <a:ext cx="1618820" cy="182880"/>
+          </a:xfrm>
+          <a:prstGeom prst="rect">
+            <a:avLst/>
+          </a:prstGeom>
+          <a:noFill/>
+        </p:spPr>
+        <p:txBody>
+          <a:bodyPr wrap="square" anchor="t" lIns="0" rIns="0" tIns="0" bIns="0">
+            <a:spAutoFit/>
+          </a:bodyPr>
+          <a:lstStyle/>
+          <a:p>
+            <a:pPr algn="ctr"/>
+            <a:r>
+              <a:rPr sz="1100" b="1" i="0">
+                <a:solidFill>
+                  <a:srgbClr val="1F4E79"/>
+                </a:solidFill>
+                <a:latin typeface="Microsoft YaHei"/>
+              </a:rPr>
+              <a:t>DC Flux WMS</a:t>
+            </a:r>
+          </a:p>
+        </p:txBody>
+      </p:sp>
+      <p:sp>
+        <p:nvSpPr>
+          <p:cNvPr id="10" name="Rectangle 9"/>
+          <p:cNvSpPr/>
+          <p:nvPr/>
+        </p:nvSpPr>
+        <p:spPr>
+          <a:xfrm>
+            <a:off x="665327" y="1367028"/>
+            <a:ext cx="1036045" cy="14630"/>
+          </a:xfrm>
+          <a:prstGeom prst="rect">
+            <a:avLst/>
+          </a:prstGeom>
+          <a:solidFill>
+            <a:srgbClr val="2E75B6"/>
+          </a:solidFill>
+          <a:ln>
+            <a:noFill/>
+          </a:ln>
+          <a:effectLst/>
+        </p:spPr>
+        <p:style>
+          <a:lnRef idx="1">
+            <a:schemeClr val="accent1"/>
+          </a:lnRef>
+          <a:fillRef idx="3">
+            <a:schemeClr val="accent1"/>
+          </a:fillRef>
+          <a:effectRef idx="2">
+            <a:schemeClr val="accent1"/>
+          </a:effectRef>
+          <a:fontRef idx="minor">
+            <a:schemeClr val="lt1"/>
+          </a:fontRef>
+        </p:style>
+        <p:txBody>
+          <a:bodyPr rtlCol="0" anchor="ctr"/>
+          <a:lstStyle/>
+          <a:p>
+            <a:pPr algn="ctr"/>
+          </a:p>
+        </p:txBody>
+      </p:sp>
+      <p:sp>
+        <p:nvSpPr>
+          <p:cNvPr id="11" name="TextBox 10"/>
+          <p:cNvSpPr txBox="1"/>
+          <p:nvPr/>
+        </p:nvSpPr>
+        <p:spPr>
+          <a:xfrm>
+            <a:off x="392227" y="1389888"/>
+            <a:ext cx="1582244" cy="155448"/>
+          </a:xfrm>
+          <a:prstGeom prst="rect">
+            <a:avLst/>
+          </a:prstGeom>
+          <a:noFill/>
+        </p:spPr>
+        <p:txBody>
+          <a:bodyPr wrap="square" anchor="t" lIns="0" rIns="0" tIns="0" bIns="0">
+            <a:spAutoFit/>
+          </a:bodyPr>
+          <a:lstStyle/>
+          <a:p>
+            <a:pPr algn="ctr"/>
+            <a:r>
+              <a:rPr sz="750" b="0" i="0">
+                <a:solidFill>
+                  <a:srgbClr val="7A7A7A"/>
+                </a:solidFill>
+                <a:latin typeface="Microsoft YaHei"/>
+              </a:rPr>
+              <a:t>DC</a:t>
+            </a:r>
+          </a:p>
+        </p:txBody>
+      </p:sp>
+      <p:sp>
+        <p:nvSpPr>
+          <p:cNvPr id="12" name="Rounded Rectangle 11"/>
+          <p:cNvSpPr/>
+          <p:nvPr/>
+        </p:nvSpPr>
+        <p:spPr>
+          <a:xfrm>
+            <a:off x="2055022" y="1143000"/>
+            <a:ext cx="1618820" cy="402335"/>
+          </a:xfrm>
+          <a:prstGeom prst="roundRect">
+            <a:avLst>
+              <a:gd name="adj" fmla="val 7000"/>
+            </a:avLst>
+          </a:prstGeom>
+          <a:solidFill>
+            <a:srgbClr val="FFFFFF"/>
+          </a:solidFill>
+          <a:ln w="12700">
+            <a:solidFill>
+              <a:srgbClr val="9FB7D4"/>
+            </a:solidFill>
+          </a:ln>
+          <a:effectLst/>
+        </p:spPr>
+        <p:style>
+          <a:lnRef idx="1">
+            <a:schemeClr val="accent1"/>
+          </a:lnRef>
+          <a:fillRef idx="3">
+            <a:schemeClr val="accent1"/>
+          </a:fillRef>
+          <a:effectRef idx="2">
+            <a:schemeClr val="accent1"/>
+          </a:effectRef>
+          <a:fontRef idx="minor">
+            <a:schemeClr val="lt1"/>
+          </a:fontRef>
+        </p:style>
+        <p:txBody>
+          <a:bodyPr rtlCol="0" anchor="ctr"/>
+          <a:lstStyle/>
+          <a:p>
+            <a:pPr algn="ctr"/>
+          </a:p>
+        </p:txBody>
+      </p:sp>
+      <p:sp>
+        <p:nvSpPr>
+          <p:cNvPr id="13" name="TextBox 12"/>
+          <p:cNvSpPr txBox="1"/>
+          <p:nvPr/>
+        </p:nvSpPr>
+        <p:spPr>
+          <a:xfrm>
+            <a:off x="2055022" y="1179576"/>
+            <a:ext cx="1618820" cy="182880"/>
+          </a:xfrm>
+          <a:prstGeom prst="rect">
+            <a:avLst/>
+          </a:prstGeom>
+          <a:noFill/>
+        </p:spPr>
+        <p:txBody>
+          <a:bodyPr wrap="square" anchor="t" lIns="0" rIns="0" tIns="0" bIns="0">
+            <a:spAutoFit/>
+          </a:bodyPr>
+          <a:lstStyle/>
+          <a:p>
+            <a:pPr algn="ctr"/>
+            <a:r>
+              <a:rPr sz="1100" b="1" i="0">
+                <a:solidFill>
+                  <a:srgbClr val="1F4E79"/>
+                </a:solidFill>
+                <a:latin typeface="Microsoft YaHei"/>
+              </a:rPr>
+              <a:t>FC Flux WMS</a:t>
+            </a:r>
+          </a:p>
+        </p:txBody>
+      </p:sp>
+      <p:sp>
+        <p:nvSpPr>
+          <p:cNvPr id="14" name="Rectangle 13"/>
+          <p:cNvSpPr/>
+          <p:nvPr/>
+        </p:nvSpPr>
+        <p:spPr>
+          <a:xfrm>
+            <a:off x="2346410" y="1367028"/>
+            <a:ext cx="1036045" cy="14630"/>
+          </a:xfrm>
+          <a:prstGeom prst="rect">
+            <a:avLst/>
+          </a:prstGeom>
+          <a:solidFill>
+            <a:srgbClr val="2E75B6"/>
+          </a:solidFill>
+          <a:ln>
+            <a:noFill/>
+          </a:ln>
+          <a:effectLst/>
+        </p:spPr>
+        <p:style>
+          <a:lnRef idx="1">
+            <a:schemeClr val="accent1"/>
+          </a:lnRef>
+          <a:fillRef idx="3">
+            <a:schemeClr val="accent1"/>
+          </a:fillRef>
+          <a:effectRef idx="2">
+            <a:schemeClr val="accent1"/>
+          </a:effectRef>
+          <a:fontRef idx="minor">
+            <a:schemeClr val="lt1"/>
+          </a:fontRef>
+        </p:style>
+        <p:txBody>
+          <a:bodyPr rtlCol="0" anchor="ctr"/>
+          <a:lstStyle/>
+          <a:p>
+            <a:pPr algn="ctr"/>
+          </a:p>
+        </p:txBody>
+      </p:sp>
+      <p:sp>
+        <p:nvSpPr>
+          <p:cNvPr id="15" name="TextBox 14"/>
+          <p:cNvSpPr txBox="1"/>
+          <p:nvPr/>
+        </p:nvSpPr>
+        <p:spPr>
+          <a:xfrm>
+            <a:off x="2073310" y="1389888"/>
+            <a:ext cx="1582244" cy="155448"/>
+          </a:xfrm>
+          <a:prstGeom prst="rect">
+            <a:avLst/>
+          </a:prstGeom>
+          <a:noFill/>
+        </p:spPr>
+        <p:txBody>
+          <a:bodyPr wrap="square" anchor="t" lIns="0" rIns="0" tIns="0" bIns="0">
+            <a:spAutoFit/>
+          </a:bodyPr>
+          <a:lstStyle/>
+          <a:p>
+            <a:pPr algn="ctr"/>
+            <a:r>
+              <a:rPr sz="750" b="0" i="0">
+                <a:solidFill>
+                  <a:srgbClr val="7A7A7A"/>
+                </a:solidFill>
+                <a:latin typeface="Microsoft YaHei"/>
+              </a:rPr>
+              <a:t>CDC</a:t>
+            </a:r>
+          </a:p>
+        </p:txBody>
+      </p:sp>
+      <p:sp>
+        <p:nvSpPr>
+          <p:cNvPr id="16" name="Rounded Rectangle 15"/>
+          <p:cNvSpPr/>
+          <p:nvPr/>
+        </p:nvSpPr>
+        <p:spPr>
+          <a:xfrm>
+            <a:off x="3736105" y="1143000"/>
+            <a:ext cx="2988591" cy="402335"/>
+          </a:xfrm>
+          <a:prstGeom prst="roundRect">
+            <a:avLst>
+              <a:gd name="adj" fmla="val 7000"/>
+            </a:avLst>
+          </a:prstGeom>
+          <a:solidFill>
+            <a:srgbClr val="FFFFFF"/>
+          </a:solidFill>
+          <a:ln w="12700">
+            <a:solidFill>
+              <a:srgbClr val="9FB7D4"/>
+            </a:solidFill>
+          </a:ln>
+          <a:effectLst/>
+        </p:spPr>
+        <p:style>
+          <a:lnRef idx="1">
+            <a:schemeClr val="accent1"/>
+          </a:lnRef>
+          <a:fillRef idx="3">
+            <a:schemeClr val="accent1"/>
+          </a:fillRef>
+          <a:effectRef idx="2">
+            <a:schemeClr val="accent1"/>
+          </a:effectRef>
+          <a:fontRef idx="minor">
+            <a:schemeClr val="lt1"/>
+          </a:fontRef>
+        </p:style>
+        <p:txBody>
+          <a:bodyPr rtlCol="0" anchor="ctr"/>
+          <a:lstStyle/>
+          <a:p>
+            <a:pPr algn="ctr"/>
+          </a:p>
+        </p:txBody>
+      </p:sp>
+      <p:sp>
+        <p:nvSpPr>
+          <p:cNvPr id="17" name="TextBox 16"/>
+          <p:cNvSpPr txBox="1"/>
+          <p:nvPr/>
+        </p:nvSpPr>
+        <p:spPr>
+          <a:xfrm>
+            <a:off x="3736105" y="1179576"/>
+            <a:ext cx="2988591" cy="182880"/>
+          </a:xfrm>
+          <a:prstGeom prst="rect">
+            <a:avLst/>
+          </a:prstGeom>
+          <a:noFill/>
+        </p:spPr>
+        <p:txBody>
+          <a:bodyPr wrap="square" anchor="t" lIns="0" rIns="0" tIns="0" bIns="0">
+            <a:spAutoFit/>
+          </a:bodyPr>
+          <a:lstStyle/>
+          <a:p>
+            <a:pPr algn="ctr"/>
+            <a:r>
+              <a:rPr sz="1200" b="1" i="0">
+                <a:solidFill>
+                  <a:srgbClr val="1F4E79"/>
+                </a:solidFill>
+                <a:latin typeface="Microsoft YaHei"/>
+              </a:rPr>
+              <a:t>City DC Flux WMS</a:t>
+            </a:r>
+          </a:p>
+        </p:txBody>
+      </p:sp>
+      <p:sp>
+        <p:nvSpPr>
+          <p:cNvPr id="18" name="Rectangle 17"/>
+          <p:cNvSpPr/>
+          <p:nvPr/>
+        </p:nvSpPr>
+        <p:spPr>
+          <a:xfrm>
+            <a:off x="4274051" y="1367028"/>
+            <a:ext cx="1912698" cy="14630"/>
+          </a:xfrm>
+          <a:prstGeom prst="rect">
+            <a:avLst/>
+          </a:prstGeom>
+          <a:solidFill>
+            <a:srgbClr val="2E75B6"/>
+          </a:solidFill>
+          <a:ln>
+            <a:noFill/>
+          </a:ln>
+          <a:effectLst/>
+        </p:spPr>
+        <p:style>
+          <a:lnRef idx="1">
+            <a:schemeClr val="accent1"/>
+          </a:lnRef>
+          <a:fillRef idx="3">
+            <a:schemeClr val="accent1"/>
+          </a:fillRef>
+          <a:effectRef idx="2">
+            <a:schemeClr val="accent1"/>
+          </a:effectRef>
+          <a:fontRef idx="minor">
+            <a:schemeClr val="lt1"/>
+          </a:fontRef>
+        </p:style>
+        <p:txBody>
+          <a:bodyPr rtlCol="0" anchor="ctr"/>
+          <a:lstStyle/>
+          <a:p>
+            <a:pPr algn="ctr"/>
+          </a:p>
+        </p:txBody>
+      </p:sp>
+      <p:sp>
+        <p:nvSpPr>
+          <p:cNvPr id="19" name="TextBox 18"/>
+          <p:cNvSpPr txBox="1"/>
+          <p:nvPr/>
+        </p:nvSpPr>
+        <p:spPr>
+          <a:xfrm>
+            <a:off x="3754393" y="1389888"/>
+            <a:ext cx="2952015" cy="155448"/>
+          </a:xfrm>
+          <a:prstGeom prst="rect">
+            <a:avLst/>
+          </a:prstGeom>
+          <a:noFill/>
+        </p:spPr>
+        <p:txBody>
+          <a:bodyPr wrap="square" anchor="t" lIns="0" rIns="0" tIns="0" bIns="0">
+            <a:spAutoFit/>
+          </a:bodyPr>
+          <a:lstStyle/>
+          <a:p>
+            <a:pPr algn="ctr"/>
+            <a:r>
+              <a:rPr sz="750" b="0" i="0">
+                <a:solidFill>
+                  <a:srgbClr val="7A7A7A"/>
+                </a:solidFill>
+                <a:latin typeface="Microsoft YaHei"/>
+              </a:rPr>
+              <a:t>FWDC / FC / CBEC</a:t>
+            </a:r>
+          </a:p>
+        </p:txBody>
+      </p:sp>
+      <p:sp>
+        <p:nvSpPr>
+          <p:cNvPr id="20" name="TextBox 19"/>
+          <p:cNvSpPr txBox="1"/>
+          <p:nvPr/>
+        </p:nvSpPr>
+        <p:spPr>
+          <a:xfrm>
+            <a:off x="7066749" y="877824"/>
+            <a:ext cx="2743200" cy="164592"/>
+          </a:xfrm>
+          <a:prstGeom prst="rect">
+            <a:avLst/>
+          </a:prstGeom>
+          <a:noFill/>
+        </p:spPr>
+        <p:txBody>
+          <a:bodyPr wrap="square" anchor="t" lIns="0" rIns="0" tIns="0" bIns="0">
+            <a:spAutoFit/>
+          </a:bodyPr>
+          <a:lstStyle/>
+          <a:p>
+            <a:pPr algn="l"/>
+            <a:r>
+              <a:rPr sz="900" b="1" i="0">
+                <a:solidFill>
+                  <a:srgbClr val="595959"/>
+                </a:solidFill>
+                <a:latin typeface="Microsoft YaHei"/>
+              </a:rPr>
+              <a:t>门店域 WMS</a:t>
+            </a:r>
+          </a:p>
+        </p:txBody>
+      </p:sp>
+      <p:sp>
+        <p:nvSpPr>
+          <p:cNvPr id="21" name="Rounded Rectangle 20"/>
+          <p:cNvSpPr/>
+          <p:nvPr/>
+        </p:nvSpPr>
+        <p:spPr>
+          <a:xfrm>
+            <a:off x="7048461" y="1078992"/>
+            <a:ext cx="4868913" cy="530352"/>
+          </a:xfrm>
+          <a:prstGeom prst="roundRect">
+            <a:avLst>
+              <a:gd name="adj" fmla="val 5000"/>
+            </a:avLst>
+          </a:prstGeom>
+          <a:solidFill>
+            <a:srgbClr val="FCFDFE"/>
+          </a:solidFill>
+          <a:ln w="12700">
+            <a:solidFill>
+              <a:srgbClr val="9FB7D4"/>
+            </a:solidFill>
+            <a:prstDash val="dash"/>
+          </a:ln>
+          <a:effectLst/>
+        </p:spPr>
+        <p:style>
+          <a:lnRef idx="1">
+            <a:schemeClr val="accent1"/>
+          </a:lnRef>
+          <a:fillRef idx="3">
+            <a:schemeClr val="accent1"/>
+          </a:fillRef>
+          <a:effectRef idx="2">
+            <a:schemeClr val="accent1"/>
+          </a:effectRef>
+          <a:fontRef idx="minor">
+            <a:schemeClr val="lt1"/>
+          </a:fontRef>
+        </p:style>
+        <p:txBody>
+          <a:bodyPr rtlCol="0" anchor="ctr"/>
+          <a:lstStyle/>
+          <a:p>
+            <a:pPr algn="ctr"/>
+          </a:p>
+        </p:txBody>
+      </p:sp>
+      <p:sp>
+        <p:nvSpPr>
+          <p:cNvPr id="22" name="Rounded Rectangle 21"/>
+          <p:cNvSpPr/>
+          <p:nvPr/>
+        </p:nvSpPr>
+        <p:spPr>
+          <a:xfrm>
+            <a:off x="7148080" y="1143000"/>
+            <a:ext cx="1618820" cy="402335"/>
+          </a:xfrm>
+          <a:prstGeom prst="roundRect">
+            <a:avLst>
+              <a:gd name="adj" fmla="val 7000"/>
+            </a:avLst>
+          </a:prstGeom>
+          <a:solidFill>
+            <a:srgbClr val="FFFFFF"/>
+          </a:solidFill>
+          <a:ln w="12700">
+            <a:solidFill>
+              <a:srgbClr val="9FB7D4"/>
+            </a:solidFill>
+          </a:ln>
+          <a:effectLst/>
+        </p:spPr>
+        <p:style>
+          <a:lnRef idx="1">
+            <a:schemeClr val="accent1"/>
+          </a:lnRef>
+          <a:fillRef idx="3">
+            <a:schemeClr val="accent1"/>
+          </a:fillRef>
+          <a:effectRef idx="2">
+            <a:schemeClr val="accent1"/>
+          </a:effectRef>
+          <a:fontRef idx="minor">
+            <a:schemeClr val="lt1"/>
+          </a:fontRef>
+        </p:style>
+        <p:txBody>
+          <a:bodyPr rtlCol="0" anchor="ctr"/>
+          <a:lstStyle/>
+          <a:p>
+            <a:pPr algn="ctr"/>
+          </a:p>
+        </p:txBody>
+      </p:sp>
+      <p:sp>
+        <p:nvSpPr>
+          <p:cNvPr id="23" name="TextBox 22"/>
+          <p:cNvSpPr txBox="1"/>
+          <p:nvPr/>
+        </p:nvSpPr>
+        <p:spPr>
+          <a:xfrm>
+            <a:off x="7148080" y="1179576"/>
+            <a:ext cx="1618820" cy="182880"/>
+          </a:xfrm>
+          <a:prstGeom prst="rect">
+            <a:avLst/>
+          </a:prstGeom>
+          <a:noFill/>
+        </p:spPr>
+        <p:txBody>
+          <a:bodyPr wrap="square" anchor="t" lIns="0" rIns="0" tIns="0" bIns="0">
+            <a:spAutoFit/>
+          </a:bodyPr>
+          <a:lstStyle/>
+          <a:p>
+            <a:pPr algn="ctr"/>
+            <a:r>
+              <a:rPr sz="1100" b="1" i="0">
+                <a:solidFill>
+                  <a:srgbClr val="1F4E79"/>
+                </a:solidFill>
+                <a:latin typeface="Microsoft YaHei"/>
+              </a:rPr>
+              <a:t>门店 WMS</a:t>
+            </a:r>
+          </a:p>
+        </p:txBody>
+      </p:sp>
+      <p:sp>
+        <p:nvSpPr>
+          <p:cNvPr id="24" name="Rectangle 23"/>
+          <p:cNvSpPr/>
+          <p:nvPr/>
+        </p:nvSpPr>
+        <p:spPr>
+          <a:xfrm>
+            <a:off x="7439468" y="1367028"/>
+            <a:ext cx="1036045" cy="14630"/>
+          </a:xfrm>
+          <a:prstGeom prst="rect">
+            <a:avLst/>
+          </a:prstGeom>
+          <a:solidFill>
+            <a:srgbClr val="2E75B6"/>
+          </a:solidFill>
+          <a:ln>
+            <a:noFill/>
+          </a:ln>
+          <a:effectLst/>
+        </p:spPr>
+        <p:style>
+          <a:lnRef idx="1">
+            <a:schemeClr val="accent1"/>
+          </a:lnRef>
+          <a:fillRef idx="3">
+            <a:schemeClr val="accent1"/>
+          </a:fillRef>
+          <a:effectRef idx="2">
+            <a:schemeClr val="accent1"/>
+          </a:effectRef>
+          <a:fontRef idx="minor">
+            <a:schemeClr val="lt1"/>
+          </a:fontRef>
+        </p:style>
+        <p:txBody>
+          <a:bodyPr rtlCol="0" anchor="ctr"/>
+          <a:lstStyle/>
+          <a:p>
+            <a:pPr algn="ctr"/>
+          </a:p>
+        </p:txBody>
+      </p:sp>
+      <p:sp>
+        <p:nvSpPr>
+          <p:cNvPr id="25" name="TextBox 24"/>
+          <p:cNvSpPr txBox="1"/>
+          <p:nvPr/>
+        </p:nvSpPr>
+        <p:spPr>
+          <a:xfrm>
+            <a:off x="7166368" y="1389888"/>
+            <a:ext cx="1582244" cy="155448"/>
+          </a:xfrm>
+          <a:prstGeom prst="rect">
+            <a:avLst/>
+          </a:prstGeom>
+          <a:noFill/>
+        </p:spPr>
+        <p:txBody>
+          <a:bodyPr wrap="square" anchor="t" lIns="0" rIns="0" tIns="0" bIns="0">
+            <a:spAutoFit/>
+          </a:bodyPr>
+          <a:lstStyle/>
+          <a:p>
+            <a:pPr algn="ctr"/>
+            <a:r>
+              <a:rPr sz="750" b="0" i="0">
+                <a:solidFill>
+                  <a:srgbClr val="7A7A7A"/>
+                </a:solidFill>
+                <a:latin typeface="Microsoft YaHei"/>
+              </a:rPr>
+              <a:t>门店</a:t>
+            </a:r>
+          </a:p>
+        </p:txBody>
+      </p:sp>
+      <p:sp>
+        <p:nvSpPr>
+          <p:cNvPr id="26" name="Rounded Rectangle 25"/>
+          <p:cNvSpPr/>
+          <p:nvPr/>
+        </p:nvSpPr>
+        <p:spPr>
+          <a:xfrm>
+            <a:off x="8829163" y="1143000"/>
+            <a:ext cx="2988591" cy="402335"/>
+          </a:xfrm>
+          <a:prstGeom prst="roundRect">
+            <a:avLst>
+              <a:gd name="adj" fmla="val 7000"/>
+            </a:avLst>
+          </a:prstGeom>
+          <a:solidFill>
+            <a:srgbClr val="FFFFFF"/>
+          </a:solidFill>
+          <a:ln w="12700">
+            <a:solidFill>
+              <a:srgbClr val="9FB7D4"/>
+            </a:solidFill>
+          </a:ln>
+          <a:effectLst/>
+        </p:spPr>
+        <p:style>
+          <a:lnRef idx="1">
+            <a:schemeClr val="accent1"/>
+          </a:lnRef>
+          <a:fillRef idx="3">
+            <a:schemeClr val="accent1"/>
+          </a:fillRef>
+          <a:effectRef idx="2">
+            <a:schemeClr val="accent1"/>
+          </a:effectRef>
+          <a:fontRef idx="minor">
+            <a:schemeClr val="lt1"/>
+          </a:fontRef>
+        </p:style>
+        <p:txBody>
+          <a:bodyPr rtlCol="0" anchor="ctr"/>
+          <a:lstStyle/>
+          <a:p>
+            <a:pPr algn="ctr"/>
+          </a:p>
+        </p:txBody>
+      </p:sp>
+      <p:sp>
+        <p:nvSpPr>
+          <p:cNvPr id="27" name="TextBox 26"/>
+          <p:cNvSpPr txBox="1"/>
+          <p:nvPr/>
+        </p:nvSpPr>
+        <p:spPr>
+          <a:xfrm>
+            <a:off x="8829163" y="1179576"/>
+            <a:ext cx="2988591" cy="182880"/>
+          </a:xfrm>
+          <a:prstGeom prst="rect">
+            <a:avLst/>
+          </a:prstGeom>
+          <a:noFill/>
+        </p:spPr>
+        <p:txBody>
+          <a:bodyPr wrap="square" anchor="t" lIns="0" rIns="0" tIns="0" bIns="0">
+            <a:spAutoFit/>
+          </a:bodyPr>
+          <a:lstStyle/>
+          <a:p>
+            <a:pPr algn="ctr"/>
+            <a:r>
+              <a:rPr sz="1200" b="1" i="0">
+                <a:solidFill>
+                  <a:srgbClr val="1F4E79"/>
+                </a:solidFill>
+                <a:latin typeface="Microsoft YaHei"/>
+              </a:rPr>
+              <a:t>云仓 WMS</a:t>
+            </a:r>
+          </a:p>
+        </p:txBody>
+      </p:sp>
+      <p:sp>
+        <p:nvSpPr>
+          <p:cNvPr id="28" name="Rectangle 27"/>
+          <p:cNvSpPr/>
+          <p:nvPr/>
+        </p:nvSpPr>
+        <p:spPr>
+          <a:xfrm>
+            <a:off x="9367110" y="1367028"/>
+            <a:ext cx="1912698" cy="14630"/>
+          </a:xfrm>
+          <a:prstGeom prst="rect">
+            <a:avLst/>
+          </a:prstGeom>
+          <a:solidFill>
+            <a:srgbClr val="2E75B6"/>
+          </a:solidFill>
+          <a:ln>
+            <a:noFill/>
+          </a:ln>
+          <a:effectLst/>
+        </p:spPr>
+        <p:style>
+          <a:lnRef idx="1">
+            <a:schemeClr val="accent1"/>
+          </a:lnRef>
+          <a:fillRef idx="3">
+            <a:schemeClr val="accent1"/>
+          </a:fillRef>
+          <a:effectRef idx="2">
+            <a:schemeClr val="accent1"/>
+          </a:effectRef>
+          <a:fontRef idx="minor">
+            <a:schemeClr val="lt1"/>
+          </a:fontRef>
+        </p:style>
+        <p:txBody>
+          <a:bodyPr rtlCol="0" anchor="ctr"/>
+          <a:lstStyle/>
+          <a:p>
+            <a:pPr algn="ctr"/>
+          </a:p>
+        </p:txBody>
+      </p:sp>
+      <p:sp>
+        <p:nvSpPr>
+          <p:cNvPr id="29" name="TextBox 28"/>
+          <p:cNvSpPr txBox="1"/>
+          <p:nvPr/>
+        </p:nvSpPr>
+        <p:spPr>
+          <a:xfrm>
+            <a:off x="8847451" y="1389888"/>
+            <a:ext cx="2952015" cy="155448"/>
+          </a:xfrm>
+          <a:prstGeom prst="rect">
+            <a:avLst/>
+          </a:prstGeom>
+          <a:noFill/>
+        </p:spPr>
+        <p:txBody>
+          <a:bodyPr wrap="square" anchor="t" lIns="0" rIns="0" tIns="0" bIns="0">
+            <a:spAutoFit/>
+          </a:bodyPr>
+          <a:lstStyle/>
+          <a:p>
+            <a:pPr algn="ctr"/>
+            <a:r>
+              <a:rPr sz="750" b="0" i="0">
+                <a:solidFill>
+                  <a:srgbClr val="7A7A7A"/>
+                </a:solidFill>
+                <a:latin typeface="Microsoft YaHei"/>
+              </a:rPr>
+              <a:t>云仓 / 社区店 / Darkstore</a:t>
+            </a:r>
+          </a:p>
+        </p:txBody>
+      </p:sp>
+      <p:cxnSp>
+        <p:nvCxnSpPr>
+          <p:cNvPr id="30" name="Connector 29"/>
+          <p:cNvCxnSpPr/>
+          <p:nvPr/>
+        </p:nvCxnSpPr>
+        <p:spPr>
+          <a:xfrm>
+            <a:off x="1183349" y="1636775"/>
+            <a:ext cx="0" cy="237744"/>
+          </a:xfrm>
+          <a:prstGeom prst="line">
+            <a:avLst/>
+          </a:prstGeom>
+          <a:ln w="12700">
+            <a:solidFill>
+              <a:srgbClr val="8C9BB3"/>
+            </a:solidFill>
+            <a:headEnd type="triangle" w="sm" len="sm"/>
+            <a:tailEnd type="triangle" w="sm" len="sm"/>
+          </a:ln>
+        </p:spPr>
+        <p:style>
+          <a:lnRef idx="2">
+            <a:schemeClr val="accent1"/>
+          </a:lnRef>
+          <a:fillRef idx="0">
+            <a:schemeClr val="accent1"/>
+          </a:fillRef>
+          <a:effectRef idx="1">
+            <a:schemeClr val="accent1"/>
+          </a:effectRef>
+          <a:fontRef idx="minor">
+            <a:schemeClr val="tx1"/>
+          </a:fontRef>
+        </p:style>
+      </p:cxnSp>
+      <p:cxnSp>
+        <p:nvCxnSpPr>
+          <p:cNvPr id="31" name="Connector 30"/>
+          <p:cNvCxnSpPr/>
+          <p:nvPr/>
+        </p:nvCxnSpPr>
+        <p:spPr>
+          <a:xfrm>
+            <a:off x="2864432" y="1636775"/>
+            <a:ext cx="0" cy="237744"/>
+          </a:xfrm>
+          <a:prstGeom prst="line">
+            <a:avLst/>
+          </a:prstGeom>
+          <a:ln w="12700">
+            <a:solidFill>
+              <a:srgbClr val="8C9BB3"/>
+            </a:solidFill>
+            <a:headEnd type="triangle" w="sm" len="sm"/>
+            <a:tailEnd type="triangle" w="sm" len="sm"/>
+          </a:ln>
+        </p:spPr>
+        <p:style>
+          <a:lnRef idx="2">
+            <a:schemeClr val="accent1"/>
+          </a:lnRef>
+          <a:fillRef idx="0">
+            <a:schemeClr val="accent1"/>
+          </a:fillRef>
+          <a:effectRef idx="1">
+            <a:schemeClr val="accent1"/>
+          </a:effectRef>
+          <a:fontRef idx="minor">
+            <a:schemeClr val="tx1"/>
+          </a:fontRef>
+        </p:style>
+      </p:cxnSp>
+      <p:cxnSp>
+        <p:nvCxnSpPr>
+          <p:cNvPr id="32" name="Connector 31"/>
+          <p:cNvCxnSpPr/>
+          <p:nvPr/>
+        </p:nvCxnSpPr>
+        <p:spPr>
+          <a:xfrm>
+            <a:off x="5230401" y="1636775"/>
+            <a:ext cx="0" cy="237744"/>
+          </a:xfrm>
+          <a:prstGeom prst="line">
+            <a:avLst/>
+          </a:prstGeom>
+          <a:ln w="12700">
+            <a:solidFill>
+              <a:srgbClr val="8C9BB3"/>
+            </a:solidFill>
+            <a:headEnd type="triangle" w="sm" len="sm"/>
+            <a:tailEnd type="triangle" w="sm" len="sm"/>
+          </a:ln>
+        </p:spPr>
+        <p:style>
+          <a:lnRef idx="2">
+            <a:schemeClr val="accent1"/>
+          </a:lnRef>
+          <a:fillRef idx="0">
+            <a:schemeClr val="accent1"/>
+          </a:fillRef>
+          <a:effectRef idx="1">
+            <a:schemeClr val="accent1"/>
+          </a:effectRef>
+          <a:fontRef idx="minor">
+            <a:schemeClr val="tx1"/>
+          </a:fontRef>
+        </p:style>
+      </p:cxnSp>
+      <p:cxnSp>
+        <p:nvCxnSpPr>
+          <p:cNvPr id="33" name="Connector 32"/>
+          <p:cNvCxnSpPr/>
+          <p:nvPr/>
+        </p:nvCxnSpPr>
+        <p:spPr>
+          <a:xfrm>
+            <a:off x="7957491" y="1636775"/>
+            <a:ext cx="0" cy="237744"/>
+          </a:xfrm>
+          <a:prstGeom prst="line">
+            <a:avLst/>
+          </a:prstGeom>
+          <a:ln w="12700">
+            <a:solidFill>
+              <a:srgbClr val="8C9BB3"/>
+            </a:solidFill>
+            <a:headEnd type="triangle" w="sm" len="sm"/>
+            <a:tailEnd type="triangle" w="sm" len="sm"/>
+          </a:ln>
+        </p:spPr>
+        <p:style>
+          <a:lnRef idx="2">
+            <a:schemeClr val="accent1"/>
+          </a:lnRef>
+          <a:fillRef idx="0">
+            <a:schemeClr val="accent1"/>
+          </a:fillRef>
+          <a:effectRef idx="1">
+            <a:schemeClr val="accent1"/>
+          </a:effectRef>
+          <a:fontRef idx="minor">
+            <a:schemeClr val="tx1"/>
+          </a:fontRef>
+        </p:style>
+      </p:cxnSp>
+      <p:cxnSp>
+        <p:nvCxnSpPr>
+          <p:cNvPr id="34" name="Connector 33"/>
+          <p:cNvCxnSpPr/>
+          <p:nvPr/>
+        </p:nvCxnSpPr>
+        <p:spPr>
+          <a:xfrm>
+            <a:off x="10323459" y="1636775"/>
+            <a:ext cx="0" cy="237744"/>
+          </a:xfrm>
+          <a:prstGeom prst="line">
+            <a:avLst/>
+          </a:prstGeom>
+          <a:ln w="12700">
+            <a:solidFill>
+              <a:srgbClr val="8C9BB3"/>
+            </a:solidFill>
+            <a:headEnd type="triangle" w="sm" len="sm"/>
+            <a:tailEnd type="triangle" w="sm" len="sm"/>
+          </a:ln>
+        </p:spPr>
+        <p:style>
+          <a:lnRef idx="2">
+            <a:schemeClr val="accent1"/>
+          </a:lnRef>
+          <a:fillRef idx="0">
+            <a:schemeClr val="accent1"/>
+          </a:fillRef>
+          <a:effectRef idx="1">
+            <a:schemeClr val="accent1"/>
+          </a:effectRef>
+          <a:fontRef idx="minor">
+            <a:schemeClr val="tx1"/>
+          </a:fontRef>
+        </p:style>
+      </p:cxnSp>
+      <p:sp>
+        <p:nvSpPr>
+          <p:cNvPr id="35" name="TextBox 34"/>
+          <p:cNvSpPr txBox="1"/>
+          <p:nvPr/>
+        </p:nvSpPr>
+        <p:spPr>
+          <a:xfrm>
+            <a:off x="3767236" y="1627631"/>
+            <a:ext cx="4657222" cy="237744"/>
+          </a:xfrm>
+          <a:prstGeom prst="rect">
+            <a:avLst/>
+          </a:prstGeom>
+          <a:noFill/>
+        </p:spPr>
+        <p:txBody>
+          <a:bodyPr wrap="square" anchor="ctr" lIns="0" rIns="0" tIns="0" bIns="0">
+            <a:spAutoFit/>
+          </a:bodyPr>
+          <a:lstStyle/>
+          <a:p>
+            <a:pPr algn="ctr"/>
+            <a:r>
+              <a:rPr sz="900" b="0" i="0">
+                <a:solidFill>
+                  <a:srgbClr val="7A7A7A"/>
+                </a:solidFill>
+                <a:latin typeface="Microsoft YaHei"/>
+              </a:rPr>
+              <a:t>标准指令双向交互：下行指令 / 上行状态，统一经 WCS</a:t>
+            </a:r>
+          </a:p>
+        </p:txBody>
+      </p:sp>
+      <p:sp>
+        <p:nvSpPr>
+          <p:cNvPr id="36" name="TextBox 35"/>
+          <p:cNvSpPr txBox="1"/>
+          <p:nvPr/>
+        </p:nvSpPr>
+        <p:spPr>
+          <a:xfrm>
+            <a:off x="274320" y="1655063"/>
+            <a:ext cx="2377440" cy="201168"/>
+          </a:xfrm>
+          <a:prstGeom prst="rect">
+            <a:avLst/>
+          </a:prstGeom>
+          <a:noFill/>
+        </p:spPr>
+        <p:txBody>
+          <a:bodyPr wrap="square" anchor="t" lIns="0" rIns="0" tIns="0" bIns="0">
+            <a:spAutoFit/>
+          </a:bodyPr>
+          <a:lstStyle/>
+          <a:p>
+            <a:pPr algn="l"/>
+            <a:r>
+              <a:rPr sz="1000" b="0" i="0">
+                <a:solidFill>
+                  <a:srgbClr val="595959"/>
+                </a:solidFill>
+                <a:latin typeface="Microsoft YaHei"/>
+              </a:rPr>
+              <a:t>WCS 平台</a:t>
+            </a:r>
+          </a:p>
+        </p:txBody>
+      </p:sp>
+      <p:sp>
+        <p:nvSpPr>
+          <p:cNvPr id="37" name="Rounded Rectangle 36"/>
+          <p:cNvSpPr/>
+          <p:nvPr/>
+        </p:nvSpPr>
+        <p:spPr>
+          <a:xfrm>
+            <a:off x="274320" y="1874519"/>
+            <a:ext cx="11643055" cy="3246120"/>
+          </a:xfrm>
+          <a:prstGeom prst="roundRect">
+            <a:avLst>
+              <a:gd name="adj" fmla="val 2000"/>
+            </a:avLst>
+          </a:prstGeom>
+          <a:solidFill>
+            <a:srgbClr val="FCFDFE"/>
+          </a:solidFill>
+          <a:ln w="12700">
+            <a:solidFill>
+              <a:srgbClr val="9FB7D4"/>
+            </a:solidFill>
+            <a:prstDash val="dash"/>
+          </a:ln>
+          <a:effectLst/>
+        </p:spPr>
+        <p:style>
+          <a:lnRef idx="1">
+            <a:schemeClr val="accent1"/>
+          </a:lnRef>
+          <a:fillRef idx="3">
+            <a:schemeClr val="accent1"/>
+          </a:fillRef>
+          <a:effectRef idx="2">
+            <a:schemeClr val="accent1"/>
+          </a:effectRef>
+          <a:fontRef idx="minor">
+            <a:schemeClr val="lt1"/>
+          </a:fontRef>
+        </p:style>
+        <p:txBody>
+          <a:bodyPr rtlCol="0" anchor="ctr"/>
+          <a:lstStyle/>
+          <a:p>
+            <a:pPr algn="ctr"/>
+          </a:p>
+        </p:txBody>
+      </p:sp>
+      <p:sp>
+        <p:nvSpPr>
+          <p:cNvPr id="38" name="Rounded Rectangle 37"/>
           <p:cNvSpPr/>
           <p:nvPr/>
         </p:nvSpPr>
@@ -4245,7 +4588,7 @@
       </p:sp>
       <p:sp>
         <p:nvSpPr>
-          <p:cNvPr id="30" name="TextBox 29"/>
+          <p:cNvPr id="39" name="TextBox 38"/>
           <p:cNvSpPr txBox="1"/>
           <p:nvPr/>
         </p:nvSpPr>
@@ -4280,7 +4623,7 @@
       </p:sp>
       <p:sp>
         <p:nvSpPr>
-          <p:cNvPr id="31" name="TextBox 30"/>
+          <p:cNvPr id="40" name="TextBox 39"/>
           <p:cNvSpPr txBox="1"/>
           <p:nvPr/>
         </p:nvSpPr>
@@ -4315,7 +4658,7 @@
       </p:sp>
       <p:sp>
         <p:nvSpPr>
-          <p:cNvPr id="32" name="Rounded Rectangle 31"/>
+          <p:cNvPr id="41" name="Rounded Rectangle 40"/>
           <p:cNvSpPr/>
           <p:nvPr/>
         </p:nvSpPr>
@@ -4384,7 +4727,7 @@
       </p:sp>
       <p:sp>
         <p:nvSpPr>
-          <p:cNvPr id="33" name="Rounded Rectangle 32"/>
+          <p:cNvPr id="42" name="Rounded Rectangle 41"/>
           <p:cNvSpPr/>
           <p:nvPr/>
         </p:nvSpPr>
@@ -4453,7 +4796,7 @@
       </p:sp>
       <p:sp>
         <p:nvSpPr>
-          <p:cNvPr id="34" name="Rounded Rectangle 33"/>
+          <p:cNvPr id="43" name="Rounded Rectangle 42"/>
           <p:cNvSpPr/>
           <p:nvPr/>
         </p:nvSpPr>
@@ -4522,7 +4865,7 @@
       </p:sp>
       <p:sp>
         <p:nvSpPr>
-          <p:cNvPr id="35" name="Rounded Rectangle 34"/>
+          <p:cNvPr id="44" name="Rounded Rectangle 43"/>
           <p:cNvSpPr/>
           <p:nvPr/>
         </p:nvSpPr>
@@ -4591,7 +4934,7 @@
       </p:sp>
       <p:sp>
         <p:nvSpPr>
-          <p:cNvPr id="36" name="Rounded Rectangle 35"/>
+          <p:cNvPr id="45" name="Rounded Rectangle 44"/>
           <p:cNvSpPr/>
           <p:nvPr/>
         </p:nvSpPr>
@@ -4660,7 +5003,7 @@
       </p:sp>
       <p:sp>
         <p:nvSpPr>
-          <p:cNvPr id="37" name="Rounded Rectangle 36"/>
+          <p:cNvPr id="46" name="Rounded Rectangle 45"/>
           <p:cNvSpPr/>
           <p:nvPr/>
         </p:nvSpPr>
@@ -4729,7 +5072,7 @@
       </p:sp>
       <p:sp>
         <p:nvSpPr>
-          <p:cNvPr id="38" name="TextBox 37"/>
+          <p:cNvPr id="47" name="TextBox 46"/>
           <p:cNvSpPr txBox="1"/>
           <p:nvPr/>
         </p:nvSpPr>
@@ -4764,7 +5107,7 @@
       </p:sp>
       <p:sp>
         <p:nvSpPr>
-          <p:cNvPr id="39" name="TextBox 38"/>
+          <p:cNvPr id="48" name="TextBox 47"/>
           <p:cNvSpPr txBox="1"/>
           <p:nvPr/>
         </p:nvSpPr>
@@ -4799,7 +5142,7 @@
       </p:sp>
       <p:sp>
         <p:nvSpPr>
-          <p:cNvPr id="40" name="Rounded Rectangle 39"/>
+          <p:cNvPr id="49" name="Rounded Rectangle 48"/>
           <p:cNvSpPr/>
           <p:nvPr/>
         </p:nvSpPr>
@@ -4868,7 +5211,7 @@
       </p:sp>
       <p:sp>
         <p:nvSpPr>
-          <p:cNvPr id="41" name="Rounded Rectangle 40"/>
+          <p:cNvPr id="50" name="Rounded Rectangle 49"/>
           <p:cNvSpPr/>
           <p:nvPr/>
         </p:nvSpPr>
@@ -4937,7 +5280,7 @@
       </p:sp>
       <p:sp>
         <p:nvSpPr>
-          <p:cNvPr id="42" name="Rounded Rectangle 41"/>
+          <p:cNvPr id="51" name="Rounded Rectangle 50"/>
           <p:cNvSpPr/>
           <p:nvPr/>
         </p:nvSpPr>
@@ -5006,7 +5349,7 @@
       </p:sp>
       <p:sp>
         <p:nvSpPr>
-          <p:cNvPr id="43" name="Rounded Rectangle 42"/>
+          <p:cNvPr id="52" name="Rounded Rectangle 51"/>
           <p:cNvSpPr/>
           <p:nvPr/>
         </p:nvSpPr>
@@ -5075,7 +5418,7 @@
       </p:sp>
       <p:sp>
         <p:nvSpPr>
-          <p:cNvPr id="44" name="Rounded Rectangle 43"/>
+          <p:cNvPr id="53" name="Rounded Rectangle 52"/>
           <p:cNvSpPr/>
           <p:nvPr/>
         </p:nvSpPr>
@@ -5144,7 +5487,7 @@
       </p:sp>
       <p:sp>
         <p:nvSpPr>
-          <p:cNvPr id="45" name="Rounded Rectangle 44"/>
+          <p:cNvPr id="54" name="Rounded Rectangle 53"/>
           <p:cNvSpPr/>
           <p:nvPr/>
         </p:nvSpPr>
@@ -5213,7 +5556,7 @@
       </p:sp>
       <p:sp>
         <p:nvSpPr>
-          <p:cNvPr id="46" name="Rounded Rectangle 45"/>
+          <p:cNvPr id="55" name="Rounded Rectangle 54"/>
           <p:cNvSpPr/>
           <p:nvPr/>
         </p:nvSpPr>
@@ -5282,7 +5625,7 @@
       </p:sp>
       <p:sp>
         <p:nvSpPr>
-          <p:cNvPr id="47" name="Rounded Rectangle 46"/>
+          <p:cNvPr id="56" name="Rounded Rectangle 55"/>
           <p:cNvSpPr/>
           <p:nvPr/>
         </p:nvSpPr>
@@ -5351,7 +5694,7 @@
       </p:sp>
       <p:sp>
         <p:nvSpPr>
-          <p:cNvPr id="48" name="Rounded Rectangle 47"/>
+          <p:cNvPr id="57" name="Rounded Rectangle 56"/>
           <p:cNvSpPr/>
           <p:nvPr/>
         </p:nvSpPr>
@@ -5420,7 +5763,7 @@
       </p:sp>
       <p:sp>
         <p:nvSpPr>
-          <p:cNvPr id="49" name="Rounded Rectangle 48"/>
+          <p:cNvPr id="58" name="Rounded Rectangle 57"/>
           <p:cNvSpPr/>
           <p:nvPr/>
         </p:nvSpPr>
@@ -5489,7 +5832,7 @@
       </p:sp>
       <p:sp>
         <p:nvSpPr>
-          <p:cNvPr id="50" name="Rounded Rectangle 49"/>
+          <p:cNvPr id="59" name="Rounded Rectangle 58"/>
           <p:cNvSpPr/>
           <p:nvPr/>
         </p:nvSpPr>
@@ -5558,7 +5901,7 @@
       </p:sp>
       <p:sp>
         <p:nvSpPr>
-          <p:cNvPr id="51" name="Rounded Rectangle 50"/>
+          <p:cNvPr id="60" name="Rounded Rectangle 59"/>
           <p:cNvSpPr/>
           <p:nvPr/>
         </p:nvSpPr>
@@ -5627,7 +5970,7 @@
       </p:sp>
       <p:sp>
         <p:nvSpPr>
-          <p:cNvPr id="52" name="TextBox 51"/>
+          <p:cNvPr id="61" name="TextBox 60"/>
           <p:cNvSpPr txBox="1"/>
           <p:nvPr/>
         </p:nvSpPr>
@@ -5662,7 +6005,7 @@
       </p:sp>
       <p:sp>
         <p:nvSpPr>
-          <p:cNvPr id="53" name="TextBox 52"/>
+          <p:cNvPr id="62" name="TextBox 61"/>
           <p:cNvSpPr txBox="1"/>
           <p:nvPr/>
         </p:nvSpPr>
@@ -5697,7 +6040,7 @@
       </p:sp>
       <p:sp>
         <p:nvSpPr>
-          <p:cNvPr id="54" name="Rounded Rectangle 53"/>
+          <p:cNvPr id="63" name="Rounded Rectangle 62"/>
           <p:cNvSpPr/>
           <p:nvPr/>
         </p:nvSpPr>
@@ -5766,7 +6109,7 @@
       </p:sp>
       <p:sp>
         <p:nvSpPr>
-          <p:cNvPr id="55" name="Rounded Rectangle 54"/>
+          <p:cNvPr id="64" name="Rounded Rectangle 63"/>
           <p:cNvSpPr/>
           <p:nvPr/>
         </p:nvSpPr>
@@ -5835,7 +6178,7 @@
       </p:sp>
       <p:sp>
         <p:nvSpPr>
-          <p:cNvPr id="56" name="Rounded Rectangle 55"/>
+          <p:cNvPr id="65" name="Rounded Rectangle 64"/>
           <p:cNvSpPr/>
           <p:nvPr/>
         </p:nvSpPr>
@@ -5904,7 +6247,7 @@
       </p:sp>
       <p:sp>
         <p:nvSpPr>
-          <p:cNvPr id="57" name="Rounded Rectangle 56"/>
+          <p:cNvPr id="66" name="Rounded Rectangle 65"/>
           <p:cNvSpPr/>
           <p:nvPr/>
         </p:nvSpPr>
@@ -5973,7 +6316,7 @@
       </p:sp>
       <p:sp>
         <p:nvSpPr>
-          <p:cNvPr id="58" name="Rounded Rectangle 57"/>
+          <p:cNvPr id="67" name="Rounded Rectangle 66"/>
           <p:cNvSpPr/>
           <p:nvPr/>
         </p:nvSpPr>
@@ -6042,7 +6385,7 @@
       </p:sp>
       <p:sp>
         <p:nvSpPr>
-          <p:cNvPr id="59" name="Rounded Rectangle 58"/>
+          <p:cNvPr id="68" name="Rounded Rectangle 67"/>
           <p:cNvSpPr/>
           <p:nvPr/>
         </p:nvSpPr>
@@ -6111,7 +6454,7 @@
       </p:sp>
       <p:sp>
         <p:nvSpPr>
-          <p:cNvPr id="60" name="TextBox 59"/>
+          <p:cNvPr id="69" name="TextBox 68"/>
           <p:cNvSpPr txBox="1"/>
           <p:nvPr/>
         </p:nvSpPr>
@@ -6146,7 +6489,7 @@
       </p:sp>
       <p:sp>
         <p:nvSpPr>
-          <p:cNvPr id="61" name="Rounded Rectangle 60"/>
+          <p:cNvPr id="70" name="Rounded Rectangle 69"/>
           <p:cNvSpPr/>
           <p:nvPr/>
         </p:nvSpPr>
@@ -6195,7 +6538,7 @@
       </p:sp>
       <p:sp>
         <p:nvSpPr>
-          <p:cNvPr id="62" name="TextBox 61"/>
+          <p:cNvPr id="71" name="TextBox 70"/>
           <p:cNvSpPr txBox="1"/>
           <p:nvPr/>
         </p:nvSpPr>
@@ -6230,14 +6573,14 @@
       </p:sp>
       <p:sp>
         <p:nvSpPr>
-          <p:cNvPr id="63" name="TextBox 62"/>
+          <p:cNvPr id="72" name="TextBox 71"/>
           <p:cNvSpPr txBox="1"/>
           <p:nvPr/>
         </p:nvSpPr>
         <p:spPr>
           <a:xfrm>
             <a:off x="9823156" y="2414015"/>
-            <a:ext cx="2112506" cy="278617"/>
+            <a:ext cx="2112506" cy="232181"/>
           </a:xfrm>
           <a:prstGeom prst="rect">
             <a:avLst/>
@@ -6265,14 +6608,14 @@
       </p:sp>
       <p:sp>
         <p:nvSpPr>
-          <p:cNvPr id="64" name="TextBox 63"/>
+          <p:cNvPr id="73" name="TextBox 72"/>
           <p:cNvSpPr txBox="1"/>
           <p:nvPr/>
         </p:nvSpPr>
         <p:spPr>
           <a:xfrm>
-            <a:off x="9823156" y="2667304"/>
-            <a:ext cx="2112506" cy="227959"/>
+            <a:off x="9823156" y="2625090"/>
+            <a:ext cx="2112506" cy="189966"/>
           </a:xfrm>
           <a:prstGeom prst="rect">
             <a:avLst/>
@@ -6300,13 +6643,13 @@
       </p:sp>
       <p:sp>
         <p:nvSpPr>
-          <p:cNvPr id="65" name="Rectangle 64"/>
+          <p:cNvPr id="74" name="Rectangle 73"/>
           <p:cNvSpPr/>
           <p:nvPr/>
         </p:nvSpPr>
         <p:spPr>
           <a:xfrm>
-            <a:off x="9804868" y="2902305"/>
+            <a:off x="9804868" y="2817876"/>
             <a:ext cx="2130794" cy="10972"/>
           </a:xfrm>
           <a:prstGeom prst="rect">
@@ -6344,14 +6687,14 @@
       </p:sp>
       <p:sp>
         <p:nvSpPr>
-          <p:cNvPr id="66" name="TextBox 65"/>
+          <p:cNvPr id="75" name="TextBox 74"/>
           <p:cNvSpPr txBox="1"/>
           <p:nvPr/>
         </p:nvSpPr>
         <p:spPr>
           <a:xfrm>
-            <a:off x="9823156" y="2920593"/>
-            <a:ext cx="2112506" cy="278617"/>
+            <a:off x="9823156" y="2836164"/>
+            <a:ext cx="2112506" cy="232181"/>
           </a:xfrm>
           <a:prstGeom prst="rect">
             <a:avLst/>
@@ -6379,14 +6722,14 @@
       </p:sp>
       <p:sp>
         <p:nvSpPr>
-          <p:cNvPr id="67" name="TextBox 66"/>
+          <p:cNvPr id="76" name="TextBox 75"/>
           <p:cNvSpPr txBox="1"/>
           <p:nvPr/>
         </p:nvSpPr>
         <p:spPr>
           <a:xfrm>
-            <a:off x="9823156" y="3173882"/>
-            <a:ext cx="2112506" cy="227959"/>
+            <a:off x="9823156" y="3047238"/>
+            <a:ext cx="2112506" cy="189966"/>
           </a:xfrm>
           <a:prstGeom prst="rect">
             <a:avLst/>
@@ -6414,13 +6757,13 @@
       </p:sp>
       <p:sp>
         <p:nvSpPr>
-          <p:cNvPr id="68" name="Rectangle 67"/>
+          <p:cNvPr id="77" name="Rectangle 76"/>
           <p:cNvSpPr/>
           <p:nvPr/>
         </p:nvSpPr>
         <p:spPr>
           <a:xfrm>
-            <a:off x="9804868" y="3408883"/>
+            <a:off x="9804868" y="3240024"/>
             <a:ext cx="2130794" cy="10972"/>
           </a:xfrm>
           <a:prstGeom prst="rect">
@@ -6458,14 +6801,14 @@
       </p:sp>
       <p:sp>
         <p:nvSpPr>
-          <p:cNvPr id="69" name="TextBox 68"/>
+          <p:cNvPr id="78" name="TextBox 77"/>
           <p:cNvSpPr txBox="1"/>
           <p:nvPr/>
         </p:nvSpPr>
         <p:spPr>
           <a:xfrm>
-            <a:off x="9823156" y="3427171"/>
-            <a:ext cx="2112506" cy="278617"/>
+            <a:off x="9823156" y="3258312"/>
+            <a:ext cx="2112506" cy="232181"/>
           </a:xfrm>
           <a:prstGeom prst="rect">
             <a:avLst/>
@@ -6493,14 +6836,14 @@
       </p:sp>
       <p:sp>
         <p:nvSpPr>
-          <p:cNvPr id="70" name="TextBox 69"/>
+          <p:cNvPr id="79" name="TextBox 78"/>
           <p:cNvSpPr txBox="1"/>
           <p:nvPr/>
         </p:nvSpPr>
         <p:spPr>
           <a:xfrm>
-            <a:off x="9823156" y="3680460"/>
-            <a:ext cx="2112506" cy="227959"/>
+            <a:off x="9823156" y="3469386"/>
+            <a:ext cx="2112506" cy="189966"/>
           </a:xfrm>
           <a:prstGeom prst="rect">
             <a:avLst/>
@@ -6528,13 +6871,13 @@
       </p:sp>
       <p:sp>
         <p:nvSpPr>
-          <p:cNvPr id="71" name="Rectangle 70"/>
+          <p:cNvPr id="80" name="Rectangle 79"/>
           <p:cNvSpPr/>
           <p:nvPr/>
         </p:nvSpPr>
         <p:spPr>
           <a:xfrm>
-            <a:off x="9804868" y="3915460"/>
+            <a:off x="9804868" y="3662172"/>
             <a:ext cx="2130794" cy="10972"/>
           </a:xfrm>
           <a:prstGeom prst="rect">
@@ -6572,14 +6915,14 @@
       </p:sp>
       <p:sp>
         <p:nvSpPr>
-          <p:cNvPr id="72" name="TextBox 71"/>
+          <p:cNvPr id="81" name="TextBox 80"/>
           <p:cNvSpPr txBox="1"/>
           <p:nvPr/>
         </p:nvSpPr>
         <p:spPr>
           <a:xfrm>
-            <a:off x="9823156" y="3933748"/>
-            <a:ext cx="2112506" cy="278617"/>
+            <a:off x="9823156" y="3680460"/>
+            <a:ext cx="2112506" cy="232181"/>
           </a:xfrm>
           <a:prstGeom prst="rect">
             <a:avLst/>
@@ -6600,21 +6943,21 @@
                 </a:solidFill>
                 <a:latin typeface="Microsoft YaHei"/>
               </a:rPr>
-              <a:t>异常工单看板</a:t>
-            </a:r>
-          </a:p>
-        </p:txBody>
-      </p:sp>
-      <p:sp>
-        <p:nvSpPr>
-          <p:cNvPr id="73" name="TextBox 72"/>
+              <a:t>设备监控层</a:t>
+            </a:r>
+          </a:p>
+        </p:txBody>
+      </p:sp>
+      <p:sp>
+        <p:nvSpPr>
+          <p:cNvPr id="82" name="TextBox 81"/>
           <p:cNvSpPr txBox="1"/>
           <p:nvPr/>
         </p:nvSpPr>
         <p:spPr>
           <a:xfrm>
-            <a:off x="9823156" y="4187037"/>
-            <a:ext cx="2112506" cy="227959"/>
+            <a:off x="9823156" y="3891534"/>
+            <a:ext cx="2112506" cy="189966"/>
           </a:xfrm>
           <a:prstGeom prst="rect">
             <a:avLst/>
@@ -6635,20 +6978,20 @@
                 </a:solidFill>
                 <a:latin typeface="Microsoft YaHei"/>
               </a:rPr>
-              <a:t>异常 / 重试 / 告警</a:t>
-            </a:r>
-          </a:p>
-        </p:txBody>
-      </p:sp>
-      <p:sp>
-        <p:nvSpPr>
-          <p:cNvPr id="74" name="Rectangle 73"/>
+              <a:t>设备状态 · 能耗 · 故障预警</a:t>
+            </a:r>
+          </a:p>
+        </p:txBody>
+      </p:sp>
+      <p:sp>
+        <p:nvSpPr>
+          <p:cNvPr id="83" name="Rectangle 82"/>
           <p:cNvSpPr/>
           <p:nvPr/>
         </p:nvSpPr>
         <p:spPr>
           <a:xfrm>
-            <a:off x="9804868" y="4422038"/>
+            <a:off x="9804868" y="4084320"/>
             <a:ext cx="2130794" cy="10972"/>
           </a:xfrm>
           <a:prstGeom prst="rect">
@@ -6686,14 +7029,14 @@
       </p:sp>
       <p:sp>
         <p:nvSpPr>
-          <p:cNvPr id="75" name="TextBox 74"/>
+          <p:cNvPr id="84" name="TextBox 83"/>
           <p:cNvSpPr txBox="1"/>
           <p:nvPr/>
         </p:nvSpPr>
         <p:spPr>
           <a:xfrm>
-            <a:off x="9823156" y="4440326"/>
-            <a:ext cx="2112506" cy="278617"/>
+            <a:off x="9823156" y="4102608"/>
+            <a:ext cx="2112506" cy="232181"/>
           </a:xfrm>
           <a:prstGeom prst="rect">
             <a:avLst/>
@@ -6714,21 +7057,21 @@
                 </a:solidFill>
                 <a:latin typeface="Microsoft YaHei"/>
               </a:rPr>
-              <a:t>数字孪生</a:t>
-            </a:r>
-          </a:p>
-        </p:txBody>
-      </p:sp>
-      <p:sp>
-        <p:nvSpPr>
-          <p:cNvPr id="76" name="TextBox 75"/>
+              <a:t>异常工单看板</a:t>
+            </a:r>
+          </a:p>
+        </p:txBody>
+      </p:sp>
+      <p:sp>
+        <p:nvSpPr>
+          <p:cNvPr id="85" name="TextBox 84"/>
           <p:cNvSpPr txBox="1"/>
           <p:nvPr/>
         </p:nvSpPr>
         <p:spPr>
           <a:xfrm>
-            <a:off x="9823156" y="4693615"/>
-            <a:ext cx="2112506" cy="227959"/>
+            <a:off x="9823156" y="4313682"/>
+            <a:ext cx="2112506" cy="189966"/>
           </a:xfrm>
           <a:prstGeom prst="rect">
             <a:avLst/>
@@ -6749,6 +7092,120 @@
                 </a:solidFill>
                 <a:latin typeface="Microsoft YaHei"/>
               </a:rPr>
+              <a:t>异常 / 重试 / 告警</a:t>
+            </a:r>
+          </a:p>
+        </p:txBody>
+      </p:sp>
+      <p:sp>
+        <p:nvSpPr>
+          <p:cNvPr id="86" name="Rectangle 85"/>
+          <p:cNvSpPr/>
+          <p:nvPr/>
+        </p:nvSpPr>
+        <p:spPr>
+          <a:xfrm>
+            <a:off x="9804868" y="4506468"/>
+            <a:ext cx="2130794" cy="10972"/>
+          </a:xfrm>
+          <a:prstGeom prst="rect">
+            <a:avLst/>
+          </a:prstGeom>
+          <a:solidFill>
+            <a:srgbClr val="E3E7EC"/>
+          </a:solidFill>
+          <a:ln>
+            <a:noFill/>
+          </a:ln>
+          <a:effectLst/>
+        </p:spPr>
+        <p:style>
+          <a:lnRef idx="1">
+            <a:schemeClr val="accent1"/>
+          </a:lnRef>
+          <a:fillRef idx="3">
+            <a:schemeClr val="accent1"/>
+          </a:fillRef>
+          <a:effectRef idx="2">
+            <a:schemeClr val="accent1"/>
+          </a:effectRef>
+          <a:fontRef idx="minor">
+            <a:schemeClr val="lt1"/>
+          </a:fontRef>
+        </p:style>
+        <p:txBody>
+          <a:bodyPr rtlCol="0" anchor="ctr"/>
+          <a:lstStyle/>
+          <a:p>
+            <a:pPr algn="ctr"/>
+          </a:p>
+        </p:txBody>
+      </p:sp>
+      <p:sp>
+        <p:nvSpPr>
+          <p:cNvPr id="87" name="TextBox 86"/>
+          <p:cNvSpPr txBox="1"/>
+          <p:nvPr/>
+        </p:nvSpPr>
+        <p:spPr>
+          <a:xfrm>
+            <a:off x="9823156" y="4524756"/>
+            <a:ext cx="2112506" cy="232181"/>
+          </a:xfrm>
+          <a:prstGeom prst="rect">
+            <a:avLst/>
+          </a:prstGeom>
+          <a:noFill/>
+        </p:spPr>
+        <p:txBody>
+          <a:bodyPr wrap="square" anchor="t" lIns="0" rIns="0" tIns="0" bIns="0">
+            <a:spAutoFit/>
+          </a:bodyPr>
+          <a:lstStyle/>
+          <a:p>
+            <a:pPr algn="l"/>
+            <a:r>
+              <a:rPr sz="1000" b="1" i="0">
+                <a:solidFill>
+                  <a:srgbClr val="262626"/>
+                </a:solidFill>
+                <a:latin typeface="Microsoft YaHei"/>
+              </a:rPr>
+              <a:t>数字孪生</a:t>
+            </a:r>
+          </a:p>
+        </p:txBody>
+      </p:sp>
+      <p:sp>
+        <p:nvSpPr>
+          <p:cNvPr id="88" name="TextBox 87"/>
+          <p:cNvSpPr txBox="1"/>
+          <p:nvPr/>
+        </p:nvSpPr>
+        <p:spPr>
+          <a:xfrm>
+            <a:off x="9823156" y="4735830"/>
+            <a:ext cx="2112506" cy="189966"/>
+          </a:xfrm>
+          <a:prstGeom prst="rect">
+            <a:avLst/>
+          </a:prstGeom>
+          <a:noFill/>
+        </p:spPr>
+        <p:txBody>
+          <a:bodyPr wrap="square" anchor="t" lIns="0" rIns="0" tIns="0" bIns="0">
+            <a:spAutoFit/>
+          </a:bodyPr>
+          <a:lstStyle/>
+          <a:p>
+            <a:pPr algn="l"/>
+            <a:r>
+              <a:rPr sz="800" b="0" i="0">
+                <a:solidFill>
+                  <a:srgbClr val="7A7A7A"/>
+                </a:solidFill>
+                <a:latin typeface="Microsoft YaHei"/>
+              </a:rPr>
               <a:t>仓内全要素映射</a:t>
             </a:r>
           </a:p>
@@ -6756,7 +7213,7 @@
       </p:sp>
       <p:cxnSp>
         <p:nvCxnSpPr>
-          <p:cNvPr id="77" name="Connector 76"/>
+          <p:cNvPr id="89" name="Connector 88"/>
           <p:cNvCxnSpPr/>
           <p:nvPr/>
         </p:nvCxnSpPr>
@@ -6793,7 +7250,7 @@
       </p:cxnSp>
       <p:cxnSp>
         <p:nvCxnSpPr>
-          <p:cNvPr id="78" name="Connector 77"/>
+          <p:cNvPr id="90" name="Connector 89"/>
           <p:cNvCxnSpPr/>
           <p:nvPr/>
         </p:nvCxnSpPr>
@@ -6830,7 +7287,7 @@
       </p:cxnSp>
       <p:cxnSp>
         <p:nvCxnSpPr>
-          <p:cNvPr id="79" name="Connector 78"/>
+          <p:cNvPr id="91" name="Connector 90"/>
           <p:cNvCxnSpPr/>
           <p:nvPr/>
         </p:nvCxnSpPr>
@@ -6867,7 +7324,7 @@
       </p:cxnSp>
       <p:cxnSp>
         <p:nvCxnSpPr>
-          <p:cNvPr id="80" name="Connector 79"/>
+          <p:cNvPr id="92" name="Connector 91"/>
           <p:cNvCxnSpPr/>
           <p:nvPr/>
         </p:nvCxnSpPr>
@@ -6904,7 +7361,7 @@
       </p:cxnSp>
       <p:cxnSp>
         <p:nvCxnSpPr>
-          <p:cNvPr id="81" name="Connector 80"/>
+          <p:cNvPr id="93" name="Connector 92"/>
           <p:cNvCxnSpPr/>
           <p:nvPr/>
         </p:nvCxnSpPr>
@@ -6941,7 +7398,7 @@
       </p:cxnSp>
       <p:cxnSp>
         <p:nvCxnSpPr>
-          <p:cNvPr id="82" name="Connector 81"/>
+          <p:cNvPr id="94" name="Connector 93"/>
           <p:cNvCxnSpPr/>
           <p:nvPr/>
         </p:nvCxnSpPr>
@@ -6978,7 +7435,7 @@
       </p:cxnSp>
       <p:sp>
         <p:nvSpPr>
-          <p:cNvPr id="83" name="TextBox 82"/>
+          <p:cNvPr id="95" name="TextBox 94"/>
           <p:cNvSpPr txBox="1"/>
           <p:nvPr/>
         </p:nvSpPr>
@@ -7013,7 +7470,7 @@
       </p:sp>
       <p:sp>
         <p:nvSpPr>
-          <p:cNvPr id="84" name="TextBox 83"/>
+          <p:cNvPr id="96" name="TextBox 95"/>
           <p:cNvSpPr txBox="1"/>
           <p:nvPr/>
         </p:nvSpPr>
@@ -7048,7 +7505,7 @@
       </p:sp>
       <p:sp>
         <p:nvSpPr>
-          <p:cNvPr id="85" name="Rounded Rectangle 84"/>
+          <p:cNvPr id="97" name="Rounded Rectangle 96"/>
           <p:cNvSpPr/>
           <p:nvPr/>
         </p:nvSpPr>
@@ -7096,7 +7553,7 @@
       </p:sp>
       <p:sp>
         <p:nvSpPr>
-          <p:cNvPr id="86" name="TextBox 85"/>
+          <p:cNvPr id="98" name="TextBox 97"/>
           <p:cNvSpPr txBox="1"/>
           <p:nvPr/>
         </p:nvSpPr>
@@ -7131,7 +7588,7 @@
       </p:sp>
       <p:sp>
         <p:nvSpPr>
-          <p:cNvPr id="87" name="Rectangle 86"/>
+          <p:cNvPr id="99" name="Rectangle 98"/>
           <p:cNvSpPr/>
           <p:nvPr/>
         </p:nvSpPr>
@@ -7175,7 +7632,7 @@
       </p:sp>
       <p:sp>
         <p:nvSpPr>
-          <p:cNvPr id="88" name="TextBox 87"/>
+          <p:cNvPr id="100" name="TextBox 99"/>
           <p:cNvSpPr txBox="1"/>
           <p:nvPr/>
         </p:nvSpPr>
@@ -7210,7 +7667,7 @@
       </p:sp>
       <p:sp>
         <p:nvSpPr>
-          <p:cNvPr id="89" name="Rounded Rectangle 88"/>
+          <p:cNvPr id="101" name="Rounded Rectangle 100"/>
           <p:cNvSpPr/>
           <p:nvPr/>
         </p:nvSpPr>
@@ -7258,7 +7715,7 @@
       </p:sp>
       <p:sp>
         <p:nvSpPr>
-          <p:cNvPr id="90" name="TextBox 89"/>
+          <p:cNvPr id="102" name="TextBox 101"/>
           <p:cNvSpPr txBox="1"/>
           <p:nvPr/>
         </p:nvSpPr>
@@ -7293,7 +7750,7 @@
       </p:sp>
       <p:sp>
         <p:nvSpPr>
-          <p:cNvPr id="91" name="Rectangle 90"/>
+          <p:cNvPr id="103" name="Rectangle 102"/>
           <p:cNvSpPr/>
           <p:nvPr/>
         </p:nvSpPr>
@@ -7337,7 +7794,7 @@
       </p:sp>
       <p:sp>
         <p:nvSpPr>
-          <p:cNvPr id="92" name="TextBox 91"/>
+          <p:cNvPr id="104" name="TextBox 103"/>
           <p:cNvSpPr txBox="1"/>
           <p:nvPr/>
         </p:nvSpPr>
@@ -7372,7 +7829,7 @@
       </p:sp>
       <p:sp>
         <p:nvSpPr>
-          <p:cNvPr id="93" name="Rounded Rectangle 92"/>
+          <p:cNvPr id="105" name="Rounded Rectangle 104"/>
           <p:cNvSpPr/>
           <p:nvPr/>
         </p:nvSpPr>
@@ -7420,7 +7877,7 @@
       </p:sp>
       <p:sp>
         <p:nvSpPr>
-          <p:cNvPr id="94" name="TextBox 93"/>
+          <p:cNvPr id="106" name="TextBox 105"/>
           <p:cNvSpPr txBox="1"/>
           <p:nvPr/>
         </p:nvSpPr>
@@ -7455,7 +7912,7 @@
       </p:sp>
       <p:sp>
         <p:nvSpPr>
-          <p:cNvPr id="95" name="Rectangle 94"/>
+          <p:cNvPr id="107" name="Rectangle 106"/>
           <p:cNvSpPr/>
           <p:nvPr/>
         </p:nvSpPr>
@@ -7499,7 +7956,7 @@
       </p:sp>
       <p:sp>
         <p:nvSpPr>
-          <p:cNvPr id="96" name="TextBox 95"/>
+          <p:cNvPr id="108" name="TextBox 107"/>
           <p:cNvSpPr txBox="1"/>
           <p:nvPr/>
         </p:nvSpPr>
@@ -7534,7 +7991,7 @@
       </p:sp>
       <p:sp>
         <p:nvSpPr>
-          <p:cNvPr id="97" name="Rounded Rectangle 96"/>
+          <p:cNvPr id="109" name="Rounded Rectangle 108"/>
           <p:cNvSpPr/>
           <p:nvPr/>
         </p:nvSpPr>
@@ -7582,7 +8039,7 @@
       </p:sp>
       <p:sp>
         <p:nvSpPr>
-          <p:cNvPr id="98" name="TextBox 97"/>
+          <p:cNvPr id="110" name="TextBox 109"/>
           <p:cNvSpPr txBox="1"/>
           <p:nvPr/>
         </p:nvSpPr>
@@ -7617,7 +8074,7 @@
       </p:sp>
       <p:sp>
         <p:nvSpPr>
-          <p:cNvPr id="99" name="Rectangle 98"/>
+          <p:cNvPr id="111" name="Rectangle 110"/>
           <p:cNvSpPr/>
           <p:nvPr/>
         </p:nvSpPr>
@@ -7661,7 +8118,7 @@
       </p:sp>
       <p:sp>
         <p:nvSpPr>
-          <p:cNvPr id="100" name="TextBox 99"/>
+          <p:cNvPr id="112" name="TextBox 111"/>
           <p:cNvSpPr txBox="1"/>
           <p:nvPr/>
         </p:nvSpPr>
@@ -7696,7 +8153,7 @@
       </p:sp>
       <p:sp>
         <p:nvSpPr>
-          <p:cNvPr id="101" name="Rounded Rectangle 100"/>
+          <p:cNvPr id="113" name="Rounded Rectangle 112"/>
           <p:cNvSpPr/>
           <p:nvPr/>
         </p:nvSpPr>
@@ -7744,7 +8201,7 @@
       </p:sp>
       <p:sp>
         <p:nvSpPr>
-          <p:cNvPr id="102" name="TextBox 101"/>
+          <p:cNvPr id="114" name="TextBox 113"/>
           <p:cNvSpPr txBox="1"/>
           <p:nvPr/>
         </p:nvSpPr>
@@ -7779,7 +8236,7 @@
       </p:sp>
       <p:sp>
         <p:nvSpPr>
-          <p:cNvPr id="103" name="Rectangle 102"/>
+          <p:cNvPr id="115" name="Rectangle 114"/>
           <p:cNvSpPr/>
           <p:nvPr/>
         </p:nvSpPr>
@@ -7823,7 +8280,7 @@
       </p:sp>
       <p:sp>
         <p:nvSpPr>
-          <p:cNvPr id="104" name="TextBox 103"/>
+          <p:cNvPr id="116" name="TextBox 115"/>
           <p:cNvSpPr txBox="1"/>
           <p:nvPr/>
         </p:nvSpPr>
@@ -7858,7 +8315,7 @@
       </p:sp>
       <p:sp>
         <p:nvSpPr>
-          <p:cNvPr id="105" name="Rounded Rectangle 104"/>
+          <p:cNvPr id="117" name="Rounded Rectangle 116"/>
           <p:cNvSpPr/>
           <p:nvPr/>
         </p:nvSpPr>
@@ -7906,7 +8363,7 @@
       </p:sp>
       <p:sp>
         <p:nvSpPr>
-          <p:cNvPr id="106" name="TextBox 105"/>
+          <p:cNvPr id="118" name="TextBox 117"/>
           <p:cNvSpPr txBox="1"/>
           <p:nvPr/>
         </p:nvSpPr>
@@ -7941,7 +8398,7 @@
       </p:sp>
       <p:sp>
         <p:nvSpPr>
-          <p:cNvPr id="107" name="Rectangle 106"/>
+          <p:cNvPr id="119" name="Rectangle 118"/>
           <p:cNvSpPr/>
           <p:nvPr/>
         </p:nvSpPr>
@@ -7985,7 +8442,7 @@
       </p:sp>
       <p:sp>
         <p:nvSpPr>
-          <p:cNvPr id="108" name="TextBox 107"/>
+          <p:cNvPr id="120" name="TextBox 119"/>
           <p:cNvSpPr txBox="1"/>
           <p:nvPr/>
         </p:nvSpPr>
@@ -8020,7 +8477,7 @@
       </p:sp>
       <p:sp>
         <p:nvSpPr>
-          <p:cNvPr id="109" name="Rounded Rectangle 108"/>
+          <p:cNvPr id="121" name="Rounded Rectangle 120"/>
           <p:cNvSpPr/>
           <p:nvPr/>
         </p:nvSpPr>
@@ -8068,7 +8525,7 @@
       </p:sp>
       <p:sp>
         <p:nvSpPr>
-          <p:cNvPr id="110" name="TextBox 109"/>
+          <p:cNvPr id="122" name="TextBox 121"/>
           <p:cNvSpPr txBox="1"/>
           <p:nvPr/>
         </p:nvSpPr>
@@ -8103,7 +8560,7 @@
       </p:sp>
       <p:sp>
         <p:nvSpPr>
-          <p:cNvPr id="111" name="Rounded Rectangle 110"/>
+          <p:cNvPr id="123" name="Rounded Rectangle 122"/>
           <p:cNvSpPr/>
           <p:nvPr/>
         </p:nvSpPr>
@@ -8151,7 +8608,7 @@
       </p:sp>
       <p:sp>
         <p:nvSpPr>
-          <p:cNvPr id="112" name="TextBox 111"/>
+          <p:cNvPr id="124" name="TextBox 123"/>
           <p:cNvSpPr txBox="1"/>
           <p:nvPr/>
         </p:nvSpPr>
@@ -8186,7 +8643,7 @@
       </p:sp>
       <p:sp>
         <p:nvSpPr>
-          <p:cNvPr id="113" name="Rounded Rectangle 112"/>
+          <p:cNvPr id="125" name="Rounded Rectangle 124"/>
           <p:cNvSpPr/>
           <p:nvPr/>
         </p:nvSpPr>
@@ -8234,7 +8691,7 @@
       </p:sp>
       <p:sp>
         <p:nvSpPr>
-          <p:cNvPr id="114" name="TextBox 113"/>
+          <p:cNvPr id="126" name="TextBox 125"/>
           <p:cNvSpPr txBox="1"/>
           <p:nvPr/>
         </p:nvSpPr>
@@ -8269,7 +8726,7 @@
       </p:sp>
       <p:sp>
         <p:nvSpPr>
-          <p:cNvPr id="115" name="Rounded Rectangle 114"/>
+          <p:cNvPr id="127" name="Rounded Rectangle 126"/>
           <p:cNvSpPr/>
           <p:nvPr/>
         </p:nvSpPr>
@@ -8317,7 +8774,7 @@
       </p:sp>
       <p:sp>
         <p:nvSpPr>
-          <p:cNvPr id="116" name="TextBox 115"/>
+          <p:cNvPr id="128" name="TextBox 127"/>
           <p:cNvSpPr txBox="1"/>
           <p:nvPr/>
         </p:nvSpPr>
@@ -8352,7 +8809,7 @@
       </p:sp>
       <p:sp>
         <p:nvSpPr>
-          <p:cNvPr id="117" name="Rounded Rectangle 116"/>
+          <p:cNvPr id="129" name="Rounded Rectangle 128"/>
           <p:cNvSpPr/>
           <p:nvPr/>
         </p:nvSpPr>
@@ -8400,7 +8857,7 @@
       </p:sp>
       <p:sp>
         <p:nvSpPr>
-          <p:cNvPr id="118" name="TextBox 117"/>
+          <p:cNvPr id="130" name="TextBox 129"/>
           <p:cNvSpPr txBox="1"/>
           <p:nvPr/>
         </p:nvSpPr>
@@ -8435,7 +8892,7 @@
       </p:sp>
       <p:sp>
         <p:nvSpPr>
-          <p:cNvPr id="119" name="Rounded Rectangle 118"/>
+          <p:cNvPr id="131" name="Rounded Rectangle 130"/>
           <p:cNvSpPr/>
           <p:nvPr/>
         </p:nvSpPr>
@@ -8483,7 +8940,7 @@
       </p:sp>
       <p:sp>
         <p:nvSpPr>
-          <p:cNvPr id="120" name="TextBox 119"/>
+          <p:cNvPr id="132" name="TextBox 131"/>
           <p:cNvSpPr txBox="1"/>
           <p:nvPr/>
         </p:nvSpPr>
@@ -8518,7 +8975,7 @@
       </p:sp>
       <p:sp>
         <p:nvSpPr>
-          <p:cNvPr id="121" name="Rounded Rectangle 120"/>
+          <p:cNvPr id="133" name="Rounded Rectangle 132"/>
           <p:cNvSpPr/>
           <p:nvPr/>
         </p:nvSpPr>
@@ -8566,7 +9023,7 @@
       </p:sp>
       <p:sp>
         <p:nvSpPr>
-          <p:cNvPr id="122" name="TextBox 121"/>
+          <p:cNvPr id="134" name="TextBox 133"/>
           <p:cNvSpPr txBox="1"/>
           <p:nvPr/>
         </p:nvSpPr>
@@ -8601,7 +9058,7 @@
       </p:sp>
       <p:sp>
         <p:nvSpPr>
-          <p:cNvPr id="123" name="Rounded Rectangle 122"/>
+          <p:cNvPr id="135" name="Rounded Rectangle 134"/>
           <p:cNvSpPr/>
           <p:nvPr/>
         </p:nvSpPr>
@@ -8649,7 +9106,7 @@
       </p:sp>
       <p:sp>
         <p:nvSpPr>
-          <p:cNvPr id="124" name="TextBox 123"/>
+          <p:cNvPr id="136" name="TextBox 135"/>
           <p:cNvSpPr txBox="1"/>
           <p:nvPr/>
         </p:nvSpPr>
@@ -8684,7 +9141,7 @@
       </p:sp>
       <p:sp>
         <p:nvSpPr>
-          <p:cNvPr id="125" name="Rounded Rectangle 124"/>
+          <p:cNvPr id="137" name="Rounded Rectangle 136"/>
           <p:cNvSpPr/>
           <p:nvPr/>
         </p:nvSpPr>
@@ -8732,7 +9189,7 @@
       </p:sp>
       <p:sp>
         <p:nvSpPr>
-          <p:cNvPr id="126" name="TextBox 125"/>
+          <p:cNvPr id="138" name="TextBox 137"/>
           <p:cNvSpPr txBox="1"/>
           <p:nvPr/>
         </p:nvSpPr>
@@ -8767,7 +9224,7 @@
       </p:sp>
       <p:sp>
         <p:nvSpPr>
-          <p:cNvPr id="127" name="Rounded Rectangle 126"/>
+          <p:cNvPr id="139" name="Rounded Rectangle 138"/>
           <p:cNvSpPr/>
           <p:nvPr/>
         </p:nvSpPr>
@@ -8815,7 +9272,7 @@
       </p:sp>
       <p:sp>
         <p:nvSpPr>
-          <p:cNvPr id="128" name="TextBox 127"/>
+          <p:cNvPr id="140" name="TextBox 139"/>
           <p:cNvSpPr txBox="1"/>
           <p:nvPr/>
         </p:nvSpPr>
@@ -8850,7 +9307,7 @@
       </p:sp>
       <p:sp>
         <p:nvSpPr>
-          <p:cNvPr id="129" name="Rounded Rectangle 128"/>
+          <p:cNvPr id="141" name="Rounded Rectangle 140"/>
           <p:cNvSpPr/>
           <p:nvPr/>
         </p:nvSpPr>
@@ -8898,7 +9355,7 @@
       </p:sp>
       <p:sp>
         <p:nvSpPr>
-          <p:cNvPr id="130" name="TextBox 129"/>
+          <p:cNvPr id="142" name="TextBox 141"/>
           <p:cNvSpPr txBox="1"/>
           <p:nvPr/>
         </p:nvSpPr>
@@ -8933,7 +9390,7 @@
       </p:sp>
       <p:sp>
         <p:nvSpPr>
-          <p:cNvPr id="131" name="TextBox 130"/>
+          <p:cNvPr id="143" name="TextBox 142"/>
           <p:cNvSpPr txBox="1"/>
           <p:nvPr/>
         </p:nvSpPr>

</xml_diff>

<commit_message>
Align slide 2 visual style with slide 1's house conventions
Replace slide 2's bespoke idioms (solid-color rail bars, dashed-only
connectors, non-bold chips, in-box bold headers) with the exact patterns
already used on slide 1: plain gray above-left section labels, solid
bidirectional arrows, bold chip text, dark-blue header bars inside one
outer dashed "WCS 平台" container, and the same plain device-tag style.
</commit_message>
<xml_diff>
--- a/wcs-architecture/WCS架构产品方案.pptx
+++ b/wcs-architecture/WCS架构产品方案.pptx
@@ -9558,25 +9558,62 @@
       </p:sp>
       <p:sp>
         <p:nvSpPr>
-          <p:cNvPr id="5" name="Rounded Rectangle 4"/>
+          <p:cNvPr id="5" name="TextBox 4"/>
+          <p:cNvSpPr txBox="1"/>
+          <p:nvPr/>
+        </p:nvSpPr>
+        <p:spPr>
+          <a:xfrm>
+            <a:off x="274320" y="877824"/>
+            <a:ext cx="5486400" cy="201168"/>
+          </a:xfrm>
+          <a:prstGeom prst="rect">
+            <a:avLst/>
+          </a:prstGeom>
+          <a:noFill/>
+        </p:spPr>
+        <p:txBody>
+          <a:bodyPr wrap="square" anchor="t" lIns="0" rIns="0" tIns="0" bIns="0">
+            <a:spAutoFit/>
+          </a:bodyPr>
+          <a:lstStyle/>
+          <a:p>
+            <a:pPr algn="l"/>
+            <a:r>
+              <a:rPr sz="1000" b="1" i="0">
+                <a:solidFill>
+                  <a:srgbClr val="595959"/>
+                </a:solidFill>
+                <a:latin typeface="Microsoft YaHei"/>
+              </a:rPr>
+              <a:t>上游 · WMS / WHC 系统接入</a:t>
+            </a:r>
+          </a:p>
+        </p:txBody>
+      </p:sp>
+      <p:sp>
+        <p:nvSpPr>
+          <p:cNvPr id="6" name="Rounded Rectangle 5"/>
           <p:cNvSpPr/>
           <p:nvPr/>
         </p:nvSpPr>
         <p:spPr>
           <a:xfrm>
-            <a:off x="274320" y="960120"/>
-            <a:ext cx="566928" cy="502920"/>
+            <a:off x="274320" y="1078992"/>
+            <a:ext cx="5748375" cy="530352"/>
           </a:xfrm>
           <a:prstGeom prst="roundRect">
             <a:avLst>
-              <a:gd name="adj" fmla="val 10000"/>
+              <a:gd name="adj" fmla="val 5000"/>
             </a:avLst>
           </a:prstGeom>
           <a:solidFill>
-            <a:srgbClr val="1F4E79"/>
-          </a:solidFill>
-          <a:ln>
-            <a:noFill/>
+            <a:srgbClr val="FFFFFF"/>
+          </a:solidFill>
+          <a:ln w="12700">
+            <a:solidFill>
+              <a:srgbClr val="9FB7D4"/>
+            </a:solidFill>
           </a:ln>
           <a:effectLst/>
         </p:spPr>
@@ -9604,14 +9641,14 @@
       </p:sp>
       <p:sp>
         <p:nvSpPr>
-          <p:cNvPr id="6" name="TextBox 5"/>
+          <p:cNvPr id="7" name="TextBox 6"/>
           <p:cNvSpPr txBox="1"/>
           <p:nvPr/>
         </p:nvSpPr>
         <p:spPr>
           <a:xfrm>
-            <a:off x="274320" y="960120"/>
-            <a:ext cx="566928" cy="502920"/>
+            <a:off x="274320" y="1152144"/>
+            <a:ext cx="5748375" cy="219456"/>
           </a:xfrm>
           <a:prstGeom prst="rect">
             <a:avLst/>
@@ -9619,39 +9656,37 @@
           <a:noFill/>
         </p:spPr>
         <p:txBody>
-          <a:bodyPr wrap="square" anchor="ctr" lIns="0" rIns="0" tIns="0" bIns="0">
+          <a:bodyPr wrap="square" anchor="t" lIns="0" rIns="0" tIns="0" bIns="0">
             <a:spAutoFit/>
           </a:bodyPr>
           <a:lstStyle/>
           <a:p>
             <a:pPr algn="ctr"/>
             <a:r>
-              <a:rPr sz="1150" b="1" i="0">
-                <a:solidFill>
-                  <a:srgbClr val="FFFFFF"/>
-                </a:solidFill>
-                <a:latin typeface="Microsoft YaHei"/>
-              </a:rPr>
-              <a:t>WMS</a:t>
-            </a:r>
-          </a:p>
-        </p:txBody>
-      </p:sp>
-      <p:sp>
-        <p:nvSpPr>
-          <p:cNvPr id="7" name="Rounded Rectangle 6"/>
+              <a:rPr sz="1250" b="1" i="0">
+                <a:solidFill>
+                  <a:srgbClr val="1F4E79"/>
+                </a:solidFill>
+                <a:latin typeface="Microsoft YaHei"/>
+              </a:rPr>
+              <a:t>Flux WMS</a:t>
+            </a:r>
+          </a:p>
+        </p:txBody>
+      </p:sp>
+      <p:sp>
+        <p:nvSpPr>
+          <p:cNvPr id="8" name="Rectangle 7"/>
           <p:cNvSpPr/>
           <p:nvPr/>
         </p:nvSpPr>
         <p:spPr>
           <a:xfrm>
-            <a:off x="274320" y="1737360"/>
-            <a:ext cx="566928" cy="4114800"/>
-          </a:xfrm>
-          <a:prstGeom prst="roundRect">
-            <a:avLst>
-              <a:gd name="adj" fmla="val 10000"/>
-            </a:avLst>
+            <a:off x="1309027" y="1389888"/>
+            <a:ext cx="3678960" cy="16459"/>
+          </a:xfrm>
+          <a:prstGeom prst="rect">
+            <a:avLst/>
           </a:prstGeom>
           <a:solidFill>
             <a:srgbClr val="2E75B6"/>
@@ -9685,60 +9720,27 @@
       </p:sp>
       <p:sp>
         <p:nvSpPr>
-          <p:cNvPr id="8" name="TextBox 7"/>
-          <p:cNvSpPr txBox="1"/>
-          <p:nvPr/>
-        </p:nvSpPr>
-        <p:spPr>
-          <a:xfrm>
-            <a:off x="274320" y="1737360"/>
-            <a:ext cx="566928" cy="4114800"/>
-          </a:xfrm>
-          <a:prstGeom prst="rect">
-            <a:avLst/>
-          </a:prstGeom>
-          <a:noFill/>
-        </p:spPr>
-        <p:txBody>
-          <a:bodyPr wrap="square" anchor="ctr" lIns="0" rIns="0" tIns="0" bIns="0">
-            <a:spAutoFit/>
-          </a:bodyPr>
-          <a:lstStyle/>
-          <a:p>
-            <a:pPr algn="ctr"/>
-            <a:r>
-              <a:rPr sz="1150" b="1" i="0">
-                <a:solidFill>
-                  <a:srgbClr val="FFFFFF"/>
-                </a:solidFill>
-                <a:latin typeface="Microsoft YaHei"/>
-              </a:rPr>
-              <a:t>WCS</a:t>
-            </a:r>
-          </a:p>
-        </p:txBody>
-      </p:sp>
-      <p:sp>
-        <p:nvSpPr>
           <p:cNvPr id="9" name="Rounded Rectangle 8"/>
           <p:cNvSpPr/>
           <p:nvPr/>
         </p:nvSpPr>
         <p:spPr>
           <a:xfrm>
-            <a:off x="274320" y="6080760"/>
-            <a:ext cx="566928" cy="457200"/>
+            <a:off x="6168999" y="1078992"/>
+            <a:ext cx="5748375" cy="530352"/>
           </a:xfrm>
           <a:prstGeom prst="roundRect">
             <a:avLst>
-              <a:gd name="adj" fmla="val 10000"/>
+              <a:gd name="adj" fmla="val 5000"/>
             </a:avLst>
           </a:prstGeom>
           <a:solidFill>
-            <a:srgbClr val="1F4E79"/>
-          </a:solidFill>
-          <a:ln>
-            <a:noFill/>
+            <a:srgbClr val="FFFFFF"/>
+          </a:solidFill>
+          <a:ln w="12700">
+            <a:solidFill>
+              <a:srgbClr val="9FB7D4"/>
+            </a:solidFill>
           </a:ln>
           <a:effectLst/>
         </p:spPr>
@@ -9772,8 +9774,8 @@
         </p:nvSpPr>
         <p:spPr>
           <a:xfrm>
-            <a:off x="274320" y="6080760"/>
-            <a:ext cx="566928" cy="457200"/>
+            <a:off x="6168999" y="1152144"/>
+            <a:ext cx="5748375" cy="219456"/>
           </a:xfrm>
           <a:prstGeom prst="rect">
             <a:avLst/>
@@ -9781,48 +9783,43 @@
           <a:noFill/>
         </p:spPr>
         <p:txBody>
-          <a:bodyPr wrap="square" anchor="ctr" lIns="0" rIns="0" tIns="0" bIns="0">
+          <a:bodyPr wrap="square" anchor="t" lIns="0" rIns="0" tIns="0" bIns="0">
             <a:spAutoFit/>
           </a:bodyPr>
           <a:lstStyle/>
           <a:p>
             <a:pPr algn="ctr"/>
             <a:r>
-              <a:rPr sz="1150" b="1" i="0">
-                <a:solidFill>
-                  <a:srgbClr val="FFFFFF"/>
-                </a:solidFill>
-                <a:latin typeface="Microsoft YaHei"/>
-              </a:rPr>
-              <a:t>DEVICE</a:t>
-            </a:r>
-          </a:p>
-        </p:txBody>
-      </p:sp>
-      <p:sp>
-        <p:nvSpPr>
-          <p:cNvPr id="11" name="Rounded Rectangle 10"/>
+              <a:rPr sz="1250" b="1" i="0">
+                <a:solidFill>
+                  <a:srgbClr val="1F4E79"/>
+                </a:solidFill>
+                <a:latin typeface="Microsoft YaHei"/>
+              </a:rPr>
+              <a:t>飞云 WMS</a:t>
+            </a:r>
+          </a:p>
+        </p:txBody>
+      </p:sp>
+      <p:sp>
+        <p:nvSpPr>
+          <p:cNvPr id="11" name="Rectangle 10"/>
           <p:cNvSpPr/>
           <p:nvPr/>
         </p:nvSpPr>
         <p:spPr>
           <a:xfrm>
-            <a:off x="969264" y="960120"/>
-            <a:ext cx="5391759" cy="502920"/>
-          </a:xfrm>
-          <a:prstGeom prst="roundRect">
-            <a:avLst>
-              <a:gd name="adj" fmla="val 4000"/>
-            </a:avLst>
-          </a:prstGeom>
-          <a:solidFill>
-            <a:srgbClr val="FCFDFE"/>
-          </a:solidFill>
-          <a:ln w="12700">
-            <a:solidFill>
-              <a:srgbClr val="C9C9C9"/>
-            </a:solidFill>
-            <a:prstDash val="dash"/>
+            <a:off x="7203707" y="1389888"/>
+            <a:ext cx="3678960" cy="16459"/>
+          </a:xfrm>
+          <a:prstGeom prst="rect">
+            <a:avLst/>
+          </a:prstGeom>
+          <a:solidFill>
+            <a:srgbClr val="2E75B6"/>
+          </a:solidFill>
+          <a:ln>
+            <a:noFill/>
           </a:ln>
           <a:effectLst/>
         </p:spPr>
@@ -9848,135 +9845,16 @@
           </a:p>
         </p:txBody>
       </p:sp>
-      <p:sp>
-        <p:nvSpPr>
-          <p:cNvPr id="12" name="TextBox 11"/>
-          <p:cNvSpPr txBox="1"/>
-          <p:nvPr/>
-        </p:nvSpPr>
-        <p:spPr>
-          <a:xfrm>
-            <a:off x="969264" y="960120"/>
-            <a:ext cx="5391759" cy="502920"/>
-          </a:xfrm>
-          <a:prstGeom prst="rect">
-            <a:avLst/>
-          </a:prstGeom>
-          <a:noFill/>
-        </p:spPr>
-        <p:txBody>
-          <a:bodyPr wrap="square" anchor="ctr" lIns="0" rIns="0" tIns="0" bIns="0">
-            <a:spAutoFit/>
-          </a:bodyPr>
-          <a:lstStyle/>
-          <a:p>
-            <a:pPr algn="ctr"/>
-            <a:r>
-              <a:rPr sz="1300" b="1" i="0">
-                <a:solidFill>
-                  <a:srgbClr val="1F4E79"/>
-                </a:solidFill>
-                <a:latin typeface="Microsoft YaHei"/>
-              </a:rPr>
-              <a:t>Flux WMS</a:t>
-            </a:r>
-          </a:p>
-        </p:txBody>
-      </p:sp>
-      <p:sp>
-        <p:nvSpPr>
-          <p:cNvPr id="13" name="Rounded Rectangle 12"/>
-          <p:cNvSpPr/>
-          <p:nvPr/>
-        </p:nvSpPr>
-        <p:spPr>
-          <a:xfrm>
-            <a:off x="6525615" y="960120"/>
-            <a:ext cx="5391759" cy="502920"/>
-          </a:xfrm>
-          <a:prstGeom prst="roundRect">
-            <a:avLst>
-              <a:gd name="adj" fmla="val 4000"/>
-            </a:avLst>
-          </a:prstGeom>
-          <a:solidFill>
-            <a:srgbClr val="FCFDFE"/>
-          </a:solidFill>
-          <a:ln w="12700">
-            <a:solidFill>
-              <a:srgbClr val="C9C9C9"/>
-            </a:solidFill>
-            <a:prstDash val="dash"/>
-          </a:ln>
-          <a:effectLst/>
-        </p:spPr>
-        <p:style>
-          <a:lnRef idx="1">
-            <a:schemeClr val="accent1"/>
-          </a:lnRef>
-          <a:fillRef idx="3">
-            <a:schemeClr val="accent1"/>
-          </a:fillRef>
-          <a:effectRef idx="2">
-            <a:schemeClr val="accent1"/>
-          </a:effectRef>
-          <a:fontRef idx="minor">
-            <a:schemeClr val="lt1"/>
-          </a:fontRef>
-        </p:style>
-        <p:txBody>
-          <a:bodyPr rtlCol="0" anchor="ctr"/>
-          <a:lstStyle/>
-          <a:p>
-            <a:pPr algn="ctr"/>
-          </a:p>
-        </p:txBody>
-      </p:sp>
-      <p:sp>
-        <p:nvSpPr>
-          <p:cNvPr id="14" name="TextBox 13"/>
-          <p:cNvSpPr txBox="1"/>
-          <p:nvPr/>
-        </p:nvSpPr>
-        <p:spPr>
-          <a:xfrm>
-            <a:off x="6525615" y="960120"/>
-            <a:ext cx="5391759" cy="502920"/>
-          </a:xfrm>
-          <a:prstGeom prst="rect">
-            <a:avLst/>
-          </a:prstGeom>
-          <a:noFill/>
-        </p:spPr>
-        <p:txBody>
-          <a:bodyPr wrap="square" anchor="ctr" lIns="0" rIns="0" tIns="0" bIns="0">
-            <a:spAutoFit/>
-          </a:bodyPr>
-          <a:lstStyle/>
-          <a:p>
-            <a:pPr algn="ctr"/>
-            <a:r>
-              <a:rPr sz="1300" b="1" i="0">
-                <a:solidFill>
-                  <a:srgbClr val="1F4E79"/>
-                </a:solidFill>
-                <a:latin typeface="Microsoft YaHei"/>
-              </a:rPr>
-              <a:t>飞云 WMS</a:t>
-            </a:r>
-          </a:p>
-        </p:txBody>
-      </p:sp>
       <p:cxnSp>
         <p:nvCxnSpPr>
-          <p:cNvPr id="15" name="Connector 14"/>
+          <p:cNvPr id="12" name="Connector 11"/>
           <p:cNvCxnSpPr/>
           <p:nvPr/>
         </p:nvCxnSpPr>
         <p:spPr>
           <a:xfrm>
-            <a:off x="3665143" y="1463040"/>
-            <a:ext cx="0" cy="274320"/>
+            <a:off x="3148507" y="1636775"/>
+            <a:ext cx="0" cy="237744"/>
           </a:xfrm>
           <a:prstGeom prst="line">
             <a:avLst/>
@@ -9985,7 +9863,7 @@
             <a:solidFill>
               <a:srgbClr val="8C9BB3"/>
             </a:solidFill>
-            <a:prstDash val="dash"/>
+            <a:headEnd type="triangle" w="sm" len="sm"/>
             <a:tailEnd type="triangle" w="sm" len="sm"/>
           </a:ln>
         </p:spPr>
@@ -10006,14 +9884,14 @@
       </p:cxnSp>
       <p:cxnSp>
         <p:nvCxnSpPr>
-          <p:cNvPr id="16" name="Connector 15"/>
+          <p:cNvPr id="13" name="Connector 12"/>
           <p:cNvCxnSpPr/>
           <p:nvPr/>
         </p:nvCxnSpPr>
         <p:spPr>
           <a:xfrm>
-            <a:off x="9221495" y="1463040"/>
-            <a:ext cx="0" cy="274320"/>
+            <a:off x="9043187" y="1636775"/>
+            <a:ext cx="0" cy="237744"/>
           </a:xfrm>
           <a:prstGeom prst="line">
             <a:avLst/>
@@ -10022,7 +9900,7 @@
             <a:solidFill>
               <a:srgbClr val="8C9BB3"/>
             </a:solidFill>
-            <a:prstDash val="dash"/>
+            <a:headEnd type="triangle" w="sm" len="sm"/>
             <a:tailEnd type="triangle" w="sm" len="sm"/>
           </a:ln>
         </p:spPr>
@@ -10043,14 +9921,49 @@
       </p:cxnSp>
       <p:sp>
         <p:nvSpPr>
-          <p:cNvPr id="17" name="TextBox 16"/>
+          <p:cNvPr id="14" name="TextBox 13"/>
           <p:cNvSpPr txBox="1"/>
           <p:nvPr/>
         </p:nvSpPr>
         <p:spPr>
           <a:xfrm>
-            <a:off x="3934731" y="1481328"/>
-            <a:ext cx="1463040" cy="182880"/>
+            <a:off x="3767236" y="1627631"/>
+            <a:ext cx="4657222" cy="237744"/>
+          </a:xfrm>
+          <a:prstGeom prst="rect">
+            <a:avLst/>
+          </a:prstGeom>
+          <a:noFill/>
+        </p:spPr>
+        <p:txBody>
+          <a:bodyPr wrap="square" anchor="ctr" lIns="0" rIns="0" tIns="0" bIns="0">
+            <a:spAutoFit/>
+          </a:bodyPr>
+          <a:lstStyle/>
+          <a:p>
+            <a:pPr algn="ctr"/>
+            <a:r>
+              <a:rPr sz="900" b="0" i="0">
+                <a:solidFill>
+                  <a:srgbClr val="7A7A7A"/>
+                </a:solidFill>
+                <a:latin typeface="Microsoft YaHei"/>
+              </a:rPr>
+              <a:t>任务同步：WMS 下发任务，统一进入 WCS 标准指令层</a:t>
+            </a:r>
+          </a:p>
+        </p:txBody>
+      </p:sp>
+      <p:sp>
+        <p:nvSpPr>
+          <p:cNvPr id="15" name="TextBox 14"/>
+          <p:cNvSpPr txBox="1"/>
+          <p:nvPr/>
+        </p:nvSpPr>
+        <p:spPr>
+          <a:xfrm>
+            <a:off x="274320" y="1655063"/>
+            <a:ext cx="2377440" cy="201168"/>
           </a:xfrm>
           <a:prstGeom prst="rect">
             <a:avLst/>
@@ -10065,27 +9978,27 @@
           <a:p>
             <a:pPr algn="l"/>
             <a:r>
-              <a:rPr sz="900" b="0" i="0">
-                <a:solidFill>
-                  <a:srgbClr val="7A7A7A"/>
-                </a:solidFill>
-                <a:latin typeface="Microsoft YaHei"/>
-              </a:rPr>
-              <a:t>同步</a:t>
-            </a:r>
-          </a:p>
-        </p:txBody>
-      </p:sp>
-      <p:sp>
-        <p:nvSpPr>
-          <p:cNvPr id="18" name="Rounded Rectangle 17"/>
+              <a:rPr sz="1000" b="0" i="0">
+                <a:solidFill>
+                  <a:srgbClr val="595959"/>
+                </a:solidFill>
+                <a:latin typeface="Microsoft YaHei"/>
+              </a:rPr>
+              <a:t>WCS 平台</a:t>
+            </a:r>
+          </a:p>
+        </p:txBody>
+      </p:sp>
+      <p:sp>
+        <p:nvSpPr>
+          <p:cNvPr id="16" name="Rounded Rectangle 15"/>
           <p:cNvSpPr/>
           <p:nvPr/>
         </p:nvSpPr>
         <p:spPr>
           <a:xfrm>
-            <a:off x="969264" y="1737360"/>
-            <a:ext cx="7280493" cy="4114800"/>
+            <a:off x="274320" y="1874519"/>
+            <a:ext cx="11643055" cy="4114800"/>
           </a:xfrm>
           <a:prstGeom prst="roundRect">
             <a:avLst>
@@ -10127,28 +10040,25 @@
       </p:sp>
       <p:sp>
         <p:nvSpPr>
-          <p:cNvPr id="19" name="Rounded Rectangle 18"/>
+          <p:cNvPr id="17" name="Rounded Rectangle 16"/>
           <p:cNvSpPr/>
           <p:nvPr/>
         </p:nvSpPr>
         <p:spPr>
           <a:xfrm>
-            <a:off x="8414349" y="1737360"/>
-            <a:ext cx="3503025" cy="4114800"/>
+            <a:off x="420623" y="1993391"/>
+            <a:ext cx="7548047" cy="457200"/>
           </a:xfrm>
           <a:prstGeom prst="roundRect">
             <a:avLst>
-              <a:gd name="adj" fmla="val 2000"/>
+              <a:gd name="adj" fmla="val 10000"/>
             </a:avLst>
           </a:prstGeom>
           <a:solidFill>
-            <a:srgbClr val="FCFDFE"/>
-          </a:solidFill>
-          <a:ln w="12700">
-            <a:solidFill>
-              <a:srgbClr val="9FB7D4"/>
-            </a:solidFill>
-            <a:prstDash val="dash"/>
+            <a:srgbClr val="1F4E79"/>
+          </a:solidFill>
+          <a:ln>
+            <a:noFill/>
           </a:ln>
           <a:effectLst/>
         </p:spPr>
@@ -10167,154 +10077,55 @@
           </a:fontRef>
         </p:style>
         <p:txBody>
-          <a:bodyPr rtlCol="0" anchor="ctr"/>
-          <a:lstStyle/>
-          <a:p>
-            <a:pPr algn="ctr"/>
-          </a:p>
-        </p:txBody>
-      </p:sp>
-      <p:sp>
-        <p:nvSpPr>
-          <p:cNvPr id="20" name="TextBox 19"/>
-          <p:cNvSpPr txBox="1"/>
-          <p:nvPr/>
-        </p:nvSpPr>
-        <p:spPr>
-          <a:xfrm>
-            <a:off x="1097280" y="1810512"/>
-            <a:ext cx="5817453" cy="201168"/>
-          </a:xfrm>
-          <a:prstGeom prst="rect">
-            <a:avLst/>
-          </a:prstGeom>
-          <a:noFill/>
-        </p:spPr>
-        <p:txBody>
-          <a:bodyPr wrap="square" anchor="t" lIns="0" rIns="0" tIns="0" bIns="0">
-            <a:spAutoFit/>
-          </a:bodyPr>
-          <a:lstStyle/>
-          <a:p>
-            <a:pPr algn="l"/>
-            <a:r>
-              <a:rPr sz="1200" b="1" i="0">
-                <a:solidFill>
-                  <a:srgbClr val="1F4E79"/>
+          <a:bodyPr rtlCol="0" anchor="ctr" wrap="square" tIns="12700" bIns="12700"/>
+          <a:lstStyle/>
+          <a:p>
+            <a:pPr algn="ctr"/>
+            <a:r>
+              <a:rPr sz="1300" b="1">
+                <a:solidFill>
+                  <a:srgbClr val="FFFFFF"/>
                 </a:solidFill>
                 <a:latin typeface="Microsoft YaHei"/>
               </a:rPr>
               <a:t>自动化设备调度服务</a:t>
             </a:r>
           </a:p>
-        </p:txBody>
-      </p:sp>
-      <p:sp>
-        <p:nvSpPr>
-          <p:cNvPr id="21" name="TextBox 20"/>
-          <p:cNvSpPr txBox="1"/>
-          <p:nvPr/>
-        </p:nvSpPr>
-        <p:spPr>
-          <a:xfrm>
-            <a:off x="6695277" y="1810512"/>
-            <a:ext cx="1426464" cy="201168"/>
-          </a:xfrm>
-          <a:prstGeom prst="rect">
-            <a:avLst/>
-          </a:prstGeom>
-          <a:noFill/>
-        </p:spPr>
-        <p:txBody>
-          <a:bodyPr wrap="square" anchor="t" lIns="0" rIns="0" tIns="0" bIns="0">
-            <a:spAutoFit/>
-          </a:bodyPr>
-          <a:lstStyle/>
-          <a:p>
-            <a:pPr algn="r"/>
-            <a:r>
-              <a:rPr sz="900" b="0" i="0">
-                <a:solidFill>
-                  <a:srgbClr val="7A7A7A"/>
-                </a:solidFill>
-                <a:latin typeface="Microsoft YaHei"/>
-              </a:rPr>
-              <a:t>wcs-core</a:t>
-            </a:r>
-          </a:p>
-        </p:txBody>
-      </p:sp>
-      <p:sp>
-        <p:nvSpPr>
-          <p:cNvPr id="22" name="TextBox 21"/>
-          <p:cNvSpPr txBox="1"/>
-          <p:nvPr/>
-        </p:nvSpPr>
-        <p:spPr>
-          <a:xfrm>
-            <a:off x="8414349" y="1792224"/>
-            <a:ext cx="3503025" cy="365760"/>
-          </a:xfrm>
-          <a:prstGeom prst="rect">
-            <a:avLst/>
-          </a:prstGeom>
-          <a:noFill/>
-        </p:spPr>
-        <p:txBody>
-          <a:bodyPr wrap="square" lIns="0" rIns="0" tIns="0" bIns="0">
-            <a:spAutoFit/>
-          </a:bodyPr>
-          <a:lstStyle/>
-          <a:p>
-            <a:pPr algn="ctr"/>
-            <a:r>
-              <a:rPr sz="1200" b="1">
-                <a:solidFill>
-                  <a:srgbClr val="1F4E79"/>
-                </a:solidFill>
-                <a:latin typeface="Microsoft YaHei"/>
-              </a:rPr>
-              <a:t>自动化设备可视化看板</a:t>
-            </a:r>
-          </a:p>
           <a:p>
             <a:pPr algn="ctr"/>
             <a:r>
               <a:rPr sz="900">
                 <a:solidFill>
-                  <a:srgbClr val="7A7A7A"/>
-                </a:solidFill>
-                <a:latin typeface="Microsoft YaHei"/>
-              </a:rPr>
-              <a:t>(wcs-dashboard)</a:t>
-            </a:r>
-          </a:p>
-        </p:txBody>
-      </p:sp>
-      <p:sp>
-        <p:nvSpPr>
-          <p:cNvPr id="23" name="Rounded Rectangle 22"/>
+                  <a:srgbClr val="CFE0F3"/>
+                </a:solidFill>
+                <a:latin typeface="Microsoft YaHei"/>
+              </a:rPr>
+              <a:t>wcs-core · 标准指令承接与统一调度</a:t>
+            </a:r>
+          </a:p>
+        </p:txBody>
+      </p:sp>
+      <p:sp>
+        <p:nvSpPr>
+          <p:cNvPr id="18" name="Rounded Rectangle 17"/>
           <p:cNvSpPr/>
           <p:nvPr/>
         </p:nvSpPr>
         <p:spPr>
           <a:xfrm>
-            <a:off x="1078992" y="2084832"/>
-            <a:ext cx="4159813" cy="1935601"/>
+            <a:off x="8133263" y="1993391"/>
+            <a:ext cx="3637807" cy="457200"/>
           </a:xfrm>
           <a:prstGeom prst="roundRect">
             <a:avLst>
-              <a:gd name="adj" fmla="val 3000"/>
+              <a:gd name="adj" fmla="val 10000"/>
             </a:avLst>
           </a:prstGeom>
           <a:solidFill>
-            <a:srgbClr val="FCFDFE"/>
-          </a:solidFill>
-          <a:ln w="12700">
-            <a:solidFill>
-              <a:srgbClr val="C9C9C9"/>
-            </a:solidFill>
-            <a:prstDash val="dash"/>
+            <a:srgbClr val="1F4E79"/>
+          </a:solidFill>
+          <a:ln>
+            <a:noFill/>
           </a:ln>
           <a:effectLst/>
         </p:spPr>
@@ -10333,23 +10144,44 @@
           </a:fontRef>
         </p:style>
         <p:txBody>
-          <a:bodyPr rtlCol="0" anchor="ctr"/>
-          <a:lstStyle/>
-          <a:p>
-            <a:pPr algn="ctr"/>
-          </a:p>
-        </p:txBody>
-      </p:sp>
-      <p:sp>
-        <p:nvSpPr>
-          <p:cNvPr id="24" name="TextBox 23"/>
+          <a:bodyPr rtlCol="0" anchor="ctr" wrap="square" tIns="12700" bIns="12700"/>
+          <a:lstStyle/>
+          <a:p>
+            <a:pPr algn="ctr"/>
+            <a:r>
+              <a:rPr sz="1300" b="1">
+                <a:solidFill>
+                  <a:srgbClr val="FFFFFF"/>
+                </a:solidFill>
+                <a:latin typeface="Microsoft YaHei"/>
+              </a:rPr>
+              <a:t>自动化设备可视化看板</a:t>
+            </a:r>
+          </a:p>
+          <a:p>
+            <a:pPr algn="ctr"/>
+            <a:r>
+              <a:rPr sz="900">
+                <a:solidFill>
+                  <a:srgbClr val="CFE0F3"/>
+                </a:solidFill>
+                <a:latin typeface="Microsoft YaHei"/>
+              </a:rPr>
+              <a:t>wcs-dashboard · 运行数据采集与展示</a:t>
+            </a:r>
+          </a:p>
+        </p:txBody>
+      </p:sp>
+      <p:sp>
+        <p:nvSpPr>
+          <p:cNvPr id="19" name="TextBox 18"/>
           <p:cNvSpPr txBox="1"/>
           <p:nvPr/>
         </p:nvSpPr>
         <p:spPr>
           <a:xfrm>
-            <a:off x="1170432" y="2139696"/>
-            <a:ext cx="3976933" cy="164592"/>
+            <a:off x="420623" y="2542032"/>
+            <a:ext cx="4452018" cy="164592"/>
           </a:xfrm>
           <a:prstGeom prst="rect">
             <a:avLst/>
@@ -10364,7 +10196,7 @@
           <a:p>
             <a:pPr algn="l"/>
             <a:r>
-              <a:rPr sz="950" b="1" i="0">
+              <a:rPr sz="1000" b="1" i="0">
                 <a:solidFill>
                   <a:srgbClr val="1F4E79"/>
                 </a:solidFill>
@@ -10377,14 +10209,14 @@
       </p:sp>
       <p:sp>
         <p:nvSpPr>
-          <p:cNvPr id="25" name="TextBox 24"/>
+          <p:cNvPr id="20" name="TextBox 19"/>
           <p:cNvSpPr txBox="1"/>
           <p:nvPr/>
         </p:nvSpPr>
         <p:spPr>
           <a:xfrm>
-            <a:off x="1170432" y="2139696"/>
-            <a:ext cx="3976933" cy="164592"/>
+            <a:off x="420623" y="2542032"/>
+            <a:ext cx="4452018" cy="164592"/>
           </a:xfrm>
           <a:prstGeom prst="rect">
             <a:avLst/>
@@ -10399,7 +10231,7 @@
           <a:p>
             <a:pPr algn="r"/>
             <a:r>
-              <a:rPr sz="750" b="0" i="0">
+              <a:rPr sz="800" b="0" i="0">
                 <a:solidFill>
                   <a:srgbClr val="7A7A7A"/>
                 </a:solidFill>
@@ -10412,14 +10244,14 @@
       </p:sp>
       <p:sp>
         <p:nvSpPr>
-          <p:cNvPr id="26" name="Rounded Rectangle 25"/>
+          <p:cNvPr id="21" name="Rounded Rectangle 20"/>
           <p:cNvSpPr/>
           <p:nvPr/>
         </p:nvSpPr>
         <p:spPr>
           <a:xfrm>
-            <a:off x="1170432" y="2359152"/>
-            <a:ext cx="1301260" cy="374172"/>
+            <a:off x="420623" y="2743200"/>
+            <a:ext cx="1459622" cy="359267"/>
           </a:xfrm>
           <a:prstGeom prst="roundRect">
             <a:avLst>
@@ -10456,7 +10288,7 @@
           <a:p>
             <a:pPr algn="ctr"/>
             <a:r>
-              <a:rPr sz="850" b="0">
+              <a:rPr sz="900" b="1">
                 <a:solidFill>
                   <a:srgbClr val="262626"/>
                 </a:solidFill>
@@ -10469,14 +10301,14 @@
       </p:sp>
       <p:sp>
         <p:nvSpPr>
-          <p:cNvPr id="27" name="Rounded Rectangle 26"/>
+          <p:cNvPr id="22" name="Rounded Rectangle 21"/>
           <p:cNvSpPr/>
           <p:nvPr/>
         </p:nvSpPr>
         <p:spPr>
           <a:xfrm>
-            <a:off x="2508268" y="2359152"/>
-            <a:ext cx="1301260" cy="374172"/>
+            <a:off x="1916822" y="2743200"/>
+            <a:ext cx="1459622" cy="359267"/>
           </a:xfrm>
           <a:prstGeom prst="roundRect">
             <a:avLst>
@@ -10513,7 +10345,7 @@
           <a:p>
             <a:pPr algn="ctr"/>
             <a:r>
-              <a:rPr sz="850" b="0">
+              <a:rPr sz="900" b="1">
                 <a:solidFill>
                   <a:srgbClr val="262626"/>
                 </a:solidFill>
@@ -10526,14 +10358,14 @@
       </p:sp>
       <p:sp>
         <p:nvSpPr>
-          <p:cNvPr id="28" name="Rounded Rectangle 27"/>
+          <p:cNvPr id="23" name="Rounded Rectangle 22"/>
           <p:cNvSpPr/>
           <p:nvPr/>
         </p:nvSpPr>
         <p:spPr>
           <a:xfrm>
-            <a:off x="3846104" y="2359152"/>
-            <a:ext cx="1301260" cy="374172"/>
+            <a:off x="3413020" y="2743200"/>
+            <a:ext cx="1459622" cy="359267"/>
           </a:xfrm>
           <a:prstGeom prst="roundRect">
             <a:avLst>
@@ -10570,7 +10402,7 @@
           <a:p>
             <a:pPr algn="ctr"/>
             <a:r>
-              <a:rPr sz="850" b="0">
+              <a:rPr sz="900" b="1">
                 <a:solidFill>
                   <a:srgbClr val="262626"/>
                 </a:solidFill>
@@ -10583,14 +10415,14 @@
       </p:sp>
       <p:sp>
         <p:nvSpPr>
-          <p:cNvPr id="29" name="Rounded Rectangle 28"/>
+          <p:cNvPr id="24" name="Rounded Rectangle 23"/>
           <p:cNvSpPr/>
           <p:nvPr/>
         </p:nvSpPr>
         <p:spPr>
           <a:xfrm>
-            <a:off x="1170432" y="2769900"/>
-            <a:ext cx="1301260" cy="374172"/>
+            <a:off x="420623" y="3139043"/>
+            <a:ext cx="1459622" cy="359267"/>
           </a:xfrm>
           <a:prstGeom prst="roundRect">
             <a:avLst>
@@ -10627,7 +10459,7 @@
           <a:p>
             <a:pPr algn="ctr"/>
             <a:r>
-              <a:rPr sz="850" b="0">
+              <a:rPr sz="900" b="1">
                 <a:solidFill>
                   <a:srgbClr val="262626"/>
                 </a:solidFill>
@@ -10640,14 +10472,14 @@
       </p:sp>
       <p:sp>
         <p:nvSpPr>
-          <p:cNvPr id="30" name="Rounded Rectangle 29"/>
+          <p:cNvPr id="25" name="Rounded Rectangle 24"/>
           <p:cNvSpPr/>
           <p:nvPr/>
         </p:nvSpPr>
         <p:spPr>
           <a:xfrm>
-            <a:off x="2508268" y="2769900"/>
-            <a:ext cx="1301260" cy="374172"/>
+            <a:off x="1916822" y="3139043"/>
+            <a:ext cx="1459622" cy="359267"/>
           </a:xfrm>
           <a:prstGeom prst="roundRect">
             <a:avLst>
@@ -10684,7 +10516,7 @@
           <a:p>
             <a:pPr algn="ctr"/>
             <a:r>
-              <a:rPr sz="850" b="0">
+              <a:rPr sz="900" b="1">
                 <a:solidFill>
                   <a:srgbClr val="262626"/>
                 </a:solidFill>
@@ -10697,14 +10529,14 @@
       </p:sp>
       <p:sp>
         <p:nvSpPr>
-          <p:cNvPr id="31" name="Rounded Rectangle 30"/>
+          <p:cNvPr id="26" name="Rounded Rectangle 25"/>
           <p:cNvSpPr/>
           <p:nvPr/>
         </p:nvSpPr>
         <p:spPr>
           <a:xfrm>
-            <a:off x="3846104" y="2769900"/>
-            <a:ext cx="1301260" cy="374172"/>
+            <a:off x="3413020" y="3139043"/>
+            <a:ext cx="1459622" cy="359267"/>
           </a:xfrm>
           <a:prstGeom prst="roundRect">
             <a:avLst>
@@ -10741,7 +10573,7 @@
           <a:p>
             <a:pPr algn="ctr"/>
             <a:r>
-              <a:rPr sz="850" b="0">
+              <a:rPr sz="900" b="1">
                 <a:solidFill>
                   <a:srgbClr val="262626"/>
                 </a:solidFill>
@@ -10754,14 +10586,14 @@
       </p:sp>
       <p:sp>
         <p:nvSpPr>
-          <p:cNvPr id="32" name="Rounded Rectangle 31"/>
+          <p:cNvPr id="27" name="Rounded Rectangle 26"/>
           <p:cNvSpPr/>
           <p:nvPr/>
         </p:nvSpPr>
         <p:spPr>
           <a:xfrm>
-            <a:off x="1170432" y="3180648"/>
-            <a:ext cx="1301260" cy="374172"/>
+            <a:off x="420623" y="3534887"/>
+            <a:ext cx="1459622" cy="359267"/>
           </a:xfrm>
           <a:prstGeom prst="roundRect">
             <a:avLst>
@@ -10798,7 +10630,7 @@
           <a:p>
             <a:pPr algn="ctr"/>
             <a:r>
-              <a:rPr sz="850" b="0">
+              <a:rPr sz="900" b="1">
                 <a:solidFill>
                   <a:srgbClr val="262626"/>
                 </a:solidFill>
@@ -10811,14 +10643,14 @@
       </p:sp>
       <p:sp>
         <p:nvSpPr>
-          <p:cNvPr id="33" name="Rounded Rectangle 32"/>
+          <p:cNvPr id="28" name="Rounded Rectangle 27"/>
           <p:cNvSpPr/>
           <p:nvPr/>
         </p:nvSpPr>
         <p:spPr>
           <a:xfrm>
-            <a:off x="2508268" y="3180648"/>
-            <a:ext cx="1301260" cy="374172"/>
+            <a:off x="1916822" y="3534887"/>
+            <a:ext cx="1459622" cy="359267"/>
           </a:xfrm>
           <a:prstGeom prst="roundRect">
             <a:avLst>
@@ -10855,7 +10687,7 @@
           <a:p>
             <a:pPr algn="ctr"/>
             <a:r>
-              <a:rPr sz="850" b="0">
+              <a:rPr sz="900" b="1">
                 <a:solidFill>
                   <a:srgbClr val="262626"/>
                 </a:solidFill>
@@ -10868,14 +10700,14 @@
       </p:sp>
       <p:sp>
         <p:nvSpPr>
-          <p:cNvPr id="34" name="Rounded Rectangle 33"/>
+          <p:cNvPr id="29" name="Rounded Rectangle 28"/>
           <p:cNvSpPr/>
           <p:nvPr/>
         </p:nvSpPr>
         <p:spPr>
           <a:xfrm>
-            <a:off x="3846104" y="3180648"/>
-            <a:ext cx="1301260" cy="374172"/>
+            <a:off x="3413020" y="3534887"/>
+            <a:ext cx="1459622" cy="359267"/>
           </a:xfrm>
           <a:prstGeom prst="roundRect">
             <a:avLst>
@@ -10912,7 +10744,7 @@
           <a:p>
             <a:pPr algn="ctr"/>
             <a:r>
-              <a:rPr sz="850" b="0">
+              <a:rPr sz="900" b="1">
                 <a:solidFill>
                   <a:srgbClr val="262626"/>
                 </a:solidFill>
@@ -10925,14 +10757,14 @@
       </p:sp>
       <p:sp>
         <p:nvSpPr>
-          <p:cNvPr id="35" name="Rounded Rectangle 34"/>
+          <p:cNvPr id="30" name="Rounded Rectangle 29"/>
           <p:cNvSpPr/>
           <p:nvPr/>
         </p:nvSpPr>
         <p:spPr>
           <a:xfrm>
-            <a:off x="1170432" y="3591397"/>
-            <a:ext cx="1301260" cy="374172"/>
+            <a:off x="420623" y="3930731"/>
+            <a:ext cx="1459622" cy="359267"/>
           </a:xfrm>
           <a:prstGeom prst="roundRect">
             <a:avLst>
@@ -10969,7 +10801,7 @@
           <a:p>
             <a:pPr algn="ctr"/>
             <a:r>
-              <a:rPr sz="850" b="0">
+              <a:rPr sz="900" b="1">
                 <a:solidFill>
                   <a:srgbClr val="262626"/>
                 </a:solidFill>
@@ -10982,14 +10814,14 @@
       </p:sp>
       <p:sp>
         <p:nvSpPr>
-          <p:cNvPr id="36" name="Rounded Rectangle 35"/>
+          <p:cNvPr id="31" name="Rounded Rectangle 30"/>
           <p:cNvSpPr/>
           <p:nvPr/>
         </p:nvSpPr>
         <p:spPr>
           <a:xfrm>
-            <a:off x="2508268" y="3591397"/>
-            <a:ext cx="1301260" cy="374172"/>
+            <a:off x="1916822" y="3930731"/>
+            <a:ext cx="1459622" cy="359267"/>
           </a:xfrm>
           <a:prstGeom prst="roundRect">
             <a:avLst>
@@ -11026,7 +10858,7 @@
           <a:p>
             <a:pPr algn="ctr"/>
             <a:r>
-              <a:rPr sz="850" b="0">
+              <a:rPr sz="900" b="1">
                 <a:solidFill>
                   <a:srgbClr val="262626"/>
                 </a:solidFill>
@@ -11039,14 +10871,14 @@
       </p:sp>
       <p:sp>
         <p:nvSpPr>
-          <p:cNvPr id="37" name="Rounded Rectangle 36"/>
+          <p:cNvPr id="32" name="Rounded Rectangle 31"/>
           <p:cNvSpPr/>
           <p:nvPr/>
         </p:nvSpPr>
         <p:spPr>
           <a:xfrm>
-            <a:off x="3846104" y="3591397"/>
-            <a:ext cx="1301260" cy="374172"/>
+            <a:off x="3413020" y="3930731"/>
+            <a:ext cx="1459622" cy="359267"/>
           </a:xfrm>
           <a:prstGeom prst="roundRect">
             <a:avLst>
@@ -11083,7 +10915,7 @@
           <a:p>
             <a:pPr algn="ctr"/>
             <a:r>
-              <a:rPr sz="850" b="0">
+              <a:rPr sz="900" b="1">
                 <a:solidFill>
                   <a:srgbClr val="262626"/>
                 </a:solidFill>
@@ -11096,63 +10928,14 @@
       </p:sp>
       <p:sp>
         <p:nvSpPr>
-          <p:cNvPr id="38" name="Rounded Rectangle 37"/>
-          <p:cNvSpPr/>
-          <p:nvPr/>
-        </p:nvSpPr>
-        <p:spPr>
-          <a:xfrm>
-            <a:off x="5366821" y="2084832"/>
-            <a:ext cx="2773208" cy="1935601"/>
-          </a:xfrm>
-          <a:prstGeom prst="roundRect">
-            <a:avLst>
-              <a:gd name="adj" fmla="val 3000"/>
-            </a:avLst>
-          </a:prstGeom>
-          <a:solidFill>
-            <a:srgbClr val="FCFDFE"/>
-          </a:solidFill>
-          <a:ln w="12700">
-            <a:solidFill>
-              <a:srgbClr val="C9C9C9"/>
-            </a:solidFill>
-            <a:prstDash val="dash"/>
-          </a:ln>
-          <a:effectLst/>
-        </p:spPr>
-        <p:style>
-          <a:lnRef idx="1">
-            <a:schemeClr val="accent1"/>
-          </a:lnRef>
-          <a:fillRef idx="3">
-            <a:schemeClr val="accent1"/>
-          </a:fillRef>
-          <a:effectRef idx="2">
-            <a:schemeClr val="accent1"/>
-          </a:effectRef>
-          <a:fontRef idx="minor">
-            <a:schemeClr val="lt1"/>
-          </a:fontRef>
-        </p:style>
-        <p:txBody>
-          <a:bodyPr rtlCol="0" anchor="ctr"/>
-          <a:lstStyle/>
-          <a:p>
-            <a:pPr algn="ctr"/>
-          </a:p>
-        </p:txBody>
-      </p:sp>
-      <p:sp>
-        <p:nvSpPr>
-          <p:cNvPr id="39" name="TextBox 38"/>
+          <p:cNvPr id="33" name="TextBox 32"/>
           <p:cNvSpPr txBox="1"/>
           <p:nvPr/>
         </p:nvSpPr>
         <p:spPr>
           <a:xfrm>
-            <a:off x="5458261" y="2139696"/>
-            <a:ext cx="2590328" cy="164592"/>
+            <a:off x="5000658" y="2542032"/>
+            <a:ext cx="2968012" cy="164592"/>
           </a:xfrm>
           <a:prstGeom prst="rect">
             <a:avLst/>
@@ -11167,7 +10950,7 @@
           <a:p>
             <a:pPr algn="l"/>
             <a:r>
-              <a:rPr sz="950" b="1" i="0">
+              <a:rPr sz="1000" b="1" i="0">
                 <a:solidFill>
                   <a:srgbClr val="1F4E79"/>
                 </a:solidFill>
@@ -11180,14 +10963,14 @@
       </p:sp>
       <p:sp>
         <p:nvSpPr>
-          <p:cNvPr id="40" name="TextBox 39"/>
+          <p:cNvPr id="34" name="TextBox 33"/>
           <p:cNvSpPr txBox="1"/>
           <p:nvPr/>
         </p:nvSpPr>
         <p:spPr>
           <a:xfrm>
-            <a:off x="5458261" y="2139696"/>
-            <a:ext cx="2590328" cy="164592"/>
+            <a:off x="5000658" y="2542032"/>
+            <a:ext cx="2968012" cy="164592"/>
           </a:xfrm>
           <a:prstGeom prst="rect">
             <a:avLst/>
@@ -11202,7 +10985,7 @@
           <a:p>
             <a:pPr algn="r"/>
             <a:r>
-              <a:rPr sz="750" b="0" i="0">
+              <a:rPr sz="800" b="0" i="0">
                 <a:solidFill>
                   <a:srgbClr val="7A7A7A"/>
                 </a:solidFill>
@@ -11215,14 +10998,14 @@
       </p:sp>
       <p:sp>
         <p:nvSpPr>
-          <p:cNvPr id="41" name="Rounded Rectangle 40"/>
+          <p:cNvPr id="35" name="Rounded Rectangle 34"/>
           <p:cNvSpPr/>
           <p:nvPr/>
         </p:nvSpPr>
         <p:spPr>
           <a:xfrm>
-            <a:off x="5458261" y="2359152"/>
-            <a:ext cx="1276876" cy="374172"/>
+            <a:off x="5000658" y="2743200"/>
+            <a:ext cx="1465718" cy="359267"/>
           </a:xfrm>
           <a:prstGeom prst="roundRect">
             <a:avLst>
@@ -11259,7 +11042,7 @@
           <a:p>
             <a:pPr algn="ctr"/>
             <a:r>
-              <a:rPr sz="850" b="0">
+              <a:rPr sz="900" b="1">
                 <a:solidFill>
                   <a:srgbClr val="262626"/>
                 </a:solidFill>
@@ -11272,14 +11055,14 @@
       </p:sp>
       <p:sp>
         <p:nvSpPr>
-          <p:cNvPr id="42" name="Rounded Rectangle 41"/>
+          <p:cNvPr id="36" name="Rounded Rectangle 35"/>
           <p:cNvSpPr/>
           <p:nvPr/>
         </p:nvSpPr>
         <p:spPr>
           <a:xfrm>
-            <a:off x="6771713" y="2359152"/>
-            <a:ext cx="1276876" cy="374172"/>
+            <a:off x="6502953" y="2743200"/>
+            <a:ext cx="1465718" cy="359267"/>
           </a:xfrm>
           <a:prstGeom prst="roundRect">
             <a:avLst>
@@ -11316,7 +11099,7 @@
           <a:p>
             <a:pPr algn="ctr"/>
             <a:r>
-              <a:rPr sz="850" b="0">
+              <a:rPr sz="900" b="1">
                 <a:solidFill>
                   <a:srgbClr val="262626"/>
                 </a:solidFill>
@@ -11329,14 +11112,14 @@
       </p:sp>
       <p:sp>
         <p:nvSpPr>
-          <p:cNvPr id="43" name="Rounded Rectangle 42"/>
+          <p:cNvPr id="37" name="Rounded Rectangle 36"/>
           <p:cNvSpPr/>
           <p:nvPr/>
         </p:nvSpPr>
         <p:spPr>
           <a:xfrm>
-            <a:off x="5458261" y="2769900"/>
-            <a:ext cx="1276876" cy="374172"/>
+            <a:off x="5000658" y="3139043"/>
+            <a:ext cx="1465718" cy="359267"/>
           </a:xfrm>
           <a:prstGeom prst="roundRect">
             <a:avLst>
@@ -11373,7 +11156,7 @@
           <a:p>
             <a:pPr algn="ctr"/>
             <a:r>
-              <a:rPr sz="850" b="0">
+              <a:rPr sz="900" b="1">
                 <a:solidFill>
                   <a:srgbClr val="262626"/>
                 </a:solidFill>
@@ -11386,14 +11169,14 @@
       </p:sp>
       <p:sp>
         <p:nvSpPr>
-          <p:cNvPr id="44" name="Rounded Rectangle 43"/>
+          <p:cNvPr id="38" name="Rounded Rectangle 37"/>
           <p:cNvSpPr/>
           <p:nvPr/>
         </p:nvSpPr>
         <p:spPr>
           <a:xfrm>
-            <a:off x="6771713" y="2769900"/>
-            <a:ext cx="1276876" cy="374172"/>
+            <a:off x="6502953" y="3139043"/>
+            <a:ext cx="1465718" cy="359267"/>
           </a:xfrm>
           <a:prstGeom prst="roundRect">
             <a:avLst>
@@ -11430,7 +11213,7 @@
           <a:p>
             <a:pPr algn="ctr"/>
             <a:r>
-              <a:rPr sz="850" b="0">
+              <a:rPr sz="900" b="1">
                 <a:solidFill>
                   <a:srgbClr val="262626"/>
                 </a:solidFill>
@@ -11443,14 +11226,14 @@
       </p:sp>
       <p:sp>
         <p:nvSpPr>
-          <p:cNvPr id="45" name="Rounded Rectangle 44"/>
+          <p:cNvPr id="39" name="Rounded Rectangle 38"/>
           <p:cNvSpPr/>
           <p:nvPr/>
         </p:nvSpPr>
         <p:spPr>
           <a:xfrm>
-            <a:off x="5458261" y="3180648"/>
-            <a:ext cx="1276876" cy="374172"/>
+            <a:off x="5000658" y="3534887"/>
+            <a:ext cx="1465718" cy="359267"/>
           </a:xfrm>
           <a:prstGeom prst="roundRect">
             <a:avLst>
@@ -11487,7 +11270,7 @@
           <a:p>
             <a:pPr algn="ctr"/>
             <a:r>
-              <a:rPr sz="850" b="0">
+              <a:rPr sz="900" b="1">
                 <a:solidFill>
                   <a:srgbClr val="262626"/>
                 </a:solidFill>
@@ -11500,14 +11283,14 @@
       </p:sp>
       <p:sp>
         <p:nvSpPr>
-          <p:cNvPr id="46" name="Rounded Rectangle 45"/>
+          <p:cNvPr id="40" name="Rounded Rectangle 39"/>
           <p:cNvSpPr/>
           <p:nvPr/>
         </p:nvSpPr>
         <p:spPr>
           <a:xfrm>
-            <a:off x="6771713" y="3180648"/>
-            <a:ext cx="1276876" cy="374172"/>
+            <a:off x="6502953" y="3534887"/>
+            <a:ext cx="1465718" cy="359267"/>
           </a:xfrm>
           <a:prstGeom prst="roundRect">
             <a:avLst>
@@ -11544,7 +11327,7 @@
           <a:p>
             <a:pPr algn="ctr"/>
             <a:r>
-              <a:rPr sz="850" b="0">
+              <a:rPr sz="900" b="1">
                 <a:solidFill>
                   <a:srgbClr val="262626"/>
                 </a:solidFill>
@@ -11557,14 +11340,14 @@
       </p:sp>
       <p:sp>
         <p:nvSpPr>
-          <p:cNvPr id="47" name="Rounded Rectangle 46"/>
+          <p:cNvPr id="41" name="Rounded Rectangle 40"/>
           <p:cNvSpPr/>
           <p:nvPr/>
         </p:nvSpPr>
         <p:spPr>
           <a:xfrm>
-            <a:off x="5458261" y="3591397"/>
-            <a:ext cx="1276876" cy="374172"/>
+            <a:off x="5000658" y="3930731"/>
+            <a:ext cx="1465718" cy="359267"/>
           </a:xfrm>
           <a:prstGeom prst="roundRect">
             <a:avLst>
@@ -11601,7 +11384,7 @@
           <a:p>
             <a:pPr algn="ctr"/>
             <a:r>
-              <a:rPr sz="850" b="0">
+              <a:rPr sz="900" b="1">
                 <a:solidFill>
                   <a:srgbClr val="262626"/>
                 </a:solidFill>
@@ -11614,14 +11397,14 @@
       </p:sp>
       <p:sp>
         <p:nvSpPr>
-          <p:cNvPr id="48" name="Rounded Rectangle 47"/>
+          <p:cNvPr id="42" name="Rounded Rectangle 41"/>
           <p:cNvSpPr/>
           <p:nvPr/>
         </p:nvSpPr>
         <p:spPr>
           <a:xfrm>
-            <a:off x="6771713" y="3591397"/>
-            <a:ext cx="1276876" cy="374172"/>
+            <a:off x="6502953" y="3930731"/>
+            <a:ext cx="1465718" cy="359267"/>
           </a:xfrm>
           <a:prstGeom prst="roundRect">
             <a:avLst>
@@ -11658,7 +11441,7 @@
           <a:p>
             <a:pPr algn="ctr"/>
             <a:r>
-              <a:rPr sz="850" b="0">
+              <a:rPr sz="900" b="1">
                 <a:solidFill>
                   <a:srgbClr val="262626"/>
                 </a:solidFill>
@@ -11671,63 +11454,14 @@
       </p:sp>
       <p:sp>
         <p:nvSpPr>
-          <p:cNvPr id="49" name="Rounded Rectangle 48"/>
-          <p:cNvSpPr/>
-          <p:nvPr/>
-        </p:nvSpPr>
-        <p:spPr>
-          <a:xfrm>
-            <a:off x="1078992" y="4111873"/>
-            <a:ext cx="2736632" cy="1648846"/>
-          </a:xfrm>
-          <a:prstGeom prst="roundRect">
-            <a:avLst>
-              <a:gd name="adj" fmla="val 3000"/>
-            </a:avLst>
-          </a:prstGeom>
-          <a:solidFill>
-            <a:srgbClr val="FCFDFE"/>
-          </a:solidFill>
-          <a:ln w="12700">
-            <a:solidFill>
-              <a:srgbClr val="C9C9C9"/>
-            </a:solidFill>
-            <a:prstDash val="dash"/>
-          </a:ln>
-          <a:effectLst/>
-        </p:spPr>
-        <p:style>
-          <a:lnRef idx="1">
-            <a:schemeClr val="accent1"/>
-          </a:lnRef>
-          <a:fillRef idx="3">
-            <a:schemeClr val="accent1"/>
-          </a:fillRef>
-          <a:effectRef idx="2">
-            <a:schemeClr val="accent1"/>
-          </a:effectRef>
-          <a:fontRef idx="minor">
-            <a:schemeClr val="lt1"/>
-          </a:fontRef>
-        </p:style>
-        <p:txBody>
-          <a:bodyPr rtlCol="0" anchor="ctr"/>
-          <a:lstStyle/>
-          <a:p>
-            <a:pPr algn="ctr"/>
-          </a:p>
-        </p:txBody>
-      </p:sp>
-      <p:sp>
-        <p:nvSpPr>
-          <p:cNvPr id="50" name="TextBox 49"/>
+          <p:cNvPr id="43" name="TextBox 42"/>
           <p:cNvSpPr txBox="1"/>
           <p:nvPr/>
         </p:nvSpPr>
         <p:spPr>
           <a:xfrm>
-            <a:off x="1170432" y="4166737"/>
-            <a:ext cx="2553752" cy="164592"/>
+            <a:off x="420623" y="4381439"/>
+            <a:ext cx="2931436" cy="164592"/>
           </a:xfrm>
           <a:prstGeom prst="rect">
             <a:avLst/>
@@ -11742,7 +11476,7 @@
           <a:p>
             <a:pPr algn="l"/>
             <a:r>
-              <a:rPr sz="950" b="1" i="0">
+              <a:rPr sz="1000" b="1" i="0">
                 <a:solidFill>
                   <a:srgbClr val="1F4E79"/>
                 </a:solidFill>
@@ -11755,14 +11489,14 @@
       </p:sp>
       <p:sp>
         <p:nvSpPr>
-          <p:cNvPr id="51" name="TextBox 50"/>
+          <p:cNvPr id="44" name="TextBox 43"/>
           <p:cNvSpPr txBox="1"/>
           <p:nvPr/>
         </p:nvSpPr>
         <p:spPr>
           <a:xfrm>
-            <a:off x="1170432" y="4166737"/>
-            <a:ext cx="2553752" cy="164592"/>
+            <a:off x="420623" y="4381439"/>
+            <a:ext cx="2931436" cy="164592"/>
           </a:xfrm>
           <a:prstGeom prst="rect">
             <a:avLst/>
@@ -11777,7 +11511,7 @@
           <a:p>
             <a:pPr algn="r"/>
             <a:r>
-              <a:rPr sz="750" b="0" i="0">
+              <a:rPr sz="800" b="0" i="0">
                 <a:solidFill>
                   <a:srgbClr val="7A7A7A"/>
                 </a:solidFill>
@@ -11790,14 +11524,14 @@
       </p:sp>
       <p:sp>
         <p:nvSpPr>
-          <p:cNvPr id="52" name="Rounded Rectangle 51"/>
+          <p:cNvPr id="45" name="Rounded Rectangle 44"/>
           <p:cNvSpPr/>
           <p:nvPr/>
         </p:nvSpPr>
         <p:spPr>
           <a:xfrm>
-            <a:off x="1170432" y="4386193"/>
-            <a:ext cx="1258588" cy="302483"/>
+            <a:off x="420623" y="4582607"/>
+            <a:ext cx="1447430" cy="294528"/>
           </a:xfrm>
           <a:prstGeom prst="roundRect">
             <a:avLst>
@@ -11834,7 +11568,7 @@
           <a:p>
             <a:pPr algn="ctr"/>
             <a:r>
-              <a:rPr sz="850" b="0">
+              <a:rPr sz="900" b="1">
                 <a:solidFill>
                   <a:srgbClr val="262626"/>
                 </a:solidFill>
@@ -11847,14 +11581,14 @@
       </p:sp>
       <p:sp>
         <p:nvSpPr>
-          <p:cNvPr id="53" name="Rounded Rectangle 52"/>
+          <p:cNvPr id="46" name="Rounded Rectangle 45"/>
           <p:cNvSpPr/>
           <p:nvPr/>
         </p:nvSpPr>
         <p:spPr>
           <a:xfrm>
-            <a:off x="2465596" y="4386193"/>
-            <a:ext cx="1258588" cy="302483"/>
+            <a:off x="1904630" y="4582607"/>
+            <a:ext cx="1447430" cy="294528"/>
           </a:xfrm>
           <a:prstGeom prst="roundRect">
             <a:avLst>
@@ -11891,7 +11625,7 @@
           <a:p>
             <a:pPr algn="ctr"/>
             <a:r>
-              <a:rPr sz="850" b="0">
+              <a:rPr sz="900" b="1">
                 <a:solidFill>
                   <a:srgbClr val="262626"/>
                 </a:solidFill>
@@ -11904,14 +11638,14 @@
       </p:sp>
       <p:sp>
         <p:nvSpPr>
-          <p:cNvPr id="54" name="Rounded Rectangle 53"/>
+          <p:cNvPr id="47" name="Rounded Rectangle 46"/>
           <p:cNvSpPr/>
           <p:nvPr/>
         </p:nvSpPr>
         <p:spPr>
           <a:xfrm>
-            <a:off x="1170432" y="4725253"/>
-            <a:ext cx="1258588" cy="302483"/>
+            <a:off x="420623" y="4913711"/>
+            <a:ext cx="1447430" cy="294528"/>
           </a:xfrm>
           <a:prstGeom prst="roundRect">
             <a:avLst>
@@ -11948,7 +11682,7 @@
           <a:p>
             <a:pPr algn="ctr"/>
             <a:r>
-              <a:rPr sz="850" b="0">
+              <a:rPr sz="900" b="1">
                 <a:solidFill>
                   <a:srgbClr val="262626"/>
                 </a:solidFill>
@@ -11961,14 +11695,14 @@
       </p:sp>
       <p:sp>
         <p:nvSpPr>
-          <p:cNvPr id="55" name="Rounded Rectangle 54"/>
+          <p:cNvPr id="48" name="Rounded Rectangle 47"/>
           <p:cNvSpPr/>
           <p:nvPr/>
         </p:nvSpPr>
         <p:spPr>
           <a:xfrm>
-            <a:off x="2465596" y="4725253"/>
-            <a:ext cx="1258588" cy="302483"/>
+            <a:off x="1904630" y="4913711"/>
+            <a:ext cx="1447430" cy="294528"/>
           </a:xfrm>
           <a:prstGeom prst="roundRect">
             <a:avLst>
@@ -12005,7 +11739,7 @@
           <a:p>
             <a:pPr algn="ctr"/>
             <a:r>
-              <a:rPr sz="850" b="0">
+              <a:rPr sz="900" b="1">
                 <a:solidFill>
                   <a:srgbClr val="262626"/>
                 </a:solidFill>
@@ -12018,14 +11752,14 @@
       </p:sp>
       <p:sp>
         <p:nvSpPr>
-          <p:cNvPr id="56" name="Rounded Rectangle 55"/>
+          <p:cNvPr id="49" name="Rounded Rectangle 48"/>
           <p:cNvSpPr/>
           <p:nvPr/>
         </p:nvSpPr>
         <p:spPr>
           <a:xfrm>
-            <a:off x="1170432" y="5064312"/>
-            <a:ext cx="1258588" cy="302483"/>
+            <a:off x="420623" y="5244815"/>
+            <a:ext cx="1447430" cy="294528"/>
           </a:xfrm>
           <a:prstGeom prst="roundRect">
             <a:avLst>
@@ -12062,7 +11796,7 @@
           <a:p>
             <a:pPr algn="ctr"/>
             <a:r>
-              <a:rPr sz="850" b="0">
+              <a:rPr sz="900" b="1">
                 <a:solidFill>
                   <a:srgbClr val="262626"/>
                 </a:solidFill>
@@ -12075,14 +11809,14 @@
       </p:sp>
       <p:sp>
         <p:nvSpPr>
-          <p:cNvPr id="57" name="Rounded Rectangle 56"/>
+          <p:cNvPr id="50" name="Rounded Rectangle 49"/>
           <p:cNvSpPr/>
           <p:nvPr/>
         </p:nvSpPr>
         <p:spPr>
           <a:xfrm>
-            <a:off x="2465596" y="5064312"/>
-            <a:ext cx="1258588" cy="302483"/>
+            <a:off x="1904630" y="5244815"/>
+            <a:ext cx="1447430" cy="294528"/>
           </a:xfrm>
           <a:prstGeom prst="roundRect">
             <a:avLst>
@@ -12119,7 +11853,7 @@
           <a:p>
             <a:pPr algn="ctr"/>
             <a:r>
-              <a:rPr sz="850" b="0">
+              <a:rPr sz="900" b="1">
                 <a:solidFill>
                   <a:srgbClr val="262626"/>
                 </a:solidFill>
@@ -12132,14 +11866,14 @@
       </p:sp>
       <p:sp>
         <p:nvSpPr>
-          <p:cNvPr id="58" name="Rounded Rectangle 57"/>
+          <p:cNvPr id="51" name="Rounded Rectangle 50"/>
           <p:cNvSpPr/>
           <p:nvPr/>
         </p:nvSpPr>
         <p:spPr>
           <a:xfrm>
-            <a:off x="1170432" y="5403372"/>
-            <a:ext cx="2553752" cy="302483"/>
+            <a:off x="420623" y="5575919"/>
+            <a:ext cx="2931436" cy="294528"/>
           </a:xfrm>
           <a:prstGeom prst="roundRect">
             <a:avLst>
@@ -12176,7 +11910,7 @@
           <a:p>
             <a:pPr algn="ctr"/>
             <a:r>
-              <a:rPr sz="850" b="0">
+              <a:rPr sz="900" b="1">
                 <a:solidFill>
                   <a:srgbClr val="262626"/>
                 </a:solidFill>
@@ -12189,63 +11923,14 @@
       </p:sp>
       <p:sp>
         <p:nvSpPr>
-          <p:cNvPr id="59" name="Rounded Rectangle 58"/>
-          <p:cNvSpPr/>
-          <p:nvPr/>
-        </p:nvSpPr>
-        <p:spPr>
-          <a:xfrm>
-            <a:off x="3925352" y="4111873"/>
-            <a:ext cx="2736632" cy="1648846"/>
-          </a:xfrm>
-          <a:prstGeom prst="roundRect">
-            <a:avLst>
-              <a:gd name="adj" fmla="val 3000"/>
-            </a:avLst>
-          </a:prstGeom>
-          <a:solidFill>
-            <a:srgbClr val="FCFDFE"/>
-          </a:solidFill>
-          <a:ln w="12700">
-            <a:solidFill>
-              <a:srgbClr val="C9C9C9"/>
-            </a:solidFill>
-            <a:prstDash val="dash"/>
-          </a:ln>
-          <a:effectLst/>
-        </p:spPr>
-        <p:style>
-          <a:lnRef idx="1">
-            <a:schemeClr val="accent1"/>
-          </a:lnRef>
-          <a:fillRef idx="3">
-            <a:schemeClr val="accent1"/>
-          </a:fillRef>
-          <a:effectRef idx="2">
-            <a:schemeClr val="accent1"/>
-          </a:effectRef>
-          <a:fontRef idx="minor">
-            <a:schemeClr val="lt1"/>
-          </a:fontRef>
-        </p:style>
-        <p:txBody>
-          <a:bodyPr rtlCol="0" anchor="ctr"/>
-          <a:lstStyle/>
-          <a:p>
-            <a:pPr algn="ctr"/>
-          </a:p>
-        </p:txBody>
-      </p:sp>
-      <p:sp>
-        <p:nvSpPr>
-          <p:cNvPr id="60" name="TextBox 59"/>
+          <p:cNvPr id="52" name="TextBox 51"/>
           <p:cNvSpPr txBox="1"/>
           <p:nvPr/>
         </p:nvSpPr>
         <p:spPr>
           <a:xfrm>
-            <a:off x="4016792" y="4166737"/>
-            <a:ext cx="2553752" cy="164592"/>
+            <a:off x="3461788" y="4381439"/>
+            <a:ext cx="2931436" cy="164592"/>
           </a:xfrm>
           <a:prstGeom prst="rect">
             <a:avLst/>
@@ -12260,7 +11945,7 @@
           <a:p>
             <a:pPr algn="l"/>
             <a:r>
-              <a:rPr sz="950" b="1" i="0">
+              <a:rPr sz="1000" b="1" i="0">
                 <a:solidFill>
                   <a:srgbClr val="1F4E79"/>
                 </a:solidFill>
@@ -12273,14 +11958,14 @@
       </p:sp>
       <p:sp>
         <p:nvSpPr>
-          <p:cNvPr id="61" name="TextBox 60"/>
+          <p:cNvPr id="53" name="TextBox 52"/>
           <p:cNvSpPr txBox="1"/>
           <p:nvPr/>
         </p:nvSpPr>
         <p:spPr>
           <a:xfrm>
-            <a:off x="4016792" y="4166737"/>
-            <a:ext cx="2553752" cy="164592"/>
+            <a:off x="3461788" y="4381439"/>
+            <a:ext cx="2931436" cy="164592"/>
           </a:xfrm>
           <a:prstGeom prst="rect">
             <a:avLst/>
@@ -12295,7 +11980,7 @@
           <a:p>
             <a:pPr algn="r"/>
             <a:r>
-              <a:rPr sz="750" b="0" i="0">
+              <a:rPr sz="800" b="0" i="0">
                 <a:solidFill>
                   <a:srgbClr val="7A7A7A"/>
                 </a:solidFill>
@@ -12308,14 +11993,14 @@
       </p:sp>
       <p:sp>
         <p:nvSpPr>
-          <p:cNvPr id="62" name="Rounded Rectangle 61"/>
+          <p:cNvPr id="54" name="Rounded Rectangle 53"/>
           <p:cNvSpPr/>
           <p:nvPr/>
         </p:nvSpPr>
         <p:spPr>
           <a:xfrm>
-            <a:off x="4016792" y="4386193"/>
-            <a:ext cx="1258588" cy="415503"/>
+            <a:off x="3461788" y="4582607"/>
+            <a:ext cx="1447430" cy="404896"/>
           </a:xfrm>
           <a:prstGeom prst="roundRect">
             <a:avLst>
@@ -12352,7 +12037,7 @@
           <a:p>
             <a:pPr algn="ctr"/>
             <a:r>
-              <a:rPr sz="850" b="0">
+              <a:rPr sz="900" b="1">
                 <a:solidFill>
                   <a:srgbClr val="262626"/>
                 </a:solidFill>
@@ -12365,14 +12050,14 @@
       </p:sp>
       <p:sp>
         <p:nvSpPr>
-          <p:cNvPr id="63" name="Rounded Rectangle 62"/>
+          <p:cNvPr id="55" name="Rounded Rectangle 54"/>
           <p:cNvSpPr/>
           <p:nvPr/>
         </p:nvSpPr>
         <p:spPr>
           <a:xfrm>
-            <a:off x="5311957" y="4386193"/>
-            <a:ext cx="1258588" cy="415503"/>
+            <a:off x="4945794" y="4582607"/>
+            <a:ext cx="1447430" cy="404896"/>
           </a:xfrm>
           <a:prstGeom prst="roundRect">
             <a:avLst>
@@ -12409,7 +12094,7 @@
           <a:p>
             <a:pPr algn="ctr"/>
             <a:r>
-              <a:rPr sz="850" b="0">
+              <a:rPr sz="900" b="1">
                 <a:solidFill>
                   <a:srgbClr val="262626"/>
                 </a:solidFill>
@@ -12422,14 +12107,14 @@
       </p:sp>
       <p:sp>
         <p:nvSpPr>
-          <p:cNvPr id="64" name="Rounded Rectangle 63"/>
+          <p:cNvPr id="56" name="Rounded Rectangle 55"/>
           <p:cNvSpPr/>
           <p:nvPr/>
         </p:nvSpPr>
         <p:spPr>
           <a:xfrm>
-            <a:off x="4016792" y="4838273"/>
-            <a:ext cx="1258588" cy="415503"/>
+            <a:off x="3461788" y="5024079"/>
+            <a:ext cx="1447430" cy="404896"/>
           </a:xfrm>
           <a:prstGeom prst="roundRect">
             <a:avLst>
@@ -12466,7 +12151,7 @@
           <a:p>
             <a:pPr algn="ctr"/>
             <a:r>
-              <a:rPr sz="850" b="0">
+              <a:rPr sz="900" b="1">
                 <a:solidFill>
                   <a:srgbClr val="262626"/>
                 </a:solidFill>
@@ -12479,14 +12164,14 @@
       </p:sp>
       <p:sp>
         <p:nvSpPr>
-          <p:cNvPr id="65" name="Rounded Rectangle 64"/>
+          <p:cNvPr id="57" name="Rounded Rectangle 56"/>
           <p:cNvSpPr/>
           <p:nvPr/>
         </p:nvSpPr>
         <p:spPr>
           <a:xfrm>
-            <a:off x="5311957" y="4838273"/>
-            <a:ext cx="1258588" cy="415503"/>
+            <a:off x="4945794" y="5024079"/>
+            <a:ext cx="1447430" cy="404896"/>
           </a:xfrm>
           <a:prstGeom prst="roundRect">
             <a:avLst>
@@ -12523,7 +12208,7 @@
           <a:p>
             <a:pPr algn="ctr"/>
             <a:r>
-              <a:rPr sz="850" b="0">
+              <a:rPr sz="900" b="1">
                 <a:solidFill>
                   <a:srgbClr val="262626"/>
                 </a:solidFill>
@@ -12536,14 +12221,14 @@
       </p:sp>
       <p:sp>
         <p:nvSpPr>
-          <p:cNvPr id="66" name="Rounded Rectangle 65"/>
+          <p:cNvPr id="58" name="Rounded Rectangle 57"/>
           <p:cNvSpPr/>
           <p:nvPr/>
         </p:nvSpPr>
         <p:spPr>
           <a:xfrm>
-            <a:off x="4016792" y="5290352"/>
-            <a:ext cx="2553752" cy="415503"/>
+            <a:off x="3461788" y="5465551"/>
+            <a:ext cx="2931436" cy="404896"/>
           </a:xfrm>
           <a:prstGeom prst="roundRect">
             <a:avLst>
@@ -12580,7 +12265,7 @@
           <a:p>
             <a:pPr algn="ctr"/>
             <a:r>
-              <a:rPr sz="850" b="0">
+              <a:rPr sz="900" b="1">
                 <a:solidFill>
                   <a:srgbClr val="262626"/>
                 </a:solidFill>
@@ -12593,63 +12278,14 @@
       </p:sp>
       <p:sp>
         <p:nvSpPr>
-          <p:cNvPr id="67" name="Rounded Rectangle 66"/>
-          <p:cNvSpPr/>
-          <p:nvPr/>
-        </p:nvSpPr>
-        <p:spPr>
-          <a:xfrm>
-            <a:off x="6771713" y="4111873"/>
-            <a:ext cx="1368316" cy="1648846"/>
-          </a:xfrm>
-          <a:prstGeom prst="roundRect">
-            <a:avLst>
-              <a:gd name="adj" fmla="val 3000"/>
-            </a:avLst>
-          </a:prstGeom>
-          <a:solidFill>
-            <a:srgbClr val="FCFDFE"/>
-          </a:solidFill>
-          <a:ln w="12700">
-            <a:solidFill>
-              <a:srgbClr val="C9C9C9"/>
-            </a:solidFill>
-            <a:prstDash val="dash"/>
-          </a:ln>
-          <a:effectLst/>
-        </p:spPr>
-        <p:style>
-          <a:lnRef idx="1">
-            <a:schemeClr val="accent1"/>
-          </a:lnRef>
-          <a:fillRef idx="3">
-            <a:schemeClr val="accent1"/>
-          </a:fillRef>
-          <a:effectRef idx="2">
-            <a:schemeClr val="accent1"/>
-          </a:effectRef>
-          <a:fontRef idx="minor">
-            <a:schemeClr val="lt1"/>
-          </a:fontRef>
-        </p:style>
-        <p:txBody>
-          <a:bodyPr rtlCol="0" anchor="ctr"/>
-          <a:lstStyle/>
-          <a:p>
-            <a:pPr algn="ctr"/>
-          </a:p>
-        </p:txBody>
-      </p:sp>
-      <p:sp>
-        <p:nvSpPr>
-          <p:cNvPr id="68" name="TextBox 67"/>
+          <p:cNvPr id="59" name="TextBox 58"/>
           <p:cNvSpPr txBox="1"/>
           <p:nvPr/>
         </p:nvSpPr>
         <p:spPr>
           <a:xfrm>
-            <a:off x="6863153" y="4166737"/>
-            <a:ext cx="1185436" cy="164592"/>
+            <a:off x="6502953" y="4381439"/>
+            <a:ext cx="1465718" cy="164592"/>
           </a:xfrm>
           <a:prstGeom prst="rect">
             <a:avLst/>
@@ -12664,7 +12300,7 @@
           <a:p>
             <a:pPr algn="l"/>
             <a:r>
-              <a:rPr sz="950" b="1" i="0">
+              <a:rPr sz="1000" b="1" i="0">
                 <a:solidFill>
                   <a:srgbClr val="1F4E79"/>
                 </a:solidFill>
@@ -12677,14 +12313,14 @@
       </p:sp>
       <p:sp>
         <p:nvSpPr>
-          <p:cNvPr id="69" name="TextBox 68"/>
+          <p:cNvPr id="60" name="TextBox 59"/>
           <p:cNvSpPr txBox="1"/>
           <p:nvPr/>
         </p:nvSpPr>
         <p:spPr>
           <a:xfrm>
-            <a:off x="6863153" y="4166737"/>
-            <a:ext cx="1185436" cy="164592"/>
+            <a:off x="6502953" y="4381439"/>
+            <a:ext cx="1465718" cy="164592"/>
           </a:xfrm>
           <a:prstGeom prst="rect">
             <a:avLst/>
@@ -12699,7 +12335,7 @@
           <a:p>
             <a:pPr algn="r"/>
             <a:r>
-              <a:rPr sz="750" b="0" i="0">
+              <a:rPr sz="800" b="0" i="0">
                 <a:solidFill>
                   <a:srgbClr val="7A7A7A"/>
                 </a:solidFill>
@@ -12712,14 +12348,14 @@
       </p:sp>
       <p:sp>
         <p:nvSpPr>
-          <p:cNvPr id="70" name="Rounded Rectangle 69"/>
+          <p:cNvPr id="61" name="Rounded Rectangle 60"/>
           <p:cNvSpPr/>
           <p:nvPr/>
         </p:nvSpPr>
         <p:spPr>
           <a:xfrm>
-            <a:off x="6863153" y="4386193"/>
-            <a:ext cx="1185436" cy="415503"/>
+            <a:off x="6502953" y="4582607"/>
+            <a:ext cx="1465718" cy="404896"/>
           </a:xfrm>
           <a:prstGeom prst="roundRect">
             <a:avLst>
@@ -12756,7 +12392,7 @@
           <a:p>
             <a:pPr algn="ctr"/>
             <a:r>
-              <a:rPr sz="850" b="0">
+              <a:rPr sz="900" b="1">
                 <a:solidFill>
                   <a:srgbClr val="262626"/>
                 </a:solidFill>
@@ -12769,14 +12405,14 @@
       </p:sp>
       <p:sp>
         <p:nvSpPr>
-          <p:cNvPr id="71" name="Rounded Rectangle 70"/>
+          <p:cNvPr id="62" name="Rounded Rectangle 61"/>
           <p:cNvSpPr/>
           <p:nvPr/>
         </p:nvSpPr>
         <p:spPr>
           <a:xfrm>
-            <a:off x="6863153" y="4838273"/>
-            <a:ext cx="1185436" cy="415503"/>
+            <a:off x="6502953" y="5024079"/>
+            <a:ext cx="1465718" cy="404896"/>
           </a:xfrm>
           <a:prstGeom prst="roundRect">
             <a:avLst>
@@ -12813,7 +12449,7 @@
           <a:p>
             <a:pPr algn="ctr"/>
             <a:r>
-              <a:rPr sz="850" b="0">
+              <a:rPr sz="900" b="1">
                 <a:solidFill>
                   <a:srgbClr val="262626"/>
                 </a:solidFill>
@@ -12826,14 +12462,14 @@
       </p:sp>
       <p:sp>
         <p:nvSpPr>
-          <p:cNvPr id="72" name="Rounded Rectangle 71"/>
+          <p:cNvPr id="63" name="Rounded Rectangle 62"/>
           <p:cNvSpPr/>
           <p:nvPr/>
         </p:nvSpPr>
         <p:spPr>
           <a:xfrm>
-            <a:off x="6863153" y="5290352"/>
-            <a:ext cx="1185436" cy="415503"/>
+            <a:off x="6502953" y="5465551"/>
+            <a:ext cx="1465718" cy="404896"/>
           </a:xfrm>
           <a:prstGeom prst="roundRect">
             <a:avLst>
@@ -12870,7 +12506,7 @@
           <a:p>
             <a:pPr algn="ctr"/>
             <a:r>
-              <a:rPr sz="850" b="0">
+              <a:rPr sz="900" b="1">
                 <a:solidFill>
                   <a:srgbClr val="262626"/>
                 </a:solidFill>
@@ -12883,63 +12519,14 @@
       </p:sp>
       <p:sp>
         <p:nvSpPr>
-          <p:cNvPr id="73" name="Rounded Rectangle 72"/>
-          <p:cNvSpPr/>
-          <p:nvPr/>
-        </p:nvSpPr>
-        <p:spPr>
-          <a:xfrm>
-            <a:off x="8524077" y="2231136"/>
-            <a:ext cx="1577776" cy="3529584"/>
-          </a:xfrm>
-          <a:prstGeom prst="roundRect">
-            <a:avLst>
-              <a:gd name="adj" fmla="val 3000"/>
-            </a:avLst>
-          </a:prstGeom>
-          <a:solidFill>
-            <a:srgbClr val="FCFDFE"/>
-          </a:solidFill>
-          <a:ln w="12700">
-            <a:solidFill>
-              <a:srgbClr val="C9C9C9"/>
-            </a:solidFill>
-            <a:prstDash val="dash"/>
-          </a:ln>
-          <a:effectLst/>
-        </p:spPr>
-        <p:style>
-          <a:lnRef idx="1">
-            <a:schemeClr val="accent1"/>
-          </a:lnRef>
-          <a:fillRef idx="3">
-            <a:schemeClr val="accent1"/>
-          </a:fillRef>
-          <a:effectRef idx="2">
-            <a:schemeClr val="accent1"/>
-          </a:effectRef>
-          <a:fontRef idx="minor">
-            <a:schemeClr val="lt1"/>
-          </a:fontRef>
-        </p:style>
-        <p:txBody>
-          <a:bodyPr rtlCol="0" anchor="ctr"/>
-          <a:lstStyle/>
-          <a:p>
-            <a:pPr algn="ctr"/>
-          </a:p>
-        </p:txBody>
-      </p:sp>
-      <p:sp>
-        <p:nvSpPr>
-          <p:cNvPr id="74" name="TextBox 73"/>
+          <p:cNvPr id="64" name="TextBox 63"/>
           <p:cNvSpPr txBox="1"/>
           <p:nvPr/>
         </p:nvSpPr>
         <p:spPr>
           <a:xfrm>
-            <a:off x="8615517" y="2286000"/>
-            <a:ext cx="1394896" cy="164592"/>
+            <a:off x="8133263" y="2542032"/>
+            <a:ext cx="1754895" cy="164592"/>
           </a:xfrm>
           <a:prstGeom prst="rect">
             <a:avLst/>
@@ -12954,7 +12541,7 @@
           <a:p>
             <a:pPr algn="l"/>
             <a:r>
-              <a:rPr sz="950" b="1" i="0">
+              <a:rPr sz="1000" b="1" i="0">
                 <a:solidFill>
                   <a:srgbClr val="1F4E79"/>
                 </a:solidFill>
@@ -12967,14 +12554,14 @@
       </p:sp>
       <p:sp>
         <p:nvSpPr>
-          <p:cNvPr id="75" name="TextBox 74"/>
+          <p:cNvPr id="65" name="TextBox 64"/>
           <p:cNvSpPr txBox="1"/>
           <p:nvPr/>
         </p:nvSpPr>
         <p:spPr>
           <a:xfrm>
-            <a:off x="8615517" y="2286000"/>
-            <a:ext cx="1394896" cy="164592"/>
+            <a:off x="8133263" y="2542032"/>
+            <a:ext cx="1754895" cy="164592"/>
           </a:xfrm>
           <a:prstGeom prst="rect">
             <a:avLst/>
@@ -12989,7 +12576,7 @@
           <a:p>
             <a:pPr algn="r"/>
             <a:r>
-              <a:rPr sz="750" b="0" i="0">
+              <a:rPr sz="800" b="0" i="0">
                 <a:solidFill>
                   <a:srgbClr val="7A7A7A"/>
                 </a:solidFill>
@@ -13002,14 +12589,14 @@
       </p:sp>
       <p:sp>
         <p:nvSpPr>
-          <p:cNvPr id="76" name="Rounded Rectangle 75"/>
+          <p:cNvPr id="66" name="Rounded Rectangle 65"/>
           <p:cNvSpPr/>
           <p:nvPr/>
         </p:nvSpPr>
         <p:spPr>
           <a:xfrm>
-            <a:off x="8615517" y="2505456"/>
-            <a:ext cx="1394896" cy="772668"/>
+            <a:off x="8133263" y="2743200"/>
+            <a:ext cx="1754895" cy="754380"/>
           </a:xfrm>
           <a:prstGeom prst="roundRect">
             <a:avLst>
@@ -13046,7 +12633,7 @@
           <a:p>
             <a:pPr algn="ctr"/>
             <a:r>
-              <a:rPr sz="850" b="0">
+              <a:rPr sz="900" b="1">
                 <a:solidFill>
                   <a:srgbClr val="262626"/>
                 </a:solidFill>
@@ -13059,14 +12646,14 @@
       </p:sp>
       <p:sp>
         <p:nvSpPr>
-          <p:cNvPr id="77" name="Rounded Rectangle 76"/>
+          <p:cNvPr id="67" name="Rounded Rectangle 66"/>
           <p:cNvSpPr/>
           <p:nvPr/>
         </p:nvSpPr>
         <p:spPr>
           <a:xfrm>
-            <a:off x="8615517" y="3314700"/>
-            <a:ext cx="1394896" cy="772668"/>
+            <a:off x="8133263" y="3534156"/>
+            <a:ext cx="1754895" cy="754380"/>
           </a:xfrm>
           <a:prstGeom prst="roundRect">
             <a:avLst>
@@ -13103,7 +12690,7 @@
           <a:p>
             <a:pPr algn="ctr"/>
             <a:r>
-              <a:rPr sz="850" b="0">
+              <a:rPr sz="900" b="1">
                 <a:solidFill>
                   <a:srgbClr val="262626"/>
                 </a:solidFill>
@@ -13116,14 +12703,14 @@
       </p:sp>
       <p:sp>
         <p:nvSpPr>
-          <p:cNvPr id="78" name="Rounded Rectangle 77"/>
+          <p:cNvPr id="68" name="Rounded Rectangle 67"/>
           <p:cNvSpPr/>
           <p:nvPr/>
         </p:nvSpPr>
         <p:spPr>
           <a:xfrm>
-            <a:off x="8615517" y="4123944"/>
-            <a:ext cx="1394896" cy="772668"/>
+            <a:off x="8133263" y="4325112"/>
+            <a:ext cx="1754895" cy="754380"/>
           </a:xfrm>
           <a:prstGeom prst="roundRect">
             <a:avLst>
@@ -13160,7 +12747,7 @@
           <a:p>
             <a:pPr algn="ctr"/>
             <a:r>
-              <a:rPr sz="850" b="0">
+              <a:rPr sz="900" b="1">
                 <a:solidFill>
                   <a:srgbClr val="262626"/>
                 </a:solidFill>
@@ -13173,14 +12760,14 @@
       </p:sp>
       <p:sp>
         <p:nvSpPr>
-          <p:cNvPr id="79" name="Rounded Rectangle 78"/>
+          <p:cNvPr id="69" name="Rounded Rectangle 68"/>
           <p:cNvSpPr/>
           <p:nvPr/>
         </p:nvSpPr>
         <p:spPr>
           <a:xfrm>
-            <a:off x="8615517" y="4933188"/>
-            <a:ext cx="1394896" cy="772668"/>
+            <a:off x="8133263" y="5116068"/>
+            <a:ext cx="1754895" cy="754380"/>
           </a:xfrm>
           <a:prstGeom prst="roundRect">
             <a:avLst>
@@ -13217,7 +12804,7 @@
           <a:p>
             <a:pPr algn="ctr"/>
             <a:r>
-              <a:rPr sz="850" b="0">
+              <a:rPr sz="900" b="1">
                 <a:solidFill>
                   <a:srgbClr val="262626"/>
                 </a:solidFill>
@@ -13230,63 +12817,14 @@
       </p:sp>
       <p:sp>
         <p:nvSpPr>
-          <p:cNvPr id="80" name="Rounded Rectangle 79"/>
-          <p:cNvSpPr/>
-          <p:nvPr/>
-        </p:nvSpPr>
-        <p:spPr>
-          <a:xfrm>
-            <a:off x="10229870" y="2231136"/>
-            <a:ext cx="1577776" cy="3529584"/>
-          </a:xfrm>
-          <a:prstGeom prst="roundRect">
-            <a:avLst>
-              <a:gd name="adj" fmla="val 3000"/>
-            </a:avLst>
-          </a:prstGeom>
-          <a:solidFill>
-            <a:srgbClr val="FCFDFE"/>
-          </a:solidFill>
-          <a:ln w="12700">
-            <a:solidFill>
-              <a:srgbClr val="C9C9C9"/>
-            </a:solidFill>
-            <a:prstDash val="dash"/>
-          </a:ln>
-          <a:effectLst/>
-        </p:spPr>
-        <p:style>
-          <a:lnRef idx="1">
-            <a:schemeClr val="accent1"/>
-          </a:lnRef>
-          <a:fillRef idx="3">
-            <a:schemeClr val="accent1"/>
-          </a:fillRef>
-          <a:effectRef idx="2">
-            <a:schemeClr val="accent1"/>
-          </a:effectRef>
-          <a:fontRef idx="minor">
-            <a:schemeClr val="lt1"/>
-          </a:fontRef>
-        </p:style>
-        <p:txBody>
-          <a:bodyPr rtlCol="0" anchor="ctr"/>
-          <a:lstStyle/>
-          <a:p>
-            <a:pPr algn="ctr"/>
-          </a:p>
-        </p:txBody>
-      </p:sp>
-      <p:sp>
-        <p:nvSpPr>
-          <p:cNvPr id="81" name="TextBox 80"/>
+          <p:cNvPr id="70" name="TextBox 69"/>
           <p:cNvSpPr txBox="1"/>
           <p:nvPr/>
         </p:nvSpPr>
         <p:spPr>
           <a:xfrm>
-            <a:off x="10321310" y="2286000"/>
-            <a:ext cx="1394896" cy="164592"/>
+            <a:off x="10016175" y="2542032"/>
+            <a:ext cx="1754895" cy="164592"/>
           </a:xfrm>
           <a:prstGeom prst="rect">
             <a:avLst/>
@@ -13301,7 +12839,7 @@
           <a:p>
             <a:pPr algn="l"/>
             <a:r>
-              <a:rPr sz="950" b="1" i="0">
+              <a:rPr sz="1000" b="1" i="0">
                 <a:solidFill>
                   <a:srgbClr val="1F4E79"/>
                 </a:solidFill>
@@ -13314,14 +12852,14 @@
       </p:sp>
       <p:sp>
         <p:nvSpPr>
-          <p:cNvPr id="82" name="TextBox 81"/>
+          <p:cNvPr id="71" name="TextBox 70"/>
           <p:cNvSpPr txBox="1"/>
           <p:nvPr/>
         </p:nvSpPr>
         <p:spPr>
           <a:xfrm>
-            <a:off x="10321310" y="2286000"/>
-            <a:ext cx="1394896" cy="164592"/>
+            <a:off x="10016175" y="2542032"/>
+            <a:ext cx="1754895" cy="164592"/>
           </a:xfrm>
           <a:prstGeom prst="rect">
             <a:avLst/>
@@ -13336,7 +12874,7 @@
           <a:p>
             <a:pPr algn="r"/>
             <a:r>
-              <a:rPr sz="750" b="0" i="0">
+              <a:rPr sz="800" b="0" i="0">
                 <a:solidFill>
                   <a:srgbClr val="7A7A7A"/>
                 </a:solidFill>
@@ -13349,14 +12887,14 @@
       </p:sp>
       <p:sp>
         <p:nvSpPr>
-          <p:cNvPr id="83" name="Rounded Rectangle 82"/>
+          <p:cNvPr id="72" name="Rounded Rectangle 71"/>
           <p:cNvSpPr/>
           <p:nvPr/>
         </p:nvSpPr>
         <p:spPr>
           <a:xfrm>
-            <a:off x="10321310" y="2505456"/>
-            <a:ext cx="1394896" cy="772668"/>
+            <a:off x="10016175" y="2743200"/>
+            <a:ext cx="1754895" cy="754380"/>
           </a:xfrm>
           <a:prstGeom prst="roundRect">
             <a:avLst>
@@ -13393,7 +12931,7 @@
           <a:p>
             <a:pPr algn="ctr"/>
             <a:r>
-              <a:rPr sz="850" b="0">
+              <a:rPr sz="900" b="1">
                 <a:solidFill>
                   <a:srgbClr val="262626"/>
                 </a:solidFill>
@@ -13406,14 +12944,14 @@
       </p:sp>
       <p:sp>
         <p:nvSpPr>
-          <p:cNvPr id="84" name="Rounded Rectangle 83"/>
+          <p:cNvPr id="73" name="Rounded Rectangle 72"/>
           <p:cNvSpPr/>
           <p:nvPr/>
         </p:nvSpPr>
         <p:spPr>
           <a:xfrm>
-            <a:off x="10321310" y="3314700"/>
-            <a:ext cx="1394896" cy="772668"/>
+            <a:off x="10016175" y="3534156"/>
+            <a:ext cx="1754895" cy="754380"/>
           </a:xfrm>
           <a:prstGeom prst="roundRect">
             <a:avLst>
@@ -13450,7 +12988,7 @@
           <a:p>
             <a:pPr algn="ctr"/>
             <a:r>
-              <a:rPr sz="850" b="0">
+              <a:rPr sz="900" b="1">
                 <a:solidFill>
                   <a:srgbClr val="262626"/>
                 </a:solidFill>
@@ -13463,14 +13001,14 @@
       </p:sp>
       <p:sp>
         <p:nvSpPr>
-          <p:cNvPr id="85" name="Rounded Rectangle 84"/>
+          <p:cNvPr id="74" name="Rounded Rectangle 73"/>
           <p:cNvSpPr/>
           <p:nvPr/>
         </p:nvSpPr>
         <p:spPr>
           <a:xfrm>
-            <a:off x="10321310" y="4123944"/>
-            <a:ext cx="1394896" cy="772668"/>
+            <a:off x="10016175" y="4325112"/>
+            <a:ext cx="1754895" cy="754380"/>
           </a:xfrm>
           <a:prstGeom prst="roundRect">
             <a:avLst>
@@ -13507,7 +13045,7 @@
           <a:p>
             <a:pPr algn="ctr"/>
             <a:r>
-              <a:rPr sz="850" b="0">
+              <a:rPr sz="900" b="1">
                 <a:solidFill>
                   <a:srgbClr val="262626"/>
                 </a:solidFill>
@@ -13520,14 +13058,14 @@
       </p:sp>
       <p:sp>
         <p:nvSpPr>
-          <p:cNvPr id="86" name="Rounded Rectangle 85"/>
+          <p:cNvPr id="75" name="Rounded Rectangle 74"/>
           <p:cNvSpPr/>
           <p:nvPr/>
         </p:nvSpPr>
         <p:spPr>
           <a:xfrm>
-            <a:off x="10321310" y="4933188"/>
-            <a:ext cx="1394896" cy="772668"/>
+            <a:off x="10016175" y="5116068"/>
+            <a:ext cx="1754895" cy="754380"/>
           </a:xfrm>
           <a:prstGeom prst="roundRect">
             <a:avLst>
@@ -13564,7 +13102,7 @@
           <a:p>
             <a:pPr algn="ctr"/>
             <a:r>
-              <a:rPr sz="850" b="0">
+              <a:rPr sz="900" b="1">
                 <a:solidFill>
                   <a:srgbClr val="262626"/>
                 </a:solidFill>
@@ -13577,14 +13115,14 @@
       </p:sp>
       <p:cxnSp>
         <p:nvCxnSpPr>
-          <p:cNvPr id="87" name="Connector 86"/>
+          <p:cNvPr id="76" name="Connector 75"/>
           <p:cNvCxnSpPr/>
           <p:nvPr/>
         </p:nvCxnSpPr>
         <p:spPr>
           <a:xfrm>
-            <a:off x="4609510" y="5852160"/>
-            <a:ext cx="0" cy="228600"/>
+            <a:off x="4194647" y="6016752"/>
+            <a:ext cx="0" cy="237744"/>
           </a:xfrm>
           <a:prstGeom prst="line">
             <a:avLst/>
@@ -13593,7 +13131,6 @@
             <a:solidFill>
               <a:srgbClr val="8C9BB3"/>
             </a:solidFill>
-            <a:prstDash val="dash"/>
             <a:headEnd type="triangle" w="sm" len="sm"/>
             <a:tailEnd type="triangle" w="sm" len="sm"/>
           </a:ln>
@@ -13613,51 +13150,16 @@
           </a:fontRef>
         </p:style>
       </p:cxnSp>
-      <p:sp>
-        <p:nvSpPr>
-          <p:cNvPr id="88" name="TextBox 87"/>
-          <p:cNvSpPr txBox="1"/>
-          <p:nvPr/>
-        </p:nvSpPr>
-        <p:spPr>
-          <a:xfrm>
-            <a:off x="4700950" y="5870448"/>
-            <a:ext cx="914400" cy="182880"/>
-          </a:xfrm>
-          <a:prstGeom prst="rect">
-            <a:avLst/>
-          </a:prstGeom>
-          <a:noFill/>
-        </p:spPr>
-        <p:txBody>
-          <a:bodyPr wrap="square" anchor="t" lIns="0" rIns="0" tIns="0" bIns="0">
-            <a:spAutoFit/>
-          </a:bodyPr>
-          <a:lstStyle/>
-          <a:p>
-            <a:pPr algn="l"/>
-            <a:r>
-              <a:rPr sz="900" b="0" i="0">
-                <a:solidFill>
-                  <a:srgbClr val="7A7A7A"/>
-                </a:solidFill>
-                <a:latin typeface="Microsoft YaHei"/>
-              </a:rPr>
-              <a:t>同步</a:t>
-            </a:r>
-          </a:p>
-        </p:txBody>
-      </p:sp>
       <p:cxnSp>
         <p:nvCxnSpPr>
-          <p:cNvPr id="89" name="Connector 88"/>
+          <p:cNvPr id="77" name="Connector 76"/>
           <p:cNvCxnSpPr/>
           <p:nvPr/>
         </p:nvCxnSpPr>
         <p:spPr>
           <a:xfrm>
-            <a:off x="10165862" y="5852160"/>
-            <a:ext cx="0" cy="228600"/>
+            <a:off x="9952167" y="6016752"/>
+            <a:ext cx="0" cy="237744"/>
           </a:xfrm>
           <a:prstGeom prst="line">
             <a:avLst/>
@@ -13666,7 +13168,6 @@
             <a:solidFill>
               <a:srgbClr val="8C9BB3"/>
             </a:solidFill>
-            <a:prstDash val="dash"/>
             <a:headEnd type="triangle" w="sm" len="sm"/>
             <a:tailEnd type="triangle" w="sm" len="sm"/>
           </a:ln>
@@ -13688,14 +13189,49 @@
       </p:cxnSp>
       <p:sp>
         <p:nvSpPr>
-          <p:cNvPr id="90" name="TextBox 89"/>
+          <p:cNvPr id="78" name="TextBox 77"/>
           <p:cNvSpPr txBox="1"/>
           <p:nvPr/>
         </p:nvSpPr>
         <p:spPr>
           <a:xfrm>
-            <a:off x="10257302" y="5870448"/>
-            <a:ext cx="914400" cy="182880"/>
+            <a:off x="3767236" y="6007608"/>
+            <a:ext cx="4657222" cy="237744"/>
+          </a:xfrm>
+          <a:prstGeom prst="rect">
+            <a:avLst/>
+          </a:prstGeom>
+          <a:noFill/>
+        </p:spPr>
+        <p:txBody>
+          <a:bodyPr wrap="square" anchor="ctr" lIns="0" rIns="0" tIns="0" bIns="0">
+            <a:spAutoFit/>
+          </a:bodyPr>
+          <a:lstStyle/>
+          <a:p>
+            <a:pPr algn="ctr"/>
+            <a:r>
+              <a:rPr sz="900" b="0" i="0">
+                <a:solidFill>
+                  <a:srgbClr val="7A7A7A"/>
+                </a:solidFill>
+                <a:latin typeface="Microsoft YaHei"/>
+              </a:rPr>
+              <a:t>执行指令下发 / 运行状态同步，经 WCS 与设备执行层衔接</a:t>
+            </a:r>
+          </a:p>
+        </p:txBody>
+      </p:sp>
+      <p:sp>
+        <p:nvSpPr>
+          <p:cNvPr id="79" name="TextBox 78"/>
+          <p:cNvSpPr txBox="1"/>
+          <p:nvPr/>
+        </p:nvSpPr>
+        <p:spPr>
+          <a:xfrm>
+            <a:off x="274320" y="6035040"/>
+            <a:ext cx="5486400" cy="201168"/>
           </a:xfrm>
           <a:prstGeom prst="rect">
             <a:avLst/>
@@ -13710,41 +13246,40 @@
           <a:p>
             <a:pPr algn="l"/>
             <a:r>
-              <a:rPr sz="900" b="0" i="0">
-                <a:solidFill>
-                  <a:srgbClr val="7A7A7A"/>
-                </a:solidFill>
-                <a:latin typeface="Microsoft YaHei"/>
-              </a:rPr>
-              <a:t>异步</a:t>
-            </a:r>
-          </a:p>
-        </p:txBody>
-      </p:sp>
-      <p:sp>
-        <p:nvSpPr>
-          <p:cNvPr id="91" name="Rounded Rectangle 90"/>
+              <a:rPr sz="1000" b="1" i="0">
+                <a:solidFill>
+                  <a:srgbClr val="595959"/>
+                </a:solidFill>
+                <a:latin typeface="Microsoft YaHei"/>
+              </a:rPr>
+              <a:t>下游 · 自动化设备执行层</a:t>
+            </a:r>
+          </a:p>
+        </p:txBody>
+      </p:sp>
+      <p:sp>
+        <p:nvSpPr>
+          <p:cNvPr id="80" name="Rounded Rectangle 79"/>
           <p:cNvSpPr/>
           <p:nvPr/>
         </p:nvSpPr>
         <p:spPr>
           <a:xfrm>
-            <a:off x="969264" y="6080760"/>
-            <a:ext cx="10948111" cy="457200"/>
+            <a:off x="274320" y="6254496"/>
+            <a:ext cx="1008583" cy="237744"/>
           </a:xfrm>
           <a:prstGeom prst="roundRect">
             <a:avLst>
-              <a:gd name="adj" fmla="val 6000"/>
+              <a:gd name="adj" fmla="val 18000"/>
             </a:avLst>
           </a:prstGeom>
           <a:solidFill>
-            <a:srgbClr val="FCFDFE"/>
-          </a:solidFill>
-          <a:ln w="12700">
+            <a:srgbClr val="F5F6F7"/>
+          </a:solidFill>
+          <a:ln w="6350">
             <a:solidFill>
               <a:srgbClr val="C9C9C9"/>
             </a:solidFill>
-            <a:prstDash val="dash"/>
           </a:ln>
           <a:effectLst/>
         </p:spPr>
@@ -13772,26 +13307,61 @@
       </p:sp>
       <p:sp>
         <p:nvSpPr>
-          <p:cNvPr id="92" name="Rounded Rectangle 91"/>
+          <p:cNvPr id="81" name="TextBox 80"/>
+          <p:cNvSpPr txBox="1"/>
+          <p:nvPr/>
+        </p:nvSpPr>
+        <p:spPr>
+          <a:xfrm>
+            <a:off x="274320" y="6254496"/>
+            <a:ext cx="1008583" cy="237744"/>
+          </a:xfrm>
+          <a:prstGeom prst="rect">
+            <a:avLst/>
+          </a:prstGeom>
+          <a:noFill/>
+        </p:spPr>
+        <p:txBody>
+          <a:bodyPr wrap="square" anchor="ctr" lIns="0" rIns="0" tIns="0" bIns="0">
+            <a:spAutoFit/>
+          </a:bodyPr>
+          <a:lstStyle/>
+          <a:p>
+            <a:pPr algn="ctr"/>
+            <a:r>
+              <a:rPr sz="800" b="0" i="0">
+                <a:solidFill>
+                  <a:srgbClr val="595959"/>
+                </a:solidFill>
+                <a:latin typeface="Microsoft YaHei"/>
+              </a:rPr>
+              <a:t>输送机</a:t>
+            </a:r>
+          </a:p>
+        </p:txBody>
+      </p:sp>
+      <p:sp>
+        <p:nvSpPr>
+          <p:cNvPr id="82" name="Rounded Rectangle 81"/>
           <p:cNvSpPr/>
           <p:nvPr/>
         </p:nvSpPr>
         <p:spPr>
           <a:xfrm>
-            <a:off x="1060704" y="6163056"/>
-            <a:ext cx="912155" cy="292608"/>
+            <a:off x="1337767" y="6254496"/>
+            <a:ext cx="1008583" cy="237744"/>
           </a:xfrm>
           <a:prstGeom prst="roundRect">
             <a:avLst>
-              <a:gd name="adj" fmla="val 16000"/>
+              <a:gd name="adj" fmla="val 18000"/>
             </a:avLst>
           </a:prstGeom>
           <a:solidFill>
-            <a:srgbClr val="FBFCFE"/>
-          </a:solidFill>
-          <a:ln w="9525">
+            <a:srgbClr val="F5F6F7"/>
+          </a:solidFill>
+          <a:ln w="6350">
             <a:solidFill>
-              <a:srgbClr val="9FB7D4"/>
+              <a:srgbClr val="C9C9C9"/>
             </a:solidFill>
           </a:ln>
           <a:effectLst/>
@@ -13820,14 +13390,14 @@
       </p:sp>
       <p:sp>
         <p:nvSpPr>
-          <p:cNvPr id="93" name="TextBox 92"/>
+          <p:cNvPr id="83" name="TextBox 82"/>
           <p:cNvSpPr txBox="1"/>
           <p:nvPr/>
         </p:nvSpPr>
         <p:spPr>
           <a:xfrm>
-            <a:off x="1060704" y="6163056"/>
-            <a:ext cx="912155" cy="292608"/>
+            <a:off x="1337767" y="6254496"/>
+            <a:ext cx="1008583" cy="237744"/>
           </a:xfrm>
           <a:prstGeom prst="rect">
             <a:avLst/>
@@ -13842,39 +13412,39 @@
           <a:p>
             <a:pPr algn="ctr"/>
             <a:r>
-              <a:rPr sz="800" b="1" i="0">
-                <a:solidFill>
-                  <a:srgbClr val="1F4E79"/>
-                </a:solidFill>
-                <a:latin typeface="Microsoft YaHei"/>
-              </a:rPr>
-              <a:t>输送机</a:t>
-            </a:r>
-          </a:p>
-        </p:txBody>
-      </p:sp>
-      <p:sp>
-        <p:nvSpPr>
-          <p:cNvPr id="94" name="Rounded Rectangle 93"/>
+              <a:rPr sz="800" b="0" i="0">
+                <a:solidFill>
+                  <a:srgbClr val="595959"/>
+                </a:solidFill>
+                <a:latin typeface="Microsoft YaHei"/>
+              </a:rPr>
+              <a:t>外形检测机</a:t>
+            </a:r>
+          </a:p>
+        </p:txBody>
+      </p:sp>
+      <p:sp>
+        <p:nvSpPr>
+          <p:cNvPr id="84" name="Rounded Rectangle 83"/>
           <p:cNvSpPr/>
           <p:nvPr/>
         </p:nvSpPr>
         <p:spPr>
           <a:xfrm>
-            <a:off x="2046011" y="6163056"/>
-            <a:ext cx="912155" cy="292608"/>
+            <a:off x="2401214" y="6254496"/>
+            <a:ext cx="1008583" cy="237744"/>
           </a:xfrm>
           <a:prstGeom prst="roundRect">
             <a:avLst>
-              <a:gd name="adj" fmla="val 16000"/>
+              <a:gd name="adj" fmla="val 18000"/>
             </a:avLst>
           </a:prstGeom>
           <a:solidFill>
-            <a:srgbClr val="FBFCFE"/>
-          </a:solidFill>
-          <a:ln w="9525">
+            <a:srgbClr val="F5F6F7"/>
+          </a:solidFill>
+          <a:ln w="6350">
             <a:solidFill>
-              <a:srgbClr val="9FB7D4"/>
+              <a:srgbClr val="C9C9C9"/>
             </a:solidFill>
           </a:ln>
           <a:effectLst/>
@@ -13903,14 +13473,14 @@
       </p:sp>
       <p:sp>
         <p:nvSpPr>
-          <p:cNvPr id="95" name="TextBox 94"/>
+          <p:cNvPr id="85" name="TextBox 84"/>
           <p:cNvSpPr txBox="1"/>
           <p:nvPr/>
         </p:nvSpPr>
         <p:spPr>
           <a:xfrm>
-            <a:off x="2046011" y="6163056"/>
-            <a:ext cx="912155" cy="292608"/>
+            <a:off x="2401214" y="6254496"/>
+            <a:ext cx="1008583" cy="237744"/>
           </a:xfrm>
           <a:prstGeom prst="rect">
             <a:avLst/>
@@ -13925,39 +13495,39 @@
           <a:p>
             <a:pPr algn="ctr"/>
             <a:r>
-              <a:rPr sz="800" b="1" i="0">
-                <a:solidFill>
-                  <a:srgbClr val="1F4E79"/>
-                </a:solidFill>
-                <a:latin typeface="Microsoft YaHei"/>
-              </a:rPr>
-              <a:t>外形检测机</a:t>
-            </a:r>
-          </a:p>
-        </p:txBody>
-      </p:sp>
-      <p:sp>
-        <p:nvSpPr>
-          <p:cNvPr id="96" name="Rounded Rectangle 95"/>
+              <a:rPr sz="800" b="0" i="0">
+                <a:solidFill>
+                  <a:srgbClr val="595959"/>
+                </a:solidFill>
+                <a:latin typeface="Microsoft YaHei"/>
+              </a:rPr>
+              <a:t>缠膜机</a:t>
+            </a:r>
+          </a:p>
+        </p:txBody>
+      </p:sp>
+      <p:sp>
+        <p:nvSpPr>
+          <p:cNvPr id="86" name="Rounded Rectangle 85"/>
           <p:cNvSpPr/>
           <p:nvPr/>
         </p:nvSpPr>
         <p:spPr>
           <a:xfrm>
-            <a:off x="3031319" y="6163056"/>
-            <a:ext cx="912155" cy="292608"/>
+            <a:off x="3464661" y="6254496"/>
+            <a:ext cx="1008583" cy="237744"/>
           </a:xfrm>
           <a:prstGeom prst="roundRect">
             <a:avLst>
-              <a:gd name="adj" fmla="val 16000"/>
+              <a:gd name="adj" fmla="val 18000"/>
             </a:avLst>
           </a:prstGeom>
           <a:solidFill>
-            <a:srgbClr val="FBFCFE"/>
-          </a:solidFill>
-          <a:ln w="9525">
+            <a:srgbClr val="F5F6F7"/>
+          </a:solidFill>
+          <a:ln w="6350">
             <a:solidFill>
-              <a:srgbClr val="9FB7D4"/>
+              <a:srgbClr val="C9C9C9"/>
             </a:solidFill>
           </a:ln>
           <a:effectLst/>
@@ -13986,14 +13556,14 @@
       </p:sp>
       <p:sp>
         <p:nvSpPr>
-          <p:cNvPr id="97" name="TextBox 96"/>
+          <p:cNvPr id="87" name="TextBox 86"/>
           <p:cNvSpPr txBox="1"/>
           <p:nvPr/>
         </p:nvSpPr>
         <p:spPr>
           <a:xfrm>
-            <a:off x="3031319" y="6163056"/>
-            <a:ext cx="912155" cy="292608"/>
+            <a:off x="3464661" y="6254496"/>
+            <a:ext cx="1008583" cy="237744"/>
           </a:xfrm>
           <a:prstGeom prst="rect">
             <a:avLst/>
@@ -14008,39 +13578,39 @@
           <a:p>
             <a:pPr algn="ctr"/>
             <a:r>
-              <a:rPr sz="800" b="1" i="0">
-                <a:solidFill>
-                  <a:srgbClr val="1F4E79"/>
-                </a:solidFill>
-                <a:latin typeface="Microsoft YaHei"/>
-              </a:rPr>
-              <a:t>缠膜机</a:t>
-            </a:r>
-          </a:p>
-        </p:txBody>
-      </p:sp>
-      <p:sp>
-        <p:nvSpPr>
-          <p:cNvPr id="98" name="Rounded Rectangle 97"/>
+              <a:rPr sz="800" b="0" i="0">
+                <a:solidFill>
+                  <a:srgbClr val="595959"/>
+                </a:solidFill>
+                <a:latin typeface="Microsoft YaHei"/>
+              </a:rPr>
+              <a:t>堆垛机</a:t>
+            </a:r>
+          </a:p>
+        </p:txBody>
+      </p:sp>
+      <p:sp>
+        <p:nvSpPr>
+          <p:cNvPr id="88" name="Rounded Rectangle 87"/>
           <p:cNvSpPr/>
           <p:nvPr/>
         </p:nvSpPr>
         <p:spPr>
           <a:xfrm>
-            <a:off x="4016626" y="6163056"/>
-            <a:ext cx="912155" cy="292608"/>
+            <a:off x="4528108" y="6254496"/>
+            <a:ext cx="1008583" cy="237744"/>
           </a:xfrm>
           <a:prstGeom prst="roundRect">
             <a:avLst>
-              <a:gd name="adj" fmla="val 16000"/>
+              <a:gd name="adj" fmla="val 18000"/>
             </a:avLst>
           </a:prstGeom>
           <a:solidFill>
-            <a:srgbClr val="FBFCFE"/>
-          </a:solidFill>
-          <a:ln w="9525">
+            <a:srgbClr val="F5F6F7"/>
+          </a:solidFill>
+          <a:ln w="6350">
             <a:solidFill>
-              <a:srgbClr val="9FB7D4"/>
+              <a:srgbClr val="C9C9C9"/>
             </a:solidFill>
           </a:ln>
           <a:effectLst/>
@@ -14069,14 +13639,14 @@
       </p:sp>
       <p:sp>
         <p:nvSpPr>
-          <p:cNvPr id="99" name="TextBox 98"/>
+          <p:cNvPr id="89" name="TextBox 88"/>
           <p:cNvSpPr txBox="1"/>
           <p:nvPr/>
         </p:nvSpPr>
         <p:spPr>
           <a:xfrm>
-            <a:off x="4016626" y="6163056"/>
-            <a:ext cx="912155" cy="292608"/>
+            <a:off x="4528108" y="6254496"/>
+            <a:ext cx="1008583" cy="237744"/>
           </a:xfrm>
           <a:prstGeom prst="rect">
             <a:avLst/>
@@ -14091,39 +13661,39 @@
           <a:p>
             <a:pPr algn="ctr"/>
             <a:r>
-              <a:rPr sz="800" b="1" i="0">
-                <a:solidFill>
-                  <a:srgbClr val="1F4E79"/>
-                </a:solidFill>
-                <a:latin typeface="Microsoft YaHei"/>
-              </a:rPr>
-              <a:t>堆垛机</a:t>
-            </a:r>
-          </a:p>
-        </p:txBody>
-      </p:sp>
-      <p:sp>
-        <p:nvSpPr>
-          <p:cNvPr id="100" name="Rounded Rectangle 99"/>
+              <a:rPr sz="800" b="0" i="0">
+                <a:solidFill>
+                  <a:srgbClr val="595959"/>
+                </a:solidFill>
+                <a:latin typeface="Microsoft YaHei"/>
+              </a:rPr>
+              <a:t>四向车</a:t>
+            </a:r>
+          </a:p>
+        </p:txBody>
+      </p:sp>
+      <p:sp>
+        <p:nvSpPr>
+          <p:cNvPr id="90" name="Rounded Rectangle 89"/>
           <p:cNvSpPr/>
           <p:nvPr/>
         </p:nvSpPr>
         <p:spPr>
           <a:xfrm>
-            <a:off x="5001934" y="6163056"/>
-            <a:ext cx="912155" cy="292608"/>
+            <a:off x="5591556" y="6254496"/>
+            <a:ext cx="1008583" cy="237744"/>
           </a:xfrm>
           <a:prstGeom prst="roundRect">
             <a:avLst>
-              <a:gd name="adj" fmla="val 16000"/>
+              <a:gd name="adj" fmla="val 18000"/>
             </a:avLst>
           </a:prstGeom>
           <a:solidFill>
-            <a:srgbClr val="FBFCFE"/>
-          </a:solidFill>
-          <a:ln w="9525">
+            <a:srgbClr val="F5F6F7"/>
+          </a:solidFill>
+          <a:ln w="6350">
             <a:solidFill>
-              <a:srgbClr val="9FB7D4"/>
+              <a:srgbClr val="C9C9C9"/>
             </a:solidFill>
           </a:ln>
           <a:effectLst/>
@@ -14152,14 +13722,14 @@
       </p:sp>
       <p:sp>
         <p:nvSpPr>
-          <p:cNvPr id="101" name="TextBox 100"/>
+          <p:cNvPr id="91" name="TextBox 90"/>
           <p:cNvSpPr txBox="1"/>
           <p:nvPr/>
         </p:nvSpPr>
         <p:spPr>
           <a:xfrm>
-            <a:off x="5001934" y="6163056"/>
-            <a:ext cx="912155" cy="292608"/>
+            <a:off x="5591556" y="6254496"/>
+            <a:ext cx="1008583" cy="237744"/>
           </a:xfrm>
           <a:prstGeom prst="rect">
             <a:avLst/>
@@ -14174,39 +13744,39 @@
           <a:p>
             <a:pPr algn="ctr"/>
             <a:r>
-              <a:rPr sz="800" b="1" i="0">
-                <a:solidFill>
-                  <a:srgbClr val="1F4E79"/>
-                </a:solidFill>
-                <a:latin typeface="Microsoft YaHei"/>
-              </a:rPr>
-              <a:t>四向车</a:t>
-            </a:r>
-          </a:p>
-        </p:txBody>
-      </p:sp>
-      <p:sp>
-        <p:nvSpPr>
-          <p:cNvPr id="102" name="Rounded Rectangle 101"/>
+              <a:rPr sz="800" b="0" i="0">
+                <a:solidFill>
+                  <a:srgbClr val="595959"/>
+                </a:solidFill>
+                <a:latin typeface="Microsoft YaHei"/>
+              </a:rPr>
+              <a:t>AGV</a:t>
+            </a:r>
+          </a:p>
+        </p:txBody>
+      </p:sp>
+      <p:sp>
+        <p:nvSpPr>
+          <p:cNvPr id="92" name="Rounded Rectangle 91"/>
           <p:cNvSpPr/>
           <p:nvPr/>
         </p:nvSpPr>
         <p:spPr>
           <a:xfrm>
-            <a:off x="5987241" y="6163056"/>
-            <a:ext cx="912155" cy="292608"/>
+            <a:off x="6655003" y="6254496"/>
+            <a:ext cx="1008583" cy="237744"/>
           </a:xfrm>
           <a:prstGeom prst="roundRect">
             <a:avLst>
-              <a:gd name="adj" fmla="val 16000"/>
+              <a:gd name="adj" fmla="val 18000"/>
             </a:avLst>
           </a:prstGeom>
           <a:solidFill>
-            <a:srgbClr val="FBFCFE"/>
-          </a:solidFill>
-          <a:ln w="9525">
+            <a:srgbClr val="F5F6F7"/>
+          </a:solidFill>
+          <a:ln w="6350">
             <a:solidFill>
-              <a:srgbClr val="9FB7D4"/>
+              <a:srgbClr val="C9C9C9"/>
             </a:solidFill>
           </a:ln>
           <a:effectLst/>
@@ -14235,14 +13805,14 @@
       </p:sp>
       <p:sp>
         <p:nvSpPr>
-          <p:cNvPr id="103" name="TextBox 102"/>
+          <p:cNvPr id="93" name="TextBox 92"/>
           <p:cNvSpPr txBox="1"/>
           <p:nvPr/>
         </p:nvSpPr>
         <p:spPr>
           <a:xfrm>
-            <a:off x="5987241" y="6163056"/>
-            <a:ext cx="912155" cy="292608"/>
+            <a:off x="6655003" y="6254496"/>
+            <a:ext cx="1008583" cy="237744"/>
           </a:xfrm>
           <a:prstGeom prst="rect">
             <a:avLst/>
@@ -14257,39 +13827,39 @@
           <a:p>
             <a:pPr algn="ctr"/>
             <a:r>
-              <a:rPr sz="800" b="1" i="0">
-                <a:solidFill>
-                  <a:srgbClr val="1F4E79"/>
-                </a:solidFill>
-                <a:latin typeface="Microsoft YaHei"/>
-              </a:rPr>
-              <a:t>AGV</a:t>
-            </a:r>
-          </a:p>
-        </p:txBody>
-      </p:sp>
-      <p:sp>
-        <p:nvSpPr>
-          <p:cNvPr id="104" name="Rounded Rectangle 103"/>
+              <a:rPr sz="800" b="0" i="0">
+                <a:solidFill>
+                  <a:srgbClr val="595959"/>
+                </a:solidFill>
+                <a:latin typeface="Microsoft YaHei"/>
+              </a:rPr>
+              <a:t>机器人</a:t>
+            </a:r>
+          </a:p>
+        </p:txBody>
+      </p:sp>
+      <p:sp>
+        <p:nvSpPr>
+          <p:cNvPr id="94" name="Rounded Rectangle 93"/>
           <p:cNvSpPr/>
           <p:nvPr/>
         </p:nvSpPr>
         <p:spPr>
           <a:xfrm>
-            <a:off x="6972549" y="6163056"/>
-            <a:ext cx="912155" cy="292608"/>
+            <a:off x="7718450" y="6254496"/>
+            <a:ext cx="1008583" cy="237744"/>
           </a:xfrm>
           <a:prstGeom prst="roundRect">
             <a:avLst>
-              <a:gd name="adj" fmla="val 16000"/>
+              <a:gd name="adj" fmla="val 18000"/>
             </a:avLst>
           </a:prstGeom>
           <a:solidFill>
-            <a:srgbClr val="FBFCFE"/>
-          </a:solidFill>
-          <a:ln w="9525">
+            <a:srgbClr val="F5F6F7"/>
+          </a:solidFill>
+          <a:ln w="6350">
             <a:solidFill>
-              <a:srgbClr val="9FB7D4"/>
+              <a:srgbClr val="C9C9C9"/>
             </a:solidFill>
           </a:ln>
           <a:effectLst/>
@@ -14318,14 +13888,14 @@
       </p:sp>
       <p:sp>
         <p:nvSpPr>
-          <p:cNvPr id="105" name="TextBox 104"/>
+          <p:cNvPr id="95" name="TextBox 94"/>
           <p:cNvSpPr txBox="1"/>
           <p:nvPr/>
         </p:nvSpPr>
         <p:spPr>
           <a:xfrm>
-            <a:off x="6972549" y="6163056"/>
-            <a:ext cx="912155" cy="292608"/>
+            <a:off x="7718450" y="6254496"/>
+            <a:ext cx="1008583" cy="237744"/>
           </a:xfrm>
           <a:prstGeom prst="rect">
             <a:avLst/>
@@ -14340,39 +13910,39 @@
           <a:p>
             <a:pPr algn="ctr"/>
             <a:r>
-              <a:rPr sz="800" b="1" i="0">
-                <a:solidFill>
-                  <a:srgbClr val="1F4E79"/>
-                </a:solidFill>
-                <a:latin typeface="Microsoft YaHei"/>
-              </a:rPr>
-              <a:t>机器人</a:t>
-            </a:r>
-          </a:p>
-        </p:txBody>
-      </p:sp>
-      <p:sp>
-        <p:nvSpPr>
-          <p:cNvPr id="106" name="Rounded Rectangle 105"/>
+              <a:rPr sz="800" b="0" i="0">
+                <a:solidFill>
+                  <a:srgbClr val="595959"/>
+                </a:solidFill>
+                <a:latin typeface="Microsoft YaHei"/>
+              </a:rPr>
+              <a:t>工作站</a:t>
+            </a:r>
+          </a:p>
+        </p:txBody>
+      </p:sp>
+      <p:sp>
+        <p:nvSpPr>
+          <p:cNvPr id="96" name="Rounded Rectangle 95"/>
           <p:cNvSpPr/>
           <p:nvPr/>
         </p:nvSpPr>
         <p:spPr>
           <a:xfrm>
-            <a:off x="7957856" y="6163056"/>
-            <a:ext cx="912155" cy="292608"/>
+            <a:off x="8781897" y="6254496"/>
+            <a:ext cx="1008583" cy="237744"/>
           </a:xfrm>
           <a:prstGeom prst="roundRect">
             <a:avLst>
-              <a:gd name="adj" fmla="val 16000"/>
+              <a:gd name="adj" fmla="val 18000"/>
             </a:avLst>
           </a:prstGeom>
           <a:solidFill>
-            <a:srgbClr val="FBFCFE"/>
-          </a:solidFill>
-          <a:ln w="9525">
+            <a:srgbClr val="F5F6F7"/>
+          </a:solidFill>
+          <a:ln w="6350">
             <a:solidFill>
-              <a:srgbClr val="9FB7D4"/>
+              <a:srgbClr val="C9C9C9"/>
             </a:solidFill>
           </a:ln>
           <a:effectLst/>
@@ -14401,14 +13971,14 @@
       </p:sp>
       <p:sp>
         <p:nvSpPr>
-          <p:cNvPr id="107" name="TextBox 106"/>
+          <p:cNvPr id="97" name="TextBox 96"/>
           <p:cNvSpPr txBox="1"/>
           <p:nvPr/>
         </p:nvSpPr>
         <p:spPr>
           <a:xfrm>
-            <a:off x="7957856" y="6163056"/>
-            <a:ext cx="912155" cy="292608"/>
+            <a:off x="8781897" y="6254496"/>
+            <a:ext cx="1008583" cy="237744"/>
           </a:xfrm>
           <a:prstGeom prst="rect">
             <a:avLst/>
@@ -14423,39 +13993,39 @@
           <a:p>
             <a:pPr algn="ctr"/>
             <a:r>
-              <a:rPr sz="800" b="1" i="0">
-                <a:solidFill>
-                  <a:srgbClr val="1F4E79"/>
-                </a:solidFill>
-                <a:latin typeface="Microsoft YaHei"/>
-              </a:rPr>
-              <a:t>工作站</a:t>
-            </a:r>
-          </a:p>
-        </p:txBody>
-      </p:sp>
-      <p:sp>
-        <p:nvSpPr>
-          <p:cNvPr id="108" name="Rounded Rectangle 107"/>
+              <a:rPr sz="800" b="0" i="0">
+                <a:solidFill>
+                  <a:srgbClr val="595959"/>
+                </a:solidFill>
+                <a:latin typeface="Microsoft YaHei"/>
+              </a:rPr>
+              <a:t>提升机</a:t>
+            </a:r>
+          </a:p>
+        </p:txBody>
+      </p:sp>
+      <p:sp>
+        <p:nvSpPr>
+          <p:cNvPr id="98" name="Rounded Rectangle 97"/>
           <p:cNvSpPr/>
           <p:nvPr/>
         </p:nvSpPr>
         <p:spPr>
           <a:xfrm>
-            <a:off x="8943164" y="6163056"/>
-            <a:ext cx="912155" cy="292608"/>
+            <a:off x="9845344" y="6254496"/>
+            <a:ext cx="1008583" cy="237744"/>
           </a:xfrm>
           <a:prstGeom prst="roundRect">
             <a:avLst>
-              <a:gd name="adj" fmla="val 16000"/>
+              <a:gd name="adj" fmla="val 18000"/>
             </a:avLst>
           </a:prstGeom>
           <a:solidFill>
-            <a:srgbClr val="FBFCFE"/>
-          </a:solidFill>
-          <a:ln w="9525">
+            <a:srgbClr val="F5F6F7"/>
+          </a:solidFill>
+          <a:ln w="6350">
             <a:solidFill>
-              <a:srgbClr val="9FB7D4"/>
+              <a:srgbClr val="C9C9C9"/>
             </a:solidFill>
           </a:ln>
           <a:effectLst/>
@@ -14484,14 +14054,14 @@
       </p:sp>
       <p:sp>
         <p:nvSpPr>
-          <p:cNvPr id="109" name="TextBox 108"/>
+          <p:cNvPr id="99" name="TextBox 98"/>
           <p:cNvSpPr txBox="1"/>
           <p:nvPr/>
         </p:nvSpPr>
         <p:spPr>
           <a:xfrm>
-            <a:off x="8943164" y="6163056"/>
-            <a:ext cx="912155" cy="292608"/>
+            <a:off x="9845344" y="6254496"/>
+            <a:ext cx="1008583" cy="237744"/>
           </a:xfrm>
           <a:prstGeom prst="rect">
             <a:avLst/>
@@ -14506,39 +14076,39 @@
           <a:p>
             <a:pPr algn="ctr"/>
             <a:r>
-              <a:rPr sz="800" b="1" i="0">
-                <a:solidFill>
-                  <a:srgbClr val="1F4E79"/>
-                </a:solidFill>
-                <a:latin typeface="Microsoft YaHei"/>
-              </a:rPr>
-              <a:t>提升机</a:t>
-            </a:r>
-          </a:p>
-        </p:txBody>
-      </p:sp>
-      <p:sp>
-        <p:nvSpPr>
-          <p:cNvPr id="110" name="Rounded Rectangle 109"/>
+              <a:rPr sz="800" b="0" i="0">
+                <a:solidFill>
+                  <a:srgbClr val="595959"/>
+                </a:solidFill>
+                <a:latin typeface="Microsoft YaHei"/>
+              </a:rPr>
+              <a:t>无人叉车</a:t>
+            </a:r>
+          </a:p>
+        </p:txBody>
+      </p:sp>
+      <p:sp>
+        <p:nvSpPr>
+          <p:cNvPr id="100" name="Rounded Rectangle 99"/>
           <p:cNvSpPr/>
           <p:nvPr/>
         </p:nvSpPr>
         <p:spPr>
           <a:xfrm>
-            <a:off x="9928472" y="6163056"/>
-            <a:ext cx="912155" cy="292608"/>
+            <a:off x="10908792" y="6254496"/>
+            <a:ext cx="1008583" cy="237744"/>
           </a:xfrm>
           <a:prstGeom prst="roundRect">
             <a:avLst>
-              <a:gd name="adj" fmla="val 16000"/>
+              <a:gd name="adj" fmla="val 18000"/>
             </a:avLst>
           </a:prstGeom>
           <a:solidFill>
-            <a:srgbClr val="FBFCFE"/>
-          </a:solidFill>
-          <a:ln w="9525">
+            <a:srgbClr val="F5F6F7"/>
+          </a:solidFill>
+          <a:ln w="6350">
             <a:solidFill>
-              <a:srgbClr val="9FB7D4"/>
+              <a:srgbClr val="C9C9C9"/>
             </a:solidFill>
           </a:ln>
           <a:effectLst/>
@@ -14567,14 +14137,14 @@
       </p:sp>
       <p:sp>
         <p:nvSpPr>
-          <p:cNvPr id="111" name="TextBox 110"/>
+          <p:cNvPr id="101" name="TextBox 100"/>
           <p:cNvSpPr txBox="1"/>
           <p:nvPr/>
         </p:nvSpPr>
         <p:spPr>
           <a:xfrm>
-            <a:off x="9928472" y="6163056"/>
-            <a:ext cx="912155" cy="292608"/>
+            <a:off x="10908792" y="6254496"/>
+            <a:ext cx="1008583" cy="237744"/>
           </a:xfrm>
           <a:prstGeom prst="rect">
             <a:avLst/>
@@ -14589,110 +14159,27 @@
           <a:p>
             <a:pPr algn="ctr"/>
             <a:r>
-              <a:rPr sz="800" b="1" i="0">
-                <a:solidFill>
-                  <a:srgbClr val="1F4E79"/>
-                </a:solidFill>
-                <a:latin typeface="Microsoft YaHei"/>
-              </a:rPr>
-              <a:t>无人叉车</a:t>
-            </a:r>
-          </a:p>
-        </p:txBody>
-      </p:sp>
-      <p:sp>
-        <p:nvSpPr>
-          <p:cNvPr id="112" name="Rounded Rectangle 111"/>
-          <p:cNvSpPr/>
-          <p:nvPr/>
-        </p:nvSpPr>
-        <p:spPr>
-          <a:xfrm>
-            <a:off x="10913779" y="6163056"/>
-            <a:ext cx="912155" cy="292608"/>
-          </a:xfrm>
-          <a:prstGeom prst="roundRect">
-            <a:avLst>
-              <a:gd name="adj" fmla="val 16000"/>
-            </a:avLst>
-          </a:prstGeom>
-          <a:solidFill>
-            <a:srgbClr val="FBFCFE"/>
-          </a:solidFill>
-          <a:ln w="9525">
-            <a:solidFill>
-              <a:srgbClr val="9FB7D4"/>
-            </a:solidFill>
-          </a:ln>
-          <a:effectLst/>
-        </p:spPr>
-        <p:style>
-          <a:lnRef idx="1">
-            <a:schemeClr val="accent1"/>
-          </a:lnRef>
-          <a:fillRef idx="3">
-            <a:schemeClr val="accent1"/>
-          </a:fillRef>
-          <a:effectRef idx="2">
-            <a:schemeClr val="accent1"/>
-          </a:effectRef>
-          <a:fontRef idx="minor">
-            <a:schemeClr val="lt1"/>
-          </a:fontRef>
-        </p:style>
-        <p:txBody>
-          <a:bodyPr rtlCol="0" anchor="ctr"/>
-          <a:lstStyle/>
-          <a:p>
-            <a:pPr algn="ctr"/>
-          </a:p>
-        </p:txBody>
-      </p:sp>
-      <p:sp>
-        <p:nvSpPr>
-          <p:cNvPr id="113" name="TextBox 112"/>
+              <a:rPr sz="800" b="0" i="0">
+                <a:solidFill>
+                  <a:srgbClr val="595959"/>
+                </a:solidFill>
+                <a:latin typeface="Microsoft YaHei"/>
+              </a:rPr>
+              <a:t>贴标机</a:t>
+            </a:r>
+          </a:p>
+        </p:txBody>
+      </p:sp>
+      <p:sp>
+        <p:nvSpPr>
+          <p:cNvPr id="102" name="TextBox 101"/>
           <p:cNvSpPr txBox="1"/>
           <p:nvPr/>
         </p:nvSpPr>
         <p:spPr>
           <a:xfrm>
-            <a:off x="10913779" y="6163056"/>
-            <a:ext cx="912155" cy="292608"/>
-          </a:xfrm>
-          <a:prstGeom prst="rect">
-            <a:avLst/>
-          </a:prstGeom>
-          <a:noFill/>
-        </p:spPr>
-        <p:txBody>
-          <a:bodyPr wrap="square" anchor="ctr" lIns="0" rIns="0" tIns="0" bIns="0">
-            <a:spAutoFit/>
-          </a:bodyPr>
-          <a:lstStyle/>
-          <a:p>
-            <a:pPr algn="ctr"/>
-            <a:r>
-              <a:rPr sz="800" b="1" i="0">
-                <a:solidFill>
-                  <a:srgbClr val="1F4E79"/>
-                </a:solidFill>
-                <a:latin typeface="Microsoft YaHei"/>
-              </a:rPr>
-              <a:t>贴标机</a:t>
-            </a:r>
-          </a:p>
-        </p:txBody>
-      </p:sp>
-      <p:sp>
-        <p:nvSpPr>
-          <p:cNvPr id="114" name="TextBox 113"/>
-          <p:cNvSpPr txBox="1"/>
-          <p:nvPr/>
-        </p:nvSpPr>
-        <p:spPr>
-          <a:xfrm>
-            <a:off x="274320" y="6601968"/>
-            <a:ext cx="11643055" cy="219456"/>
+            <a:off x="274320" y="6565392"/>
+            <a:ext cx="11643055" cy="256032"/>
           </a:xfrm>
           <a:prstGeom prst="rect">
             <a:avLst/>
@@ -14713,7 +14200,7 @@
                 </a:solidFill>
                 <a:latin typeface="Microsoft YaHei"/>
               </a:rPr>
-              <a:t>说明：wcs-core 以标准指令承接上行 WMS 指令并统一调度，按场景适配 / 厂商对接 / 调度策略下发执行；wcs-dashboard 独立采集、加工并展示运行数据，分别通过同步 / 异步通路与执行层交互。</a:t>
+              <a:t>说明：wcs-core 以标准指令承接上行 WMS 指令并统一调度，按场景适配 / 厂商对接 / 调度策略下发执行；wcs-dashboard 独立采集、加工并展示运行数据，经 WCS 与设备执行层完成上下行衔接。</a:t>
             </a:r>
           </a:p>
         </p:txBody>

</xml_diff>